<commit_message>
Audit evidence and external holdout gate; publish traced reports
</commit_message>
<xml_diff>
--- a/deliverables/药物重定位Agent_答辩稿_v7.pptx
+++ b/deliverables/药物重定位Agent_答辩稿_v7.pptx
@@ -1712,7 +1712,7 @@
           <a:p>
             <a:r>
               <a:rPr lang="en-US" dirty="0"/>
-              <a:t>约 50 秒。每个候选：文献 Agent 检索 PubMed 并提出带原文引语的支持论断；批评 Agent 独立检索反对证据；确定性校验要求 PMID 在检索集中且引语逐字出现；协调者给出分级。65 条引语 0 条被拒；10/10 为证据不足，与单轮审阅一致。局限：逐字校验不保证引语真正支持论断（例如批评 Agent 引用了一篇勘误），仍需人工复核。共 22 次调用。</a:t>
+              <a:t>约 50 秒。每个候选由文献 Agent、批评 Agent 和协调者处理。冻结版 65 条引语全部通过 PMID 与逐字校验、10/10 判为证据不足，共 22 次模型调用。事后来源/药名范围预筛标记 23 条；当前 PubMed 摘要级复核中 13 条原样候选级引用需排除，9 条仅能收窄终点保留，1 条仅作一般安全提示。错误包括勘误当原始研究、未指名类固醇归给具体候选、柚皮素抗癌结果误归给 fluticasone。冻结分级未重跑；这不是独立双人全文审阅。</a:t>
             </a:r>
             <a:endParaRPr lang="en-US" dirty="0"/>
           </a:p>
@@ -1800,7 +1800,7 @@
           <a:p>
             <a:r>
               <a:rPr lang="en-US" dirty="0"/>
-              <a:t>约 40 秒。总结五点。最后强调：Benchmark 分数只代表已知关联恢复能力；LUAD 候选是待验证的研究假设，不是用药建议。代码与所有结果见 GitHub 仓库。</a:t>
+              <a:t>约 40 秒。总结五点。23 条是事后来源/药名范围预筛标记，并非 65 条都经过全文审阅；13 条原样候选级引用需排除，冻结药物分级未重算。独立外部方法选择 v3 的数据与标签门槛未通过，没有外部 NS-AUC 结果。Benchmark 分数只代表已知关联恢复能力；LUAD 候选是待验证的研究假设，不是用药建议。代码与所有结果见 GitHub 仓库。</a:t>
             </a:r>
             <a:endParaRPr lang="en-US" dirty="0"/>
           </a:p>
@@ -2416,7 +2416,7 @@
           <a:p>
             <a:r>
               <a:rPr lang="en-US" dirty="0"/>
-              <a:t>约 50 秒。冻结 120 个封闭决策用例（工具路由、数据质量、证据充分性、候选分级各 30），参考答案由成文策略决定，调用前提交冻结。J0 与 J1 准确率都是 0.875；J1 对模糊用例全部升级人工，但高风险误执行 0.150，高于规则的 0.033；加入置信门控后降到 0.083，代价是升级率 0.400。Jev 未获访问，同一冻结集可直接复测。用例为策略生成的合成数据，单次运行。</a:t>
+              <a:t>约 50 秒。图为 v1 的 120 个封闭合成决策用例：J0 与 J1 准确率都是 0.875，J1 高风险误执行 0.150；置信门控降到 0.083，但增加人工升级。新 v2 是另一个在任何调用前冻结的 40 条中文风险备注压力测试：混合层 39/40、完整 LLM 37/40、旧关键词规则 20/40；80/80 provider trace 通过回放。v2 是作者标注的合成新用例，不与 v1 准确率直接比较，也不代表临床正确率。Jev 未获访问。</a:t>
             </a:r>
             <a:endParaRPr lang="en-US" dirty="0"/>
           </a:p>
@@ -3059,7 +3059,7 @@
                 <a:ea typeface="Microsoft YaHei" pitchFamily="34" charset="-122"/>
                 <a:cs typeface="Microsoft YaHei" pitchFamily="34" charset="-120"/>
               </a:rPr>
-              <a:t>多 Agent 证据审阅：文献 × 批评 × 确定性校验</a:t>
+              <a:t>多 Agent 证据审阅：逐字引用 ≠ 论断成立</a:t>
             </a:r>
             <a:endParaRPr lang="en-US" sz="3000" dirty="0"/>
           </a:p>
@@ -3203,7 +3203,7 @@
                 <a:ea typeface="Microsoft YaHei" pitchFamily="34" charset="-122"/>
                 <a:cs typeface="Microsoft YaHei" pitchFamily="34" charset="-120"/>
               </a:rPr>
-              <a:t>带原文引语的论断</a:t>
+              <a:t>冻结版通过逐字校验</a:t>
             </a:r>
             <a:endParaRPr lang="en-US" sz="1200" dirty="0"/>
           </a:p>
@@ -3269,7 +3269,7 @@
                 <a:ea typeface="Microsoft YaHei" pitchFamily="34" charset="-122"/>
                 <a:cs typeface="Microsoft YaHei" pitchFamily="34" charset="-120"/>
               </a:rPr>
-              <a:t>0</a:t>
+              <a:t>23</a:t>
             </a:r>
             <a:endParaRPr lang="en-US" sz="2800" dirty="0"/>
           </a:p>
@@ -3308,7 +3308,7 @@
                 <a:ea typeface="Microsoft YaHei" pitchFamily="34" charset="-122"/>
                 <a:cs typeface="Microsoft YaHei" pitchFamily="34" charset="-120"/>
               </a:rPr>
-              <a:t>未通过 PMID/逐字校验</a:t>
+              <a:t>事后范围预筛标记</a:t>
             </a:r>
             <a:endParaRPr lang="en-US" sz="1200" dirty="0"/>
           </a:p>
@@ -3368,13 +3368,13 @@
             <a:r>
               <a:rPr lang="en-US" sz="2800" b="1" dirty="0">
                 <a:solidFill>
-                  <a:srgbClr val="087E78"/>
+                  <a:srgbClr val="9E493D"/>
                 </a:solidFill>
                 <a:latin typeface="Microsoft YaHei" pitchFamily="34" charset="0"/>
                 <a:ea typeface="Microsoft YaHei" pitchFamily="34" charset="-122"/>
                 <a:cs typeface="Microsoft YaHei" pitchFamily="34" charset="-120"/>
               </a:rPr>
-              <a:t>10/10</a:t>
+              <a:t>13</a:t>
             </a:r>
             <a:endParaRPr lang="en-US" sz="2800" dirty="0"/>
           </a:p>
@@ -3413,7 +3413,7 @@
                 <a:ea typeface="Microsoft YaHei" pitchFamily="34" charset="-122"/>
                 <a:cs typeface="Microsoft YaHei" pitchFamily="34" charset="-120"/>
               </a:rPr>
-              <a:t>证据不足（与单轮一致）</a:t>
+              <a:t>原样候选级引用需排除</a:t>
             </a:r>
             <a:endParaRPr lang="en-US" sz="1200" dirty="0"/>
           </a:p>
@@ -3479,7 +3479,7 @@
                 <a:ea typeface="Microsoft YaHei" pitchFamily="34" charset="-122"/>
                 <a:cs typeface="Microsoft YaHei" pitchFamily="34" charset="-120"/>
               </a:rPr>
-              <a:t>22</a:t>
+              <a:t>10/10</a:t>
             </a:r>
             <a:endParaRPr lang="en-US" sz="2800" dirty="0"/>
           </a:p>
@@ -3518,7 +3518,7 @@
                 <a:ea typeface="Microsoft YaHei" pitchFamily="34" charset="-122"/>
                 <a:cs typeface="Microsoft YaHei" pitchFamily="34" charset="-120"/>
               </a:rPr>
-              <a:t>LLM 调用次数</a:t>
+              <a:t>冻结分级：未重新计算</a:t>
             </a:r>
             <a:endParaRPr lang="en-US" sz="1200" dirty="0"/>
           </a:p>
@@ -3706,7 +3706,7 @@
                           <a:ea typeface="Microsoft YaHei" pitchFamily="34" charset="-122"/>
                           <a:cs typeface="Microsoft YaHei" pitchFamily="34" charset="-120"/>
                         </a:rPr>
-                        <a:t>分级</a:t>
+                        <a:t>冻结分级</a:t>
                       </a:r>
                       <a:endParaRPr lang="en-US" sz="1050" dirty="0">
                         <a:latin typeface="Microsoft YaHei" charset="0"/>
@@ -3774,7 +3774,7 @@
                           <a:ea typeface="Microsoft YaHei" pitchFamily="34" charset="-122"/>
                           <a:cs typeface="Microsoft YaHei" pitchFamily="34" charset="-120"/>
                         </a:rPr>
-                        <a:t>关键 PMID</a:t>
+                        <a:t>23 条中的摘要级审计</a:t>
                       </a:r>
                       <a:endParaRPr lang="en-US" sz="1050" dirty="0">
                         <a:latin typeface="Microsoft YaHei" charset="0"/>
@@ -4048,7 +4048,7 @@
                           <a:ea typeface="Microsoft YaHei" pitchFamily="34" charset="-122"/>
                           <a:cs typeface="Microsoft YaHei" pitchFamily="34" charset="-120"/>
                         </a:rPr>
-                        <a:t>28824067, 29151505, 34657060</a:t>
+                        <a:t>排除 1；限定范围 0</a:t>
                       </a:r>
                       <a:endParaRPr lang="en-US" sz="1050" dirty="0">
                         <a:latin typeface="Microsoft YaHei" charset="0"/>
@@ -4322,7 +4322,7 @@
                           <a:ea typeface="Microsoft YaHei" pitchFamily="34" charset="-122"/>
                           <a:cs typeface="Microsoft YaHei" pitchFamily="34" charset="-120"/>
                         </a:rPr>
-                        <a:t>12538830, 10903220, 24555085</a:t>
+                        <a:t>排除 3；限定范围 3</a:t>
                       </a:r>
                       <a:endParaRPr lang="en-US" sz="1050" dirty="0">
                         <a:latin typeface="Microsoft YaHei" charset="0"/>
@@ -4596,7 +4596,7 @@
                           <a:ea typeface="Microsoft YaHei" pitchFamily="34" charset="-122"/>
                           <a:cs typeface="Microsoft YaHei" pitchFamily="34" charset="-120"/>
                         </a:rPr>
-                        <a:t>42205670, 42684586, 41376996</a:t>
+                        <a:t>排除 1；限定范围 0</a:t>
                       </a:r>
                       <a:endParaRPr lang="en-US" sz="1050" dirty="0">
                         <a:latin typeface="Microsoft YaHei" charset="0"/>
@@ -4870,7 +4870,7 @@
                           <a:ea typeface="Microsoft YaHei" pitchFamily="34" charset="-122"/>
                           <a:cs typeface="Microsoft YaHei" pitchFamily="34" charset="-120"/>
                         </a:rPr>
-                        <a:t>11698053, 12948397, 19177906</a:t>
+                        <a:t>排除 0；限定范围 4</a:t>
                       </a:r>
                       <a:endParaRPr lang="en-US" sz="1050" dirty="0">
                         <a:latin typeface="Microsoft YaHei" charset="0"/>
@@ -5144,7 +5144,7 @@
                           <a:ea typeface="Microsoft YaHei" pitchFamily="34" charset="-122"/>
                           <a:cs typeface="Microsoft YaHei" pitchFamily="34" charset="-120"/>
                         </a:rPr>
-                        <a:t>42205670, 42684586, 41376996</a:t>
+                        <a:t>排除 1；限定范围 0</a:t>
                       </a:r>
                       <a:endParaRPr lang="en-US" sz="1050" dirty="0">
                         <a:latin typeface="Microsoft YaHei" charset="0"/>
@@ -5418,7 +5418,7 @@
                           <a:ea typeface="Microsoft YaHei" pitchFamily="34" charset="-122"/>
                           <a:cs typeface="Microsoft YaHei" pitchFamily="34" charset="-120"/>
                         </a:rPr>
-                        <a:t>—</a:t>
+                        <a:t>本轮未标记（不等于已全面核验）</a:t>
                       </a:r>
                       <a:endParaRPr lang="en-US" sz="1050" dirty="0">
                         <a:latin typeface="Microsoft YaHei" charset="0"/>
@@ -5692,7 +5692,7 @@
                           <a:ea typeface="Microsoft YaHei" pitchFamily="34" charset="-122"/>
                           <a:cs typeface="Microsoft YaHei" pitchFamily="34" charset="-120"/>
                         </a:rPr>
-                        <a:t>42205670, 42684586, 41376996</a:t>
+                        <a:t>排除 1；限定范围 0</a:t>
                       </a:r>
                       <a:endParaRPr lang="en-US" sz="1050" dirty="0">
                         <a:latin typeface="Microsoft YaHei" charset="0"/>
@@ -5966,7 +5966,7 @@
                           <a:ea typeface="Microsoft YaHei" pitchFamily="34" charset="-122"/>
                           <a:cs typeface="Microsoft YaHei" pitchFamily="34" charset="-120"/>
                         </a:rPr>
-                        <a:t>42205670, 42684586, 41376996</a:t>
+                        <a:t>排除 4；限定范围 0</a:t>
                       </a:r>
                       <a:endParaRPr lang="en-US" sz="1050" dirty="0">
                         <a:latin typeface="Microsoft YaHei" charset="0"/>
@@ -6240,7 +6240,7 @@
                           <a:ea typeface="Microsoft YaHei" pitchFamily="34" charset="-122"/>
                           <a:cs typeface="Microsoft YaHei" pitchFamily="34" charset="-120"/>
                         </a:rPr>
-                        <a:t>12924514, 42589695, 42196603</a:t>
+                        <a:t>排除 2；限定范围 3</a:t>
                       </a:r>
                       <a:endParaRPr lang="en-US" sz="1050" dirty="0">
                         <a:latin typeface="Microsoft YaHei" charset="0"/>
@@ -6514,7 +6514,7 @@
                           <a:ea typeface="Microsoft YaHei" pitchFamily="34" charset="-122"/>
                           <a:cs typeface="Microsoft YaHei" pitchFamily="34" charset="-120"/>
                         </a:rPr>
-                        <a:t>42205670, 42684586</a:t>
+                        <a:t>本轮未标记（不等于已全面核验）</a:t>
                       </a:r>
                       <a:endParaRPr lang="en-US" sz="1050" dirty="0">
                         <a:latin typeface="Microsoft YaHei" charset="0"/>
@@ -6947,7 +6947,7 @@
                 <a:ea typeface="Microsoft YaHei" pitchFamily="34" charset="-122"/>
                 <a:cs typeface="Microsoft YaHei" pitchFamily="34" charset="-120"/>
               </a:rPr>
-              <a:t>规划 98/100；门控降低高风险误执行；多 Agent 引用逐字校验</a:t>
+              <a:t>规划 98/100；23 条范围预筛引用中 13 条原样需排除</a:t>
             </a:r>
             <a:endParaRPr lang="en-US" sz="1800" dirty="0"/>
           </a:p>
@@ -7025,7 +7025,7 @@
                 <a:ea typeface="Microsoft YaHei" pitchFamily="34" charset="-122"/>
                 <a:cs typeface="Microsoft YaHei" pitchFamily="34" charset="-120"/>
               </a:rPr>
-              <a:t>细胞系 ≠ 患者；未知 ≠ 阴性；无湿实验；Jev 未获访问</a:t>
+              <a:t>细胞系 ≠ 患者；未知 ≠ 阴性；外部 v3 未跑；Jev/湿实验未做</a:t>
             </a:r>
             <a:endParaRPr lang="en-US" sz="1800" dirty="0"/>
           </a:p>
@@ -10324,7 +10324,7 @@
                 <a:ea typeface="Microsoft YaHei" pitchFamily="34" charset="-122"/>
                 <a:cs typeface="Microsoft YaHei" pitchFamily="34" charset="-120"/>
               </a:rPr>
-              <a:t>120 个冻结用例，参考答案由成文策略决定</a:t>
+              <a:t>图：v1 120 个冻结合成决策用例</a:t>
             </a:r>
             <a:endParaRPr lang="en-US" sz="1400" dirty="0"/>
           </a:p>
@@ -10345,7 +10345,7 @@
                 <a:ea typeface="Microsoft YaHei" pitchFamily="34" charset="-122"/>
                 <a:cs typeface="Microsoft YaHei" pitchFamily="34" charset="-120"/>
               </a:rPr>
-              <a:t>LLM 与规则总体准确率持平</a:t>
+              <a:t>v1 规则与 LLM 准确率持平；门控减少高风险误执行</a:t>
             </a:r>
             <a:endParaRPr lang="en-US" sz="1400" dirty="0"/>
           </a:p>
@@ -10366,7 +10366,7 @@
                 <a:ea typeface="Microsoft YaHei" pitchFamily="34" charset="-122"/>
                 <a:cs typeface="Microsoft YaHei" pitchFamily="34" charset="-120"/>
               </a:rPr>
-              <a:t>LLM 更会“知道自己不确定”：模糊用例全部升级人工</a:t>
+              <a:t>新 v2 中文备注：混合 39/40，完整 LLM 37/40</a:t>
             </a:r>
             <a:endParaRPr lang="en-US" sz="1400" dirty="0"/>
           </a:p>
@@ -10387,7 +10387,7 @@
                 <a:ea typeface="Microsoft YaHei" pitchFamily="34" charset="-122"/>
                 <a:cs typeface="Microsoft YaHei" pitchFamily="34" charset="-120"/>
               </a:rPr>
-              <a:t>但 LLM 会高置信出错 → 必须叠加门控</a:t>
+              <a:t>v2 作者标注、合成；两集结果不能直接比</a:t>
             </a:r>
             <a:endParaRPr lang="en-US" sz="1400" dirty="0"/>
           </a:p>
@@ -10408,7 +10408,7 @@
                 <a:ea typeface="Microsoft YaHei" pitchFamily="34" charset="-122"/>
                 <a:cs typeface="Microsoft YaHei" pitchFamily="34" charset="-120"/>
               </a:rPr>
-              <a:t>Jev 未获访问：接口保留，可直接复测</a:t>
+              <a:t>Jev 未获访问：接口保留</a:t>
             </a:r>
             <a:endParaRPr lang="en-US" sz="1400" dirty="0"/>
           </a:p>
@@ -10579,7 +10579,7 @@
         <p:spPr>
           <a:xfrm>
             <a:off x="548640" y="5852160"/>
-            <a:ext cx="10424160" cy="411480"/>
+            <a:ext cx="10881360" cy="411480"/>
           </a:xfrm>
           <a:prstGeom prst="rect">
             <a:avLst/>
@@ -10595,7 +10595,7 @@
               <a:buNone/>
             </a:pPr>
             <a:r>
-              <a:rPr lang="en-US" sz="1600" b="1" dirty="0">
+              <a:rPr lang="en-US" sz="1500" b="1" dirty="0">
                 <a:solidFill>
                   <a:srgbClr val="9E493D"/>
                 </a:solidFill>
@@ -10603,9 +10603,9 @@
                 <a:ea typeface="Microsoft YaHei" pitchFamily="34" charset="-122"/>
                 <a:cs typeface="Microsoft YaHei" pitchFamily="34" charset="-120"/>
               </a:rPr>
-              <a:t>Top-10 中 8/10 为糖皮质激素 → 一个 NR3C1 机制假设，而非十个独立候选</a:t>
-            </a:r>
-            <a:endParaRPr lang="en-US" sz="1600" dirty="0"/>
+              <a:t>Top-10 中 9/10 属于或很可能属于糖皮质激素 → NR3C1 类别假设，而非十个独立疗效证据</a:t>
+            </a:r>
+            <a:endParaRPr lang="en-US" sz="1500" dirty="0"/>
           </a:p>
         </p:txBody>
       </p:sp>

</xml_diff>

<commit_message>
docs: deck v7 slide 9 shows pathway enrichment and Top-10 reversal; slide 6 title says B4 ties BNNR
Rendered through PowerPoint and re-checked slides 6, 9 and 11; validator passes.

Co-Authored-By: Claude Opus 5.5 <noreply@anthropic.com>
</commit_message>
<xml_diff>
--- a/deliverables/药物重定位Agent_答辩稿_v7.pptx
+++ b/deliverables/药物重定位Agent_答辩稿_v7.pptx
@@ -2240,7 +2240,7 @@
           <a:p>
             <a:r>
               <a:rPr lang="en-US" dirty="0"/>
-              <a:t>约 70 秒。RECeSS 官方 Runner，与作者公布的 11 个模型逐种子对齐。B3：随机 0.723（BNNR 0.733 第一，B3 在 100 个配对种子中胜 35 次），弱相关 0.692（MBiRW 0.738 第一）。第二轮 B4（B3 + BNNR 的 NumPy 移植，只在开发种子上设计后冻结）：随机 0.745、弱相关 0.658。B4 在随机拆分上超过全部 11 个发表模型（对 BNNR 配对胜 87/100），但弱相关拆分仍落后 MBiRW 与 HAN，因此只能说随机拆分协议下排名第一，不宣称两种协议下的 SOTA。</a:t>
+              <a:t>约 70 秒。RECeSS 官方 Runner，与作者公布的 11 个模型逐种子对齐。B3：随机 0.723（BNNR 0.733 第一，B3 在 100 个配对种子中胜 35 次），弱相关 0.692（MBiRW 0.738 第一）。第二轮 B4（B3 + BNNR 的 NumPy 移植，只在开发种子上设计后冻结）：随机 0.745、弱相关 0.658。B4 在随机拆分上的均值高于全部 11 个发表模型（对 BNNR 配对胜 87/100）。但 100 个种子的测试集互相重叠，用 Nadeau–Bengio 校正检验后，对 BNNR 的差值 p = 0.066，95% CI [-0.0008, 0.0251] 跨 0，只能说与 BNNR 持平；global NDCG 与 HR@10 上 BNNR 仍更强。弱相关拆分落后 MBiRW 与 HAN。因此不宣称 SOTA。</a:t>
             </a:r>
             <a:endParaRPr lang="en-US" dirty="0"/>
           </a:p>
@@ -2504,7 +2504,7 @@
           <a:p>
             <a:r>
               <a:rPr lang="en-US" dirty="0"/>
-              <a:t>约 60 秒。GSE32863 配对差异表达得到 512 上调 / 749 下调基因（FDR&lt;0.05，|log2FC|≥1）；肺泡上皮标志物（AGER、SFTPA1、CLDN18）下调，细胞外基质与侵袭相关基因（SPP1、MMP11、COL1A1）上调，符合 LUAD 生物学。A549 签名反转得到的 Top-10 中 8 个是糖皮质激素、共同指向 NR3C1 与 GR 转录通路——这是一个机制假设而不是十个独立发现；A549 为 KRAS 突变细胞系，细胞系结果不能外推到患者。</a:t>
+              <a:t>约 60 秒。GSE32863 配对差异表达得到 512 上调 / 749 下调基因（FDR&lt;0.05，|log2FC|≥1）。Hallmark 富集：肿瘤上调 Estrogen Response Late、G2-M Checkpoint、Glycolysis、E2F Targets、KRAS Signaling Up；肿瘤下调 TNF-alpha Signaling via NF-kB、KRAS Signaling Up、Epithelial Mesenchymal Transition、Inflammatory Response，后者更可能反映正常肺组织免疫/间质成分在肿瘤中减少。右图：Top-10 在这些通路上的反转百分位，主要集中在糖酵解、G2-M/E2F 与缺氧；diflorasone 与 beclomethasone 不反转 EMT 基因。Top-10 中 9/10 属于或很可能属于糖皮质激素，指向 NR3C1 类别假设。注意：Top-10 与通路基因来自同一签名，右图不是独立验证。预先冻结的参考药中 5 个可测，平均名次百分位 0.362，置换 p = 0.147，不显著——本筛选没有证明能恢复已知 LUAD 药物。A549 为 KRAS 突变细胞系，结果不能外推到患者。</a:t>
             </a:r>
             <a:endParaRPr lang="en-US" dirty="0"/>
           </a:p>
@@ -6791,7 +6791,7 @@
                 <a:ea typeface="Microsoft YaHei" pitchFamily="34" charset="-122"/>
                 <a:cs typeface="Microsoft YaHei" pitchFamily="34" charset="-120"/>
               </a:rPr>
-              <a:t>对齐指标方向并集成 BNNR 后 B4 随机拆分第 1/13、弱相关第 3/13；随机拆分超过全部发表模型，弱相关未超过</a:t>
+              <a:t>对齐指标方向并集成 BNNR 后 B4 随机拆分第 1/13、弱相关第 3/13；随机拆分与 BNNR 持平（校正检验不显著），弱相关未超过</a:t>
             </a:r>
             <a:endParaRPr lang="en-US" sz="1800" dirty="0"/>
           </a:p>
@@ -9861,7 +9861,7 @@
                 <a:ea typeface="Microsoft YaHei" pitchFamily="34" charset="-122"/>
                 <a:cs typeface="Microsoft YaHei" pitchFamily="34" charset="-120"/>
               </a:rPr>
-              <a:t>官方 Benchmark：B4 随机拆分第 1/13，弱相关第 3/13</a:t>
+              <a:t>Benchmark：B4 随机 1/13（与 BNNR 持平）、弱相关 3/13</a:t>
             </a:r>
             <a:endParaRPr lang="en-US" sz="3000" dirty="0"/>
           </a:p>
@@ -10479,7 +10479,7 @@
                 <a:ea typeface="Microsoft YaHei" pitchFamily="34" charset="-122"/>
                 <a:cs typeface="Microsoft YaHei" pitchFamily="34" charset="-120"/>
               </a:rPr>
-              <a:t>肺腺癌案例：签名与机制</a:t>
+              <a:t>肺腺癌案例：通路与机制</a:t>
             </a:r>
             <a:endParaRPr lang="en-US" sz="3000" dirty="0"/>
           </a:p>
@@ -10526,7 +10526,7 @@
       </p:sp>
       <p:pic>
         <p:nvPicPr>
-          <p:cNvPr id="5" name="Image 0" descr="docs/figures/fig3_luad_volcano.png">    </p:cNvPr>
+          <p:cNvPr id="5" name="Image 0" descr="docs/figures/fig7_luad_pathways.png">    </p:cNvPr>
           <p:cNvPicPr>
             <a:picLocks noChangeAspect="1"/>
           </p:cNvPicPr>
@@ -10540,7 +10540,7 @@
         <p:spPr>
           <a:xfrm>
             <a:off x="365760" y="1188720"/>
-            <a:ext cx="5669280" cy="4480560"/>
+            <a:ext cx="5760720" cy="4480560"/>
           </a:xfrm>
           <a:prstGeom prst="rect">
             <a:avLst/>
@@ -10549,7 +10549,7 @@
       </p:pic>
       <p:pic>
         <p:nvPicPr>
-          <p:cNvPr id="6" name="Image 1" descr="docs/figures/fig5_top10_network.png">    </p:cNvPr>
+          <p:cNvPr id="6" name="Image 1" descr="docs/figures/fig8_top10_pathway_reversal.png">    </p:cNvPr>
           <p:cNvPicPr>
             <a:picLocks noChangeAspect="1"/>
           </p:cNvPicPr>
@@ -10562,7 +10562,7 @@
         </p:blipFill>
         <p:spPr>
           <a:xfrm>
-            <a:off x="6217920" y="1188720"/>
+            <a:off x="6263640" y="1188720"/>
             <a:ext cx="5577840" cy="4480560"/>
           </a:xfrm>
           <a:prstGeom prst="rect">
@@ -10603,7 +10603,7 @@
                 <a:ea typeface="Microsoft YaHei" pitchFamily="34" charset="-122"/>
                 <a:cs typeface="Microsoft YaHei" pitchFamily="34" charset="-120"/>
               </a:rPr>
-              <a:t>Top-10 中 9/10 属于或很可能属于糖皮质激素 → NR3C1 类别假设，而非十个独立疗效证据</a:t>
+              <a:t>9/10 为糖皮质激素（NR3C1 类别假设）；主要反转增殖与糖酵解程序；参考药恢复 p = 0.147，不显著</a:t>
             </a:r>
             <a:endParaRPr lang="en-US" sz="1500" dirty="0"/>
           </a:p>

</xml_diff>

<commit_message>
docs: rebuild deck v7, report v5 and LaTeX PDFs with the threshold-sensitivity result
Deck validated and rendered via PowerPoint (slide 9 checked); report rendered via Word (10 pages); LaTeX QA clean.

Co-Authored-By: Claude Opus 5.5 <noreply@anthropic.com>
</commit_message>
<xml_diff>
--- a/deliverables/药物重定位Agent_答辩稿_v7.pptx
+++ b/deliverables/药物重定位Agent_答辩稿_v7.pptx
@@ -2504,7 +2504,7 @@
           <a:p>
             <a:r>
               <a:rPr lang="en-US" dirty="0"/>
-              <a:t>约 60 秒。GSE32863 配对差异表达得到 512 上调 / 749 下调基因（FDR&lt;0.05，|log2FC|≥1）。Hallmark 富集：肿瘤上调 Estrogen Response Late、G2-M Checkpoint、Glycolysis、E2F Targets、KRAS Signaling Up；肿瘤下调 TNF-alpha Signaling via NF-kB、KRAS Signaling Up、Epithelial Mesenchymal Transition、Inflammatory Response，后者更可能反映正常肺组织免疫/间质成分在肿瘤中减少。右图：Top-10 在这些通路上的反转百分位，主要集中在糖酵解、G2-M/E2F 与缺氧；diflorasone 与 beclomethasone 不反转 EMT 基因。Top-10 中 9/10 属于或很可能属于糖皮质激素，指向 NR3C1 类别假设。注意：Top-10 与通路基因来自同一签名，右图不是独立验证。预先冻结的参考药中 5 个可测，平均名次百分位 0.362，置换 p = 0.147，不显著——本筛选没有证明能恢复已知 LUAD 药物。A549 为 KRAS 突变细胞系，结果不能外推到患者。</a:t>
+              <a:t>约 60 秒。GSE32863 配对差异表达得到 512 上调 / 749 下调基因（FDR&lt;0.05，|log2FC|≥1）。Hallmark 富集：肿瘤上调 Estrogen Response Late、G2-M Checkpoint、Glycolysis、E2F Targets、KRAS Signaling Up；肿瘤下调 TNF-alpha Signaling via NF-kB、KRAS Signaling Up、Epithelial Mesenchymal Transition、Inflammatory Response，后者更可能反映正常肺组织免疫/间质成分在肿瘤中减少。右图：Top-10 在这些通路上的反转百分位，主要集中在糖酵解、G2-M/E2F 与缺氧；diflorasone 与 beclomethasone 不反转 EMT 基因。Top-10 中 9/10 属于或很可能属于糖皮质激素，指向 NR3C1 类别假设；但阈值敏感性分析显示这只在 |log2FC|≥1 及更严时成立，放宽到 0.58 后 Top-10 只剩 3 个原候选，RAF/PI3K/mTOR 抑制剂（Hub 注释）进入，只有 hydrocortisone、beclomethasone、clocortolone 在 12 种设定下都留在 Top-10（docs/luad_threshold_sensitivity.md）。注意：Top-10 与通路基因来自同一签名，右图不是独立验证。预先冻结的参考药中 5 个可测，平均名次百分位 0.362，置换 p = 0.147，不显著——本筛选没有证明能恢复已知 LUAD 药物。A549 为 KRAS 突变细胞系，结果不能外推到患者。</a:t>
             </a:r>
             <a:endParaRPr lang="en-US" dirty="0"/>
           </a:p>
@@ -10603,7 +10603,7 @@
                 <a:ea typeface="Microsoft YaHei" pitchFamily="34" charset="-122"/>
                 <a:cs typeface="Microsoft YaHei" pitchFamily="34" charset="-120"/>
               </a:rPr>
-              <a:t>9/10 为糖皮质激素（NR3C1 类别假设）；主要反转增殖与糖酵解程序；参考药恢复 p = 0.147，不显著</a:t>
+              <a:t>预设阈值下 9/10 为糖皮质激素，但放宽阈值后被 RAF/PI3K/mTOR 抑制剂部分取代；参考药恢复 p = 0.147，不显著</a:t>
             </a:r>
             <a:endParaRPr lang="en-US" sz="1500" dirty="0"/>
           </a:p>

</xml_diff>

<commit_message>
docs: rebuild deck v7, report v5 and LaTeX PDFs with the v4-pro replication
Deck validated and rendered via PowerPoint (slide 8 checked); report rendered via Word (10 pages); LaTeX QA clean.

Co-Authored-By: Claude Opus 5.5 <noreply@anthropic.com>
</commit_message>
<xml_diff>
--- a/deliverables/药物重定位Agent_答辩稿_v7.pptx
+++ b/deliverables/药物重定位Agent_答辩稿_v7.pptx
@@ -2416,7 +2416,7 @@
           <a:p>
             <a:r>
               <a:rPr lang="en-US" dirty="0"/>
-              <a:t>约 50 秒。图为 v1 的 120 个封闭合成决策用例：J0 与 J1 准确率都是 0.875，J1 高风险误执行 0.150；置信门控降到 0.083，但增加人工升级。新 v2 是另一个在任何调用前冻结的 40 条中文风险备注压力测试：混合层 39/40、完整 LLM 37/40、旧关键词规则 20/40；80/80 provider trace 通过回放。v2 是作者标注的合成新用例，不与 v1 准确率直接比较，也不代表临床正确率。Jev 未获访问。</a:t>
+              <a:t>约 50 秒。图为 v1 的 120 个封闭合成决策用例：J0 与 J1 准确率都是 0.875，J1 高风险误执行 0.150；置信门控降到 0.083，但增加人工升级。新 v2 是另一个在任何调用前冻结的 40 条中文风险备注压力测试：混合层 39/40、完整 LLM 37/40、旧关键词规则 20/40；80/80 provider trace 通过回放。v2 是作者标注的合成新用例，不与 v1 准确率直接比较，也不代表临床正确率。换模型复现（deepseek-v4-pro，同一冻结用例）：规划 97/100（flash 98/100）；v1 门控在 flash 上拦下 29 个低置信判断，在 v4-pro 上一次都没触发——v4-pro 更自信但 Brier 相近，门控阈值不能跨模型照搬；v2 混合层在两个模型上都是 0 高风险误执行，而完整 LLM 在 v4-pro 上升到 17%。Jev 未获访问。</a:t>
             </a:r>
             <a:endParaRPr lang="en-US" dirty="0"/>
           </a:p>
@@ -10387,7 +10387,7 @@
                 <a:ea typeface="Microsoft YaHei" pitchFamily="34" charset="-122"/>
                 <a:cs typeface="Microsoft YaHei" pitchFamily="34" charset="-120"/>
               </a:rPr>
-              <a:t>v2 作者标注、合成；两集结果不能直接比</a:t>
+              <a:t>换 v4-pro：门控 0/120 触发；混合层仍 0 高风险误执行</a:t>
             </a:r>
             <a:endParaRPr lang="en-US" sz="1400" dirty="0"/>
           </a:p>

</xml_diff>

<commit_message>
docs: rebuild deck v7 with the live Jev results on slides 8 and 11
Validated and rendered through PowerPoint; deliverable QA passes (10-page report, 11-slide deck).

Co-Authored-By: Claude Opus 5.5 <noreply@anthropic.com>
</commit_message>
<xml_diff>
--- a/deliverables/药物重定位Agent_答辩稿_v7.pptx
+++ b/deliverables/药物重定位Agent_答辩稿_v7.pptx
@@ -844,7 +844,7 @@
               <a:lstStyle/>
               <a:p>
                 <a:pPr>
-                  <a:defRPr b="0" i="0" strike="noStrike" sz="1100" u="none">
+                  <a:defRPr b="0" i="0" strike="noStrike" sz="900" u="none">
                     <a:solidFill>
                       <a:srgbClr val="000000"/>
                     </a:solidFill>
@@ -863,18 +863,24 @@
           </c:dLbls>
           <c:cat>
             <c:multiLvlStrRef>
-              <c:f>Sheet1!$A$2:$A$4</c:f>
+              <c:f>Sheet1!$A$2:$A$6</c:f>
               <c:multiLvlStrCache>
-                <c:ptCount val="3"/>
+                <c:ptCount val="5"/>
                 <c:lvl>
                   <c:pt idx="0">
-                    <c:v>J0 固定规则</c:v>
+                    <c:v>J0 规则</c:v>
                   </c:pt>
                   <c:pt idx="1">
-                    <c:v>J1 通用 LLM</c:v>
+                    <c:v>J1 flash</c:v>
                   </c:pt>
                   <c:pt idx="2">
-                    <c:v>J3 LLM + 置信门控</c:v>
+                    <c:v>J3 flash+门控</c:v>
+                  </c:pt>
+                  <c:pt idx="3">
+                    <c:v>J2 Jev</c:v>
+                  </c:pt>
+                  <c:pt idx="4">
+                    <c:v>J3 Jev+门控</c:v>
                   </c:pt>
                 </c:lvl>
               </c:multiLvlStrCache>
@@ -882,10 +888,10 @@
           </c:cat>
           <c:val>
             <c:numRef>
-              <c:f>Sheet1!$B$2:$B$4</c:f>
+              <c:f>Sheet1!$B$2:$B$6</c:f>
               <c:numCache>
                 <c:formatCode>General</c:formatCode>
-                <c:ptCount val="3"/>
+                <c:ptCount val="5"/>
                 <c:pt idx="0">
                   <c:v>0.875</c:v>
                 </c:pt>
@@ -894,6 +900,12 @@
                 </c:pt>
                 <c:pt idx="2">
                   <c:v>0.792</c:v>
+                </c:pt>
+                <c:pt idx="3">
+                  <c:v>0.9</c:v>
+                </c:pt>
+                <c:pt idx="4">
+                  <c:v>0.783</c:v>
                 </c:pt>
               </c:numCache>
             </c:numRef>
@@ -908,7 +920,7 @@
               <c:strCache>
                 <c:ptCount val="1"/>
                 <c:pt idx="0">
-                  <c:v>模糊用例升级召回</c:v>
+                  <c:v>模糊用例转人工</c:v>
                 </c:pt>
               </c:strCache>
             </c:strRef>
@@ -927,7 +939,7 @@
               <a:lstStyle/>
               <a:p>
                 <a:pPr>
-                  <a:defRPr b="0" i="0" strike="noStrike" sz="1100" u="none">
+                  <a:defRPr b="0" i="0" strike="noStrike" sz="900" u="none">
                     <a:solidFill>
                       <a:srgbClr val="000000"/>
                     </a:solidFill>
@@ -946,18 +958,24 @@
           </c:dLbls>
           <c:cat>
             <c:multiLvlStrRef>
-              <c:f>Sheet1!$A$2:$A$4</c:f>
+              <c:f>Sheet1!$A$2:$A$6</c:f>
               <c:multiLvlStrCache>
-                <c:ptCount val="3"/>
+                <c:ptCount val="5"/>
                 <c:lvl>
                   <c:pt idx="0">
-                    <c:v>J0 固定规则</c:v>
+                    <c:v>J0 规则</c:v>
                   </c:pt>
                   <c:pt idx="1">
-                    <c:v>J1 通用 LLM</c:v>
+                    <c:v>J1 flash</c:v>
                   </c:pt>
                   <c:pt idx="2">
-                    <c:v>J3 LLM + 置信门控</c:v>
+                    <c:v>J3 flash+门控</c:v>
+                  </c:pt>
+                  <c:pt idx="3">
+                    <c:v>J2 Jev</c:v>
+                  </c:pt>
+                  <c:pt idx="4">
+                    <c:v>J3 Jev+门控</c:v>
                   </c:pt>
                 </c:lvl>
               </c:multiLvlStrCache>
@@ -965,10 +983,10 @@
           </c:cat>
           <c:val>
             <c:numRef>
-              <c:f>Sheet1!$C$2:$C$4</c:f>
+              <c:f>Sheet1!$C$2:$C$6</c:f>
               <c:numCache>
                 <c:formatCode>General</c:formatCode>
-                <c:ptCount val="3"/>
+                <c:ptCount val="5"/>
                 <c:pt idx="0">
                   <c:v>0.688</c:v>
                 </c:pt>
@@ -976,6 +994,12 @@
                   <c:v>1</c:v>
                 </c:pt>
                 <c:pt idx="2">
+                  <c:v>1</c:v>
+                </c:pt>
+                <c:pt idx="3">
+                  <c:v>0.938</c:v>
+                </c:pt>
+                <c:pt idx="4">
                   <c:v>1</c:v>
                 </c:pt>
               </c:numCache>
@@ -1010,7 +1034,7 @@
               <a:lstStyle/>
               <a:p>
                 <a:pPr>
-                  <a:defRPr b="0" i="0" strike="noStrike" sz="1100" u="none">
+                  <a:defRPr b="0" i="0" strike="noStrike" sz="900" u="none">
                     <a:solidFill>
                       <a:srgbClr val="000000"/>
                     </a:solidFill>
@@ -1029,18 +1053,24 @@
           </c:dLbls>
           <c:cat>
             <c:multiLvlStrRef>
-              <c:f>Sheet1!$A$2:$A$4</c:f>
+              <c:f>Sheet1!$A$2:$A$6</c:f>
               <c:multiLvlStrCache>
-                <c:ptCount val="3"/>
+                <c:ptCount val="5"/>
                 <c:lvl>
                   <c:pt idx="0">
-                    <c:v>J0 固定规则</c:v>
+                    <c:v>J0 规则</c:v>
                   </c:pt>
                   <c:pt idx="1">
-                    <c:v>J1 通用 LLM</c:v>
+                    <c:v>J1 flash</c:v>
                   </c:pt>
                   <c:pt idx="2">
-                    <c:v>J3 LLM + 置信门控</c:v>
+                    <c:v>J3 flash+门控</c:v>
+                  </c:pt>
+                  <c:pt idx="3">
+                    <c:v>J2 Jev</c:v>
+                  </c:pt>
+                  <c:pt idx="4">
+                    <c:v>J3 Jev+门控</c:v>
                   </c:pt>
                 </c:lvl>
               </c:multiLvlStrCache>
@@ -1048,10 +1078,10 @@
           </c:cat>
           <c:val>
             <c:numRef>
-              <c:f>Sheet1!$D$2:$D$4</c:f>
+              <c:f>Sheet1!$D$2:$D$6</c:f>
               <c:numCache>
                 <c:formatCode>General</c:formatCode>
-                <c:ptCount val="3"/>
+                <c:ptCount val="5"/>
                 <c:pt idx="0">
                   <c:v>0.033</c:v>
                 </c:pt>
@@ -1060,6 +1090,12 @@
                 </c:pt>
                 <c:pt idx="2">
                   <c:v>0.083</c:v>
+                </c:pt>
+                <c:pt idx="3">
+                  <c:v>0.117</c:v>
+                </c:pt>
+                <c:pt idx="4">
+                  <c:v>0</c:v>
                 </c:pt>
               </c:numCache>
             </c:numRef>
@@ -1072,7 +1108,7 @@
             <a:lstStyle/>
             <a:p>
               <a:pPr>
-                <a:defRPr b="0" i="0" strike="noStrike" sz="1100" u="none">
+                <a:defRPr b="0" i="0" strike="noStrike" sz="900" u="none">
                   <a:solidFill>
                     <a:srgbClr val="000000"/>
                   </a:solidFill>
@@ -1120,7 +1156,7 @@
           <a:lstStyle/>
           <a:p>
             <a:pPr>
-              <a:defRPr sz="1200" b="0" i="0" u="none" strike="noStrike">
+              <a:defRPr sz="1100" b="0" i="0" u="none" strike="noStrike">
                 <a:solidFill>
                   <a:srgbClr val="5B6B75"/>
                 </a:solidFill>
@@ -2416,7 +2452,7 @@
           <a:p>
             <a:r>
               <a:rPr lang="en-US" dirty="0"/>
-              <a:t>约 50 秒。图为 v1 的 120 个封闭合成决策用例：J0 与 J1 准确率都是 0.875，J1 高风险误执行 0.150；置信门控降到 0.083，但增加人工升级。新 v2 是另一个在任何调用前冻结的 40 条中文风险备注压力测试：混合层 39/40、完整 LLM 37/40、旧关键词规则 20/40；80/80 provider trace 通过回放。v2 是作者标注的合成新用例，不与 v1 准确率直接比较，也不代表临床正确率。换模型复现（deepseek-v4-pro，同一冻结用例）：规划 97/100（flash 98/100）；v1 门控在 flash 上拦下 29 个低置信判断，在 v4-pro 上一次都没触发——v4-pro 更自信但 Brier 相近，门控阈值不能跨模型照搬；v2 混合层在两个模型上都是 0 高风险误执行，而完整 LLM 在 v4-pro 上升到 17%。Jev 未获访问。</a:t>
+              <a:t>约 60 秒。图为 v1 的 120 个封闭合成决策用例，所有决策器看到同样的策略文本与用例字段，门控阈值（0.8/0.9）在调用前固定。规则与 flash 准确率都是 0.875；flash 高风险误执行 0.150，加门控降到 0.083。Jev（TypeSafe System One，经 OpenCode Zen 调用 jev-1.13-free；付费版因余额不足在得到答案前改用免费版）不加门控准确率 0.900，为所有决策器最高；Brier 0.147，低于 flash 0.221 与 v4-pro 0.228，但 ECE 0.042 略高于 flash 的 0.025。Jev 加门控后高风险误执行为 0.000，代价是 0.483 的升级率；低置信交给 flash 的 J4 准确率 0.867。v2 的 40 条中文风险备注上，“规则算结构化字段、模型只判备注”的混合层，无论 flash、v4-pro 还是 Jev 判备注，高风险误执行都是 0（Jev 39/40）；让模型包办整个决策时，完整 Jev 只有 32/40 并出现高风险误执行。换 v4-pro 时门控一次都没触发，阈值需要按模型校准。用例为合成数据、单次运行，不代表临床正确率。</a:t>
             </a:r>
             <a:endParaRPr lang="en-US" dirty="0"/>
           </a:p>
@@ -7025,7 +7061,7 @@
                 <a:ea typeface="Microsoft YaHei" pitchFamily="34" charset="-122"/>
                 <a:cs typeface="Microsoft YaHei" pitchFamily="34" charset="-120"/>
               </a:rPr>
-              <a:t>细胞系 ≠ 患者；未知 ≠ 阴性；外部 v3 未跑；Jev/湿实验未做</a:t>
+              <a:t>细胞系 ≠ 患者；未知 ≠ 阴性；外部 v3 未跑；无湿实验；Jev 仅免费版单次运行</a:t>
             </a:r>
             <a:endParaRPr lang="en-US" sz="1800" dirty="0"/>
           </a:p>
@@ -10226,7 +10262,7 @@
                 <a:ea typeface="Microsoft YaHei" pitchFamily="34" charset="-122"/>
                 <a:cs typeface="Microsoft YaHei" pitchFamily="34" charset="-120"/>
               </a:rPr>
-              <a:t>决策层消融：规则 vs LLM vs 门控（Jev 接口已预留）</a:t>
+              <a:t>决策层：规则 vs 通用 LLM vs Jev（实测）</a:t>
             </a:r>
             <a:endParaRPr lang="en-US" sz="3000" dirty="0"/>
           </a:p>
@@ -10278,8 +10314,8 @@
           <p:nvPr/>
         </p:nvGraphicFramePr>
         <p:xfrm>
-          <a:off x="457200" y="1188720"/>
-          <a:ext cx="7498080" cy="4937760"/>
+          <a:off x="365760" y="1188720"/>
+          <a:ext cx="7772400" cy="4937760"/>
         </p:xfrm>
         <a:graphic xmlns:a="http://schemas.openxmlformats.org/drawingml/2006/main">
           <a:graphicData uri="http://schemas.openxmlformats.org/drawingml/2006/chart">
@@ -10295,8 +10331,8 @@
         </p:nvSpPr>
         <p:spPr>
           <a:xfrm>
-            <a:off x="8229600" y="1371600"/>
-            <a:ext cx="3474720" cy="4572000"/>
+            <a:off x="8321040" y="1280160"/>
+            <a:ext cx="3474720" cy="4846320"/>
           </a:xfrm>
           <a:prstGeom prst="rect">
             <a:avLst/>
@@ -10316,7 +10352,7 @@
               <a:buChar char="•"/>
             </a:pPr>
             <a:r>
-              <a:rPr lang="en-US" sz="1400" dirty="0">
+              <a:rPr lang="en-US" sz="1300" dirty="0">
                 <a:solidFill>
                   <a:srgbClr val="183042"/>
                 </a:solidFill>
@@ -10324,9 +10360,9 @@
                 <a:ea typeface="Microsoft YaHei" pitchFamily="34" charset="-122"/>
                 <a:cs typeface="Microsoft YaHei" pitchFamily="34" charset="-120"/>
               </a:rPr>
-              <a:t>图：v1 120 个冻结合成决策用例</a:t>
-            </a:r>
-            <a:endParaRPr lang="en-US" sz="1400" dirty="0"/>
+              <a:t>v1 120 例：Jev 准确率 0.900 最高，Brier 0.147 最低</a:t>
+            </a:r>
+            <a:endParaRPr lang="en-US" sz="1300" dirty="0"/>
           </a:p>
           <a:p>
             <a:pPr marL="342900" indent="-342900">
@@ -10337,7 +10373,7 @@
               <a:buChar char="•"/>
             </a:pPr>
             <a:r>
-              <a:rPr lang="en-US" sz="1400" dirty="0">
+              <a:rPr lang="en-US" sz="1300" dirty="0">
                 <a:solidFill>
                   <a:srgbClr val="183042"/>
                 </a:solidFill>
@@ -10345,9 +10381,9 @@
                 <a:ea typeface="Microsoft YaHei" pitchFamily="34" charset="-122"/>
                 <a:cs typeface="Microsoft YaHei" pitchFamily="34" charset="-120"/>
               </a:rPr>
-              <a:t>v1 规则与 LLM 准确率持平；门控减少高风险误执行</a:t>
-            </a:r>
-            <a:endParaRPr lang="en-US" sz="1400" dirty="0"/>
+              <a:t>Jev + 门控：高风险误执行 0.000，但升级率 0.483</a:t>
+            </a:r>
+            <a:endParaRPr lang="en-US" sz="1300" dirty="0"/>
           </a:p>
           <a:p>
             <a:pPr marL="342900" indent="-342900">
@@ -10358,7 +10394,7 @@
               <a:buChar char="•"/>
             </a:pPr>
             <a:r>
-              <a:rPr lang="en-US" sz="1400" dirty="0">
+              <a:rPr lang="en-US" sz="1300" dirty="0">
                 <a:solidFill>
                   <a:srgbClr val="183042"/>
                 </a:solidFill>
@@ -10366,9 +10402,9 @@
                 <a:ea typeface="Microsoft YaHei" pitchFamily="34" charset="-122"/>
                 <a:cs typeface="Microsoft YaHei" pitchFamily="34" charset="-120"/>
               </a:rPr>
-              <a:t>新 v2 中文备注：混合 39/40，完整 LLM 37/40</a:t>
-            </a:r>
-            <a:endParaRPr lang="en-US" sz="1400" dirty="0"/>
+              <a:t>v2 混合层（Jev 判备注）39/40、0 高风险误执行；完整 Jev 32/40</a:t>
+            </a:r>
+            <a:endParaRPr lang="en-US" sz="1300" dirty="0"/>
           </a:p>
           <a:p>
             <a:pPr marL="342900" indent="-342900">
@@ -10379,7 +10415,7 @@
               <a:buChar char="•"/>
             </a:pPr>
             <a:r>
-              <a:rPr lang="en-US" sz="1400" dirty="0">
+              <a:rPr lang="en-US" sz="1300" dirty="0">
                 <a:solidFill>
                   <a:srgbClr val="183042"/>
                 </a:solidFill>
@@ -10387,9 +10423,9 @@
                 <a:ea typeface="Microsoft YaHei" pitchFamily="34" charset="-122"/>
                 <a:cs typeface="Microsoft YaHei" pitchFamily="34" charset="-120"/>
               </a:rPr>
-              <a:t>换 v4-pro：门控 0/120 触发；混合层仍 0 高风险误执行</a:t>
-            </a:r>
-            <a:endParaRPr lang="en-US" sz="1400" dirty="0"/>
+              <a:t>混合设计换 flash / v4-pro / Jev 都是 0 高风险误执行</a:t>
+            </a:r>
+            <a:endParaRPr lang="en-US" sz="1300" dirty="0"/>
           </a:p>
           <a:p>
             <a:pPr marL="342900" indent="-342900">
@@ -10400,7 +10436,7 @@
               <a:buChar char="•"/>
             </a:pPr>
             <a:r>
-              <a:rPr lang="en-US" sz="1400" dirty="0">
+              <a:rPr lang="en-US" sz="1300" dirty="0">
                 <a:solidFill>
                   <a:srgbClr val="183042"/>
                 </a:solidFill>
@@ -10408,9 +10444,9 @@
                 <a:ea typeface="Microsoft YaHei" pitchFamily="34" charset="-122"/>
                 <a:cs typeface="Microsoft YaHei" pitchFamily="34" charset="-120"/>
               </a:rPr>
-              <a:t>Jev 未获访问：接口保留</a:t>
-            </a:r>
-            <a:endParaRPr lang="en-US" sz="1400" dirty="0"/>
+              <a:t>合成用例、单次运行；Jev 用免费版</a:t>
+            </a:r>
+            <a:endParaRPr lang="en-US" sz="1300" dirty="0"/>
           </a:p>
         </p:txBody>
       </p:sp>

</xml_diff>

<commit_message>
docs: deck v7 gains an agent v2 planning slide and the v2 architecture diagram (12 slides)
Slide 4 shows the updated architecture figure; new slide 5 charts the frozen 40-case multi-step planning results by category and the real observe-replan run. Rendered via PowerPoint, validator and deliverable QA pass; outline renumbered with Q&A on autonomous planning.

Co-Authored-By: Claude Opus 5.5 <noreply@anthropic.com>
</commit_message>
<xml_diff>
--- a/deliverables/药物重定位Agent_答辩稿_v7.pptx
+++ b/deliverables/药物重定位Agent_答辩稿_v7.pptx
@@ -16,9 +16,10 @@
     <p:sldId id="264" r:id="rId10"/>
     <p:sldId id="265" r:id="rId11"/>
     <p:sldId id="266" r:id="rId12"/>
+    <p:sldId id="267" r:id="rId13"/>
   </p:sldIdLst>
   <p:notesMasterIdLst>
-    <p:notesMasterId r:id="rId13"/>
+    <p:notesMasterId r:id="rId14"/>
   </p:notesMasterIdLst>
   <p:sldSz cx="12192000" cy="6858000"/>
   <p:notesSz cx="6858000" cy="12192000"/>
@@ -118,6 +119,413 @@
 </file>
 
 <file path=ppt/charts/chart1.xml><?xml version="1.0" encoding="utf-8"?>
+<c:chartSpace xmlns:c="http://schemas.openxmlformats.org/drawingml/2006/chart" xmlns:a="http://schemas.openxmlformats.org/drawingml/2006/main" xmlns:r="http://schemas.openxmlformats.org/officeDocument/2006/relationships">
+  <c:date1904 val="0"/>
+  <c:roundedCorners val="1"/>
+  <c:chart>
+    <c:title>
+      <c:tx>
+        <c:rich>
+          <a:bodyPr/>
+          <a:lstStyle/>
+          <a:p>
+            <a:pPr>
+              <a:defRPr sz="1400" b="0" i="0" u="none" strike="noStrike">
+                <a:solidFill>
+                  <a:srgbClr val="183042"/>
+                </a:solidFill>
+                <a:latin typeface="Microsoft YaHei"/>
+              </a:defRPr>
+            </a:pPr>
+            <a:r>
+              <a:rPr sz="1400" b="0" i="0" u="none" strike="noStrike">
+                <a:solidFill>
+                  <a:srgbClr val="183042"/>
+                </a:solidFill>
+                <a:latin typeface="Microsoft YaHei"/>
+              </a:rPr>
+              <a:t>冻结 40 例多步规划：规则 30/40 · DeepSeek 36/40</a:t>
+            </a:r>
+          </a:p>
+        </c:rich>
+      </c:tx>
+      <c:layout/>
+      <c:overlay val="0"/>
+    </c:title>
+    <c:autoTitleDeleted val="0"/>
+    <c:plotArea>
+      <c:layout/>
+      <c:barChart>
+        <c:barDir val="col"/>
+        <c:grouping val="clustered"/>
+        <c:varyColors val="0"/>
+        <c:ser>
+          <c:idx val="0"/>
+          <c:order val="0"/>
+          <c:tx>
+            <c:strRef>
+              <c:f>Sheet1!$B$1</c:f>
+              <c:strCache>
+                <c:ptCount val="1"/>
+                <c:pt idx="0">
+                  <c:v>规则规划器</c:v>
+                </c:pt>
+              </c:strCache>
+            </c:strRef>
+          </c:tx>
+          <c:spPr>
+            <a:solidFill>
+              <a:srgbClr val="B9C2C7"/>
+            </a:solidFill>
+            <a:effectLst/>
+          </c:spPr>
+          <c:invertIfNegative val="0"/>
+          <c:dLbls>
+            <c:numFmt formatCode="0%" sourceLinked="0"/>
+            <c:txPr>
+              <a:bodyPr/>
+              <a:lstStyle/>
+              <a:p>
+                <a:pPr>
+                  <a:defRPr b="0" i="0" strike="noStrike" sz="900" u="none">
+                    <a:solidFill>
+                      <a:srgbClr val="000000"/>
+                    </a:solidFill>
+                    <a:latin typeface="Microsoft YaHei"/>
+                  </a:defRPr>
+                </a:pPr>
+              </a:p>
+            </c:txPr>
+            <c:showLegendKey val="0"/>
+            <c:showVal val="1"/>
+            <c:showCatName val="0"/>
+            <c:showSerName val="0"/>
+            <c:showPercent val="0"/>
+            <c:showBubbleSize val="0"/>
+            <c:showLeaderLines val="0"/>
+          </c:dLbls>
+          <c:cat>
+            <c:multiLvlStrRef>
+              <c:f>Sheet1!$A$2:$A$7</c:f>
+              <c:multiLvlStrCache>
+                <c:ptCount val="6"/>
+                <c:lvl>
+                  <c:pt idx="0">
+                    <c:v>完整流程</c:v>
+                  </c:pt>
+                  <c:pt idx="1">
+                    <c:v>部分任务</c:v>
+                  </c:pt>
+                  <c:pt idx="2">
+                    <c:v>基准模式</c:v>
+                  </c:pt>
+                  <c:pt idx="3">
+                    <c:v>缺少输入</c:v>
+                  </c:pt>
+                  <c:pt idx="4">
+                    <c:v>故障恢复</c:v>
+                  </c:pt>
+                  <c:pt idx="5">
+                    <c:v>越权/注入</c:v>
+                  </c:pt>
+                </c:lvl>
+              </c:multiLvlStrCache>
+            </c:multiLvlStrRef>
+          </c:cat>
+          <c:val>
+            <c:numRef>
+              <c:f>Sheet1!$B$2:$B$7</c:f>
+              <c:numCache>
+                <c:formatCode>General</c:formatCode>
+                <c:ptCount val="6"/>
+                <c:pt idx="0">
+                  <c:v>1</c:v>
+                </c:pt>
+                <c:pt idx="1">
+                  <c:v>0.25</c:v>
+                </c:pt>
+                <c:pt idx="2">
+                  <c:v>0.8</c:v>
+                </c:pt>
+                <c:pt idx="3">
+                  <c:v>0.833</c:v>
+                </c:pt>
+                <c:pt idx="4">
+                  <c:v>0.857</c:v>
+                </c:pt>
+                <c:pt idx="5">
+                  <c:v>0.875</c:v>
+                </c:pt>
+              </c:numCache>
+            </c:numRef>
+          </c:val>
+        </c:ser>
+        <c:ser>
+          <c:idx val="1"/>
+          <c:order val="1"/>
+          <c:tx>
+            <c:strRef>
+              <c:f>Sheet1!$C$1</c:f>
+              <c:strCache>
+                <c:ptCount val="1"/>
+                <c:pt idx="0">
+                  <c:v>DeepSeek 规划器</c:v>
+                </c:pt>
+              </c:strCache>
+            </c:strRef>
+          </c:tx>
+          <c:spPr>
+            <a:solidFill>
+              <a:srgbClr val="087E78"/>
+            </a:solidFill>
+            <a:effectLst/>
+          </c:spPr>
+          <c:invertIfNegative val="0"/>
+          <c:dLbls>
+            <c:numFmt formatCode="0%" sourceLinked="0"/>
+            <c:txPr>
+              <a:bodyPr/>
+              <a:lstStyle/>
+              <a:p>
+                <a:pPr>
+                  <a:defRPr b="0" i="0" strike="noStrike" sz="900" u="none">
+                    <a:solidFill>
+                      <a:srgbClr val="000000"/>
+                    </a:solidFill>
+                    <a:latin typeface="Microsoft YaHei"/>
+                  </a:defRPr>
+                </a:pPr>
+              </a:p>
+            </c:txPr>
+            <c:showLegendKey val="0"/>
+            <c:showVal val="1"/>
+            <c:showCatName val="0"/>
+            <c:showSerName val="0"/>
+            <c:showPercent val="0"/>
+            <c:showBubbleSize val="0"/>
+            <c:showLeaderLines val="0"/>
+          </c:dLbls>
+          <c:cat>
+            <c:multiLvlStrRef>
+              <c:f>Sheet1!$A$2:$A$7</c:f>
+              <c:multiLvlStrCache>
+                <c:ptCount val="6"/>
+                <c:lvl>
+                  <c:pt idx="0">
+                    <c:v>完整流程</c:v>
+                  </c:pt>
+                  <c:pt idx="1">
+                    <c:v>部分任务</c:v>
+                  </c:pt>
+                  <c:pt idx="2">
+                    <c:v>基准模式</c:v>
+                  </c:pt>
+                  <c:pt idx="3">
+                    <c:v>缺少输入</c:v>
+                  </c:pt>
+                  <c:pt idx="4">
+                    <c:v>故障恢复</c:v>
+                  </c:pt>
+                  <c:pt idx="5">
+                    <c:v>越权/注入</c:v>
+                  </c:pt>
+                </c:lvl>
+              </c:multiLvlStrCache>
+            </c:multiLvlStrRef>
+          </c:cat>
+          <c:val>
+            <c:numRef>
+              <c:f>Sheet1!$C$2:$C$7</c:f>
+              <c:numCache>
+                <c:formatCode>General</c:formatCode>
+                <c:ptCount val="6"/>
+                <c:pt idx="0">
+                  <c:v>1</c:v>
+                </c:pt>
+                <c:pt idx="1">
+                  <c:v>1</c:v>
+                </c:pt>
+                <c:pt idx="2">
+                  <c:v>1</c:v>
+                </c:pt>
+                <c:pt idx="3">
+                  <c:v>1</c:v>
+                </c:pt>
+                <c:pt idx="4">
+                  <c:v>0.857</c:v>
+                </c:pt>
+                <c:pt idx="5">
+                  <c:v>0.625</c:v>
+                </c:pt>
+              </c:numCache>
+            </c:numRef>
+          </c:val>
+        </c:ser>
+        <c:dLbls>
+          <c:numFmt formatCode="0%" sourceLinked="0"/>
+          <c:txPr>
+            <a:bodyPr/>
+            <a:lstStyle/>
+            <a:p>
+              <a:pPr>
+                <a:defRPr b="0" i="0" strike="noStrike" sz="900" u="none">
+                  <a:solidFill>
+                    <a:srgbClr val="000000"/>
+                  </a:solidFill>
+                  <a:latin typeface="Microsoft YaHei"/>
+                </a:defRPr>
+              </a:pPr>
+            </a:p>
+          </c:txPr>
+          <c:showLegendKey val="0"/>
+          <c:showVal val="1"/>
+          <c:showCatName val="0"/>
+          <c:showSerName val="0"/>
+          <c:showPercent val="0"/>
+          <c:showBubbleSize val="0"/>
+          <c:showLeaderLines val="0"/>
+        </c:dLbls>
+        <c:gapWidth val="40"/>
+        <c:overlap val="-8"/>
+        <c:axId val="2094734554"/>
+        <c:axId val="2094734552"/>
+        <c:axId val="2094734556"/>
+      </c:barChart>
+      <c:catAx>
+        <c:axId val="2094734554"/>
+        <c:scaling>
+          <c:orientation val="minMax"/>
+        </c:scaling>
+        <c:delete val="0"/>
+        <c:axPos val="b"/>
+        <c:numFmt formatCode="General" sourceLinked="1"/>
+        <c:majorTickMark val="out"/>
+        <c:minorTickMark val="none"/>
+        <c:tickLblPos val="low"/>
+        <c:spPr>
+          <a:ln w="12700" cap="flat">
+            <a:solidFill>
+              <a:srgbClr val="888888"/>
+            </a:solidFill>
+            <a:prstDash val="solid"/>
+            <a:round/>
+          </a:ln>
+        </c:spPr>
+        <c:txPr>
+          <a:bodyPr/>
+          <a:lstStyle/>
+          <a:p>
+            <a:pPr>
+              <a:defRPr sz="1200" b="0" i="0" u="none" strike="noStrike">
+                <a:solidFill>
+                  <a:srgbClr val="5B6B75"/>
+                </a:solidFill>
+                <a:latin typeface="Microsoft YaHei"/>
+              </a:defRPr>
+            </a:pPr>
+            <a:endParaRPr lang="en-US"/>
+          </a:p>
+        </c:txPr>
+        <c:crossAx val="2094734552"/>
+        <c:crosses val="autoZero"/>
+        <c:auto val="1"/>
+        <c:lblAlgn val="ctr"/>
+        <c:noMultiLvlLbl val="1"/>
+      </c:catAx>
+      <c:valAx>
+        <c:axId val="2094734552"/>
+        <c:scaling>
+          <c:orientation val="minMax"/>
+          <c:max val="1.15"/>
+          <c:min val="0"/>
+        </c:scaling>
+        <c:delete val="0"/>
+        <c:axPos val="l"/>
+        <c:majorGridlines>
+          <c:spPr>
+            <a:ln w="6350" cap="flat">
+              <a:solidFill>
+                <a:srgbClr val="E3E7EA"/>
+              </a:solidFill>
+              <a:prstDash val="solid"/>
+              <a:round/>
+            </a:ln>
+          </c:spPr>
+        </c:majorGridlines>
+        <c:numFmt formatCode="0%" sourceLinked="0"/>
+        <c:majorTickMark val="out"/>
+        <c:minorTickMark val="none"/>
+        <c:tickLblPos val="nextTo"/>
+        <c:spPr>
+          <a:ln w="12700" cap="flat">
+            <a:solidFill>
+              <a:srgbClr val="888888"/>
+            </a:solidFill>
+            <a:prstDash val="solid"/>
+            <a:round/>
+          </a:ln>
+        </c:spPr>
+        <c:txPr>
+          <a:bodyPr/>
+          <a:lstStyle/>
+          <a:p>
+            <a:pPr>
+              <a:defRPr sz="1100" b="0" i="0" u="none" strike="noStrike">
+                <a:solidFill>
+                  <a:srgbClr val="5B6B75"/>
+                </a:solidFill>
+                <a:latin typeface="Microsoft YaHei"/>
+              </a:defRPr>
+            </a:pPr>
+            <a:endParaRPr lang="en-US"/>
+          </a:p>
+        </c:txPr>
+        <c:crossAx val="2094734554"/>
+        <c:crosses val="autoZero"/>
+        <c:crossBetween val="between"/>
+      </c:valAx>
+      <c:spPr>
+        <a:noFill/>
+        <a:ln>
+          <a:noFill/>
+        </a:ln>
+        <a:effectLst/>
+      </c:spPr>
+    </c:plotArea>
+    <c:legend>
+      <c:legendPos val="b"/>
+      <c:overlay val="0"/>
+      <c:txPr>
+        <a:bodyPr/>
+        <a:lstStyle/>
+        <a:p>
+          <a:pPr>
+            <a:defRPr sz="1200">
+              <a:latin typeface="Microsoft YaHei"/>
+              <a:cs typeface="Microsoft YaHei"/>
+            </a:defRPr>
+          </a:pPr>
+          <a:endParaRPr lang="en-US"/>
+        </a:p>
+      </c:txPr>
+    </c:legend>
+    <c:plotVisOnly val="1"/>
+    <c:dispBlanksAs val="span"/>
+  </c:chart>
+  <c:spPr>
+    <a:noFill/>
+    <a:ln>
+      <a:noFill/>
+    </a:ln>
+    <a:effectLst/>
+  </c:spPr>
+  <c:externalData r:id="rId1">
+    <c:autoUpdate val="0"/>
+  </c:externalData>
+</c:chartSpace>
+</file>
+
+<file path=ppt/charts/chart2.xml><?xml version="1.0" encoding="utf-8"?>
 <c:chartSpace xmlns:c="http://schemas.openxmlformats.org/drawingml/2006/chart" xmlns:a="http://schemas.openxmlformats.org/drawingml/2006/main" xmlns:r="http://schemas.openxmlformats.org/officeDocument/2006/relationships">
   <c:date1904 val="0"/>
   <c:roundedCorners val="1"/>
@@ -500,7 +908,7 @@
 </c:chartSpace>
 </file>
 
-<file path=ppt/charts/chart2.xml><?xml version="1.0" encoding="utf-8"?>
+<file path=ppt/charts/chart3.xml><?xml version="1.0" encoding="utf-8"?>
 <c:chartSpace xmlns:c="http://schemas.openxmlformats.org/drawingml/2006/chart" xmlns:a="http://schemas.openxmlformats.org/drawingml/2006/main" xmlns:r="http://schemas.openxmlformats.org/officeDocument/2006/relationships">
   <c:date1904 val="0"/>
   <c:roundedCorners val="1"/>
@@ -804,7 +1212,7 @@
 </c:chartSpace>
 </file>
 
-<file path=ppt/charts/chart3.xml><?xml version="1.0" encoding="utf-8"?>
+<file path=ppt/charts/chart4.xml><?xml version="1.0" encoding="utf-8"?>
 <c:chartSpace xmlns:c="http://schemas.openxmlformats.org/drawingml/2006/chart" xmlns:a="http://schemas.openxmlformats.org/drawingml/2006/main" xmlns:r="http://schemas.openxmlformats.org/officeDocument/2006/relationships">
   <c:date1904 val="0"/>
   <c:roundedCorners val="1"/>
@@ -1748,7 +2156,7 @@
           <a:p>
             <a:r>
               <a:rPr lang="en-US" dirty="0"/>
-              <a:t>约 50 秒。每个候选由文献 Agent、批评 Agent 和协调者处理。冻结版 65 条引语全部通过 PMID 与逐字校验、10/10 判为证据不足，共 22 次模型调用。事后来源/药名范围预筛标记 23 条；当前 PubMed 摘要级复核中 13 条原样候选级引用需排除，9 条仅能收窄终点保留，1 条仅作一般安全提示。错误包括勘误当原始研究、未指名类固醇归给具体候选、柚皮素抗癌结果误归给 fluticasone。冻结分级未重跑；这不是独立双人全文审阅。</a:t>
+              <a:t>约 60 秒。GSE32863 配对差异表达得到 512 上调 / 749 下调基因（FDR&lt;0.05，|log2FC|≥1）。Hallmark 富集：肿瘤上调 Estrogen Response Late、G2-M Checkpoint、Glycolysis、E2F Targets、KRAS Signaling Up；肿瘤下调 TNF-alpha Signaling via NF-kB、KRAS Signaling Up、Epithelial Mesenchymal Transition、Inflammatory Response，后者更可能反映正常肺组织免疫/间质成分在肿瘤中减少。右图：Top-10 在这些通路上的反转百分位，主要集中在糖酵解、G2-M/E2F 与缺氧；diflorasone 与 beclomethasone 不反转 EMT 基因。Top-10 中 9/10 属于或很可能属于糖皮质激素，指向 NR3C1 类别假设；但阈值敏感性分析显示这只在 |log2FC|≥1 及更严时成立，放宽到 0.58 后 Top-10 只剩 3 个原候选，RAF/PI3K/mTOR 抑制剂（Hub 注释）进入，只有 hydrocortisone、beclomethasone、clocortolone 在 12 种设定下都留在 Top-10（docs/luad_threshold_sensitivity.md）。注意：Top-10 与通路基因来自同一签名，右图不是独立验证。预先冻结的参考药中 5 个可测，平均名次百分位 0.362，置换 p = 0.147，不显著——本筛选没有证明能恢复已知 LUAD 药物。A549 为 KRAS 突变细胞系，结果不能外推到患者。</a:t>
             </a:r>
             <a:endParaRPr lang="en-US" dirty="0"/>
           </a:p>
@@ -1836,7 +2244,7 @@
           <a:p>
             <a:r>
               <a:rPr lang="en-US" dirty="0"/>
-              <a:t>约 40 秒。总结五点。23 条是事后来源/药名范围预筛标记，并非 65 条都经过全文审阅；13 条原样候选级引用需排除，冻结药物分级未重算。独立外部方法选择 v3 的数据与标签门槛未通过，没有外部 NS-AUC 结果。Benchmark 分数只代表已知关联恢复能力；LUAD 候选是待验证的研究假设，不是用药建议。代码与所有结果见 GitHub 仓库。</a:t>
+              <a:t>约 50 秒。每个候选由文献 Agent、批评 Agent 和协调者处理。冻结版 65 条引语全部通过 PMID 与逐字校验、10/10 判为证据不足，共 22 次模型调用。事后来源/药名范围预筛标记 23 条；当前 PubMed 摘要级复核中 13 条原样候选级引用需排除，9 条仅能收窄终点保留，1 条仅作一般安全提示。错误包括勘误当原始研究、未指名类固醇归给具体候选、柚皮素抗癌结果误归给 fluticasone。冻结分级未重跑；这不是独立双人全文审阅。</a:t>
             </a:r>
             <a:endParaRPr lang="en-US" dirty="0"/>
           </a:p>
@@ -1860,6 +2268,94 @@
             <a:fld id="{F7021451-1387-4CA6-816F-3879F97B5CBC}" type="slidenum">
               <a:rPr lang="en-US"/>
               <a:t>11</a:t>
+            </a:fld>
+            <a:endParaRPr lang="en-US"/>
+          </a:p>
+        </p:txBody>
+      </p:sp>
+    </p:spTree>
+    <p:extLst>
+      <p:ext uri="{BB962C8B-B14F-4D97-AF65-F5344CB8AC3E}">
+        <p14:creationId xmlns:p14="http://schemas.microsoft.com/office/powerpoint/2010/main" val="1024086991"/>
+      </p:ext>
+    </p:extLst>
+  </p:cSld>
+  <p:clrMapOvr>
+    <a:masterClrMapping/>
+  </p:clrMapOvr>
+</p:notes>
+</file>
+
+<file path=ppt/notesSlides/notesSlide12.xml><?xml version="1.0" encoding="utf-8"?>
+<p:notes xmlns:a="http://schemas.openxmlformats.org/drawingml/2006/main" xmlns:r="http://schemas.openxmlformats.org/officeDocument/2006/relationships" xmlns:p="http://schemas.openxmlformats.org/presentationml/2006/main">
+  <p:cSld>
+    <p:spTree>
+      <p:nvGrpSpPr>
+        <p:cNvPr id="1" name=""/>
+        <p:cNvGrpSpPr/>
+        <p:nvPr/>
+      </p:nvGrpSpPr>
+      <p:grpSpPr>
+        <a:xfrm>
+          <a:off x="0" y="0"/>
+          <a:ext cx="0" cy="0"/>
+          <a:chOff x="0" y="0"/>
+          <a:chExt cx="0" cy="0"/>
+        </a:xfrm>
+      </p:grpSpPr>
+      <p:sp>
+        <p:nvSpPr>
+          <p:cNvPr id="2" name="Slide Image Placeholder 1"/>
+          <p:cNvSpPr>
+            <a:spLocks noGrp="1" noRot="1" noChangeAspect="1"/>
+          </p:cNvSpPr>
+          <p:nvPr>
+            <p:ph type="sldImg"/>
+          </p:nvPr>
+        </p:nvSpPr>
+        <p:spPr/>
+      </p:sp>
+      <p:sp>
+        <p:nvSpPr>
+          <p:cNvPr id="3" name="Notes Placeholder 2"/>
+          <p:cNvSpPr>
+            <a:spLocks noGrp="1"/>
+          </p:cNvSpPr>
+          <p:nvPr>
+            <p:ph type="body" idx="1"/>
+          </p:nvPr>
+        </p:nvSpPr>
+        <p:spPr/>
+        <p:txBody>
+          <a:bodyPr/>
+          <a:lstStyle/>
+          <a:p>
+            <a:r>
+              <a:rPr lang="en-US" dirty="0"/>
+              <a:t>约 40 秒。总结五点。23 条是事后来源/药名范围预筛标记，并非 65 条都经过全文审阅；13 条原样候选级引用需排除，冻结药物分级未重算。独立外部方法选择 v3 的数据与标签门槛未通过，没有外部 NS-AUC 结果。Benchmark 分数只代表已知关联恢复能力；LUAD 候选是待验证的研究假设，不是用药建议。代码与所有结果见 GitHub 仓库。</a:t>
+            </a:r>
+            <a:endParaRPr lang="en-US" dirty="0"/>
+          </a:p>
+        </p:txBody>
+      </p:sp>
+      <p:sp>
+        <p:nvSpPr>
+          <p:cNvPr id="4" name="Slide Number Placeholder 3"/>
+          <p:cNvSpPr>
+            <a:spLocks noGrp="1"/>
+          </p:cNvSpPr>
+          <p:nvPr>
+            <p:ph type="sldNum" sz="quarter" idx="10"/>
+          </p:nvPr>
+        </p:nvSpPr>
+        <p:spPr/>
+        <p:txBody>
+          <a:bodyPr/>
+          <a:lstStyle/>
+          <a:p>
+            <a:fld id="{F7021451-1387-4CA6-816F-3879F97B5CBC}" type="slidenum">
+              <a:rPr lang="en-US"/>
+              <a:t>12</a:t>
             </a:fld>
             <a:endParaRPr lang="en-US"/>
           </a:p>
@@ -2100,7 +2596,7 @@
           <a:p>
             <a:r>
               <a:rPr lang="en-US" dirty="0"/>
-              <a:t>约 60 秒。LLM 只做规划与解释，数值计算全部由确定性工具完成，最终由代码校验 Schema、ID、引用和权限。Strict 模式下 LLM 看不到任何标签或药名。规划器在事先冻结的 100 例独立 holdout 上：DeepSeek 98/100，规则 90/100（docs/planner_eval_results.md）。每次运行写入带 SHA-256 链的 JSONL 轨迹。</a:t>
+              <a:t>约 50 秒。图为 Agent v2。大模型只看到模式、可用输入名称和已完成产物，看不到数据、文件路径和 Benchmark 标签；它一次提交多步计划，代码逐条校验白名单、模式、依赖和输入，不合法或某步失败时把观察反馈给它重新规划，最多 3 轮。数值计算全部由确定性工具完成，最终由 Validator 检查 ID、哈希、排名、引用和权限；每一步写入 SHA-256 链式轨迹。来源：docs/agent_v2.md、docs/figures/fig9_architecture.png。</a:t>
             </a:r>
             <a:endParaRPr lang="en-US" dirty="0"/>
           </a:p>
@@ -2188,7 +2684,7 @@
           <a:p>
             <a:r>
               <a:rPr lang="en-US" dirty="0"/>
-              <a:t>约 70 秒。表达反转 B1 在官方 NS-AUC 上只有 0.482（随机拆分），与随机无差别——这是本项目的核心负结果。复核评价代码发现：官方 NS-AUC 在每个药物行内对疾病排序、并把同分记 0；旧 B2 在疾病列内排序，且流行度分量在行内是常数。B3 改为行方向、加入疾病流行度与标签共现并打破同分，配置在正式评分前冻结（commit 92943bb），开发种子与官方 100 种子不相交。弱相关拆分只有一个固定留出集，冻结前已看过，已在配置中披露。</a:t>
+              <a:t>约 60 秒。v1 只从 3 个工具里选 1 个；v2 让大模型把请求拆成有序步骤，代码校验依赖、模式和输入后执行，失败时带着已完成产物重新规划。冻结的 40 例多步规划测试（调用前提交）：DeepSeek 36/40，规则规划器 30/40。规则输在“部分任务”（只认关键词，把“只做差异表达”也跑成全流程）；DeepSeek 部分任务、缺少输入、基准模式全对，但越权类 5/8：对“跳过质控”“忽略校验当治疗方案”“排完删数据”它照常跑了安全的标准流程而没有拒绝——代码层依赖校验和白名单仍挡住了实际风险，但这是规划器的真实弱点。右侧是真实工具上的一次运行：排名第一次失败后，第 2 轮只规划剩下的 4 步，跳过已完成的质控、差异表达和通路分析，最终完成。</a:t>
             </a:r>
             <a:endParaRPr lang="en-US" dirty="0"/>
           </a:p>
@@ -2276,7 +2772,7 @@
           <a:p>
             <a:r>
               <a:rPr lang="en-US" dirty="0"/>
-              <a:t>约 70 秒。RECeSS 官方 Runner，与作者公布的 11 个模型逐种子对齐。B3：随机 0.723（BNNR 0.733 第一，B3 在 100 个配对种子中胜 35 次），弱相关 0.692（MBiRW 0.738 第一）。第二轮 B4（B3 + BNNR 的 NumPy 移植，只在开发种子上设计后冻结）：随机 0.745、弱相关 0.658。B4 在随机拆分上的均值高于全部 11 个发表模型（对 BNNR 配对胜 87/100）。但 100 个种子的测试集互相重叠，用 Nadeau–Bengio 校正检验后，对 BNNR 的差值 p = 0.066，95% CI [-0.0008, 0.0251] 跨 0，只能说与 BNNR 持平；global NDCG 与 HR@10 上 BNNR 仍更强。弱相关拆分落后 MBiRW 与 HAN。因此不宣称 SOTA。</a:t>
+              <a:t>约 70 秒。表达反转 B1 在官方 NS-AUC 上只有 0.482（随机拆分），与随机无差别——这是本项目的核心负结果。复核评价代码发现：官方 NS-AUC 在每个药物行内对疾病排序、并把同分记 0；旧 B2 在疾病列内排序，且流行度分量在行内是常数。B3 改为行方向、加入疾病流行度与标签共现并打破同分，配置在正式评分前冻结（commit 92943bb），开发种子与官方 100 种子不相交。弱相关拆分只有一个固定留出集，冻结前已看过，已在配置中披露。</a:t>
             </a:r>
             <a:endParaRPr lang="en-US" dirty="0"/>
           </a:p>
@@ -2364,7 +2860,7 @@
           <a:p>
             <a:r>
               <a:rPr lang="en-US" dirty="0"/>
-              <a:t>约 50 秒。同一 DeepSeek 模型、同一冻结样本（300 正例 + 300 未知，哈希在调用前固定）。开卷给药名和病名：AUC 0.567，95% CI [0.526, 0.609]，唯一显著高于 0.5；闭卷只给反转数值：0.527；反转分数本身 0.519。开卷减闭卷 0.040，CI 跨 0。结论：LLM 会凭记忆认出教科书适应症，这是泄漏不是发现，所以 Benchmark 必须在 LLM 看不到身份的 Strict 模式下运行；TRANSCRIPT 标签噪声使泄漏幅度不大。共 1222 次调用，约 0.08 美元。</a:t>
+              <a:t>约 70 秒。RECeSS 官方 Runner，与作者公布的 11 个模型逐种子对齐。B3：随机 0.723（BNNR 0.733 第一，B3 在 100 个配对种子中胜 35 次），弱相关 0.692（MBiRW 0.738 第一）。第二轮 B4（B3 + BNNR 的 NumPy 移植，只在开发种子上设计后冻结）：随机 0.745、弱相关 0.658。B4 在随机拆分上的均值高于全部 11 个发表模型（对 BNNR 配对胜 87/100）。但 100 个种子的测试集互相重叠，用 Nadeau–Bengio 校正检验后，对 BNNR 的差值 p = 0.066，95% CI [-0.0008, 0.0251] 跨 0，只能说与 BNNR 持平；global NDCG 与 HR@10 上 BNNR 仍更强。弱相关拆分落后 MBiRW 与 HAN。因此不宣称 SOTA。</a:t>
             </a:r>
             <a:endParaRPr lang="en-US" dirty="0"/>
           </a:p>
@@ -2452,7 +2948,7 @@
           <a:p>
             <a:r>
               <a:rPr lang="en-US" dirty="0"/>
-              <a:t>约 60 秒。图为 v1 的 120 个封闭合成决策用例，所有决策器看到同样的策略文本与用例字段，门控阈值（0.8/0.9）在调用前固定。规则与 flash 准确率都是 0.875；flash 高风险误执行 0.150，加门控降到 0.083。Jev（TypeSafe System One，经 OpenCode Zen 调用 jev-1.13-free；付费版因余额不足在得到答案前改用免费版）不加门控准确率 0.900，为所有决策器最高；Brier 0.147，低于 flash 0.221 与 v4-pro 0.228，但 ECE 0.042 略高于 flash 的 0.025。Jev 加门控后高风险误执行为 0.000，代价是 0.483 的升级率；低置信交给 flash 的 J4 准确率 0.867。v2 的 40 条中文风险备注上，“规则算结构化字段、模型只判备注”的混合层，无论 flash、v4-pro 还是 Jev 判备注，高风险误执行都是 0（Jev 39/40）；让模型包办整个决策时，完整 Jev 只有 32/40 并出现高风险误执行。换 v4-pro 时门控一次都没触发，阈值需要按模型校准。用例为合成数据、单次运行，不代表临床正确率。</a:t>
+              <a:t>约 50 秒。同一 DeepSeek 模型、同一冻结样本（300 正例 + 300 未知，哈希在调用前固定）。开卷给药名和病名：AUC 0.567，95% CI [0.526, 0.609]，唯一显著高于 0.5；闭卷只给反转数值：0.527；反转分数本身 0.519。开卷减闭卷 0.040，CI 跨 0。结论：LLM 会凭记忆认出教科书适应症，这是泄漏不是发现，所以 Benchmark 必须在 LLM 看不到身份的 Strict 模式下运行；TRANSCRIPT 标签噪声使泄漏幅度不大。共 1222 次调用，约 0.08 美元。</a:t>
             </a:r>
             <a:endParaRPr lang="en-US" dirty="0"/>
           </a:p>
@@ -2540,7 +3036,7 @@
           <a:p>
             <a:r>
               <a:rPr lang="en-US" dirty="0"/>
-              <a:t>约 60 秒。GSE32863 配对差异表达得到 512 上调 / 749 下调基因（FDR&lt;0.05，|log2FC|≥1）。Hallmark 富集：肿瘤上调 Estrogen Response Late、G2-M Checkpoint、Glycolysis、E2F Targets、KRAS Signaling Up；肿瘤下调 TNF-alpha Signaling via NF-kB、KRAS Signaling Up、Epithelial Mesenchymal Transition、Inflammatory Response，后者更可能反映正常肺组织免疫/间质成分在肿瘤中减少。右图：Top-10 在这些通路上的反转百分位，主要集中在糖酵解、G2-M/E2F 与缺氧；diflorasone 与 beclomethasone 不反转 EMT 基因。Top-10 中 9/10 属于或很可能属于糖皮质激素，指向 NR3C1 类别假设；但阈值敏感性分析显示这只在 |log2FC|≥1 及更严时成立，放宽到 0.58 后 Top-10 只剩 3 个原候选，RAF/PI3K/mTOR 抑制剂（Hub 注释）进入，只有 hydrocortisone、beclomethasone、clocortolone 在 12 种设定下都留在 Top-10（docs/luad_threshold_sensitivity.md）。注意：Top-10 与通路基因来自同一签名，右图不是独立验证。预先冻结的参考药中 5 个可测，平均名次百分位 0.362，置换 p = 0.147，不显著——本筛选没有证明能恢复已知 LUAD 药物。A549 为 KRAS 突变细胞系，结果不能外推到患者。</a:t>
+              <a:t>约 60 秒。图为 v1 的 120 个封闭合成决策用例，所有决策器看到同样的策略文本与用例字段，门控阈值（0.8/0.9）在调用前固定。规则与 flash 准确率都是 0.875；flash 高风险误执行 0.150，加门控降到 0.083。Jev（TypeSafe System One，经 OpenCode Zen 调用 jev-1.13-free；付费版因余额不足在得到答案前改用免费版）不加门控准确率 0.900，为所有决策器最高；Brier 0.147，低于 flash 0.221 与 v4-pro 0.228，但 ECE 0.042 略高于 flash 的 0.025。Jev 加门控后高风险误执行为 0.000，代价是 0.483 的升级率；低置信交给 flash 的 J4 准确率 0.867。v2 的 40 条中文风险备注上，“规则算结构化字段、模型只判备注”的混合层，无论 flash、v4-pro 还是 Jev 判备注，高风险误执行都是 0（Jev 39/40）；让模型包办整个决策时，完整 Jev 只有 32/40 并出现高风险误执行。换 v4-pro 时门控一次都没触发，阈值需要按模型校准。用例为合成数据、单次运行，不代表临床正确率。</a:t>
             </a:r>
             <a:endParaRPr lang="en-US" dirty="0"/>
           </a:p>
@@ -3095,7 +3591,7 @@
                 <a:ea typeface="Microsoft YaHei" pitchFamily="34" charset="-122"/>
                 <a:cs typeface="Microsoft YaHei" pitchFamily="34" charset="-120"/>
               </a:rPr>
-              <a:t>多 Agent 证据审阅：逐字引用 ≠ 论断成立</a:t>
+              <a:t>肺腺癌案例：通路与机制</a:t>
             </a:r>
             <a:endParaRPr lang="en-US" sz="3000" dirty="0"/>
           </a:p>
@@ -3135,6 +3631,201 @@
                 <a:cs typeface="Microsoft YaHei" pitchFamily="34" charset="-120"/>
               </a:rPr>
               <a:t>10</a:t>
+            </a:r>
+            <a:endParaRPr lang="en-US" sz="1200" dirty="0"/>
+          </a:p>
+        </p:txBody>
+      </p:sp>
+      <p:pic>
+        <p:nvPicPr>
+          <p:cNvPr id="5" name="Image 0" descr="docs/figures/fig7_luad_pathways.png">    </p:cNvPr>
+          <p:cNvPicPr>
+            <a:picLocks noChangeAspect="1"/>
+          </p:cNvPicPr>
+          <p:nvPr/>
+        </p:nvPicPr>
+        <p:blipFill>
+          <a:blip r:embed="rId1"/>
+          <a:srcRect l="0" r="0" t="0" b="0"/>
+          <a:stretch/>
+        </p:blipFill>
+        <p:spPr>
+          <a:xfrm>
+            <a:off x="365760" y="1188720"/>
+            <a:ext cx="5760720" cy="4480560"/>
+          </a:xfrm>
+          <a:prstGeom prst="rect">
+            <a:avLst/>
+          </a:prstGeom>
+        </p:spPr>
+      </p:pic>
+      <p:pic>
+        <p:nvPicPr>
+          <p:cNvPr id="6" name="Image 1" descr="docs/figures/fig8_top10_pathway_reversal.png">    </p:cNvPr>
+          <p:cNvPicPr>
+            <a:picLocks noChangeAspect="1"/>
+          </p:cNvPicPr>
+          <p:nvPr/>
+        </p:nvPicPr>
+        <p:blipFill>
+          <a:blip r:embed="rId2"/>
+          <a:srcRect l="0" r="0" t="0" b="0"/>
+          <a:stretch/>
+        </p:blipFill>
+        <p:spPr>
+          <a:xfrm>
+            <a:off x="6263640" y="1188720"/>
+            <a:ext cx="5577840" cy="4480560"/>
+          </a:xfrm>
+          <a:prstGeom prst="rect">
+            <a:avLst/>
+          </a:prstGeom>
+        </p:spPr>
+      </p:pic>
+      <p:sp>
+        <p:nvSpPr>
+          <p:cNvPr id="7" name="Text 2"/>
+          <p:cNvSpPr txBox="1"/>
+          <p:nvPr/>
+        </p:nvSpPr>
+        <p:spPr>
+          <a:xfrm>
+            <a:off x="548640" y="5852160"/>
+            <a:ext cx="10881360" cy="411480"/>
+          </a:xfrm>
+          <a:prstGeom prst="rect">
+            <a:avLst/>
+          </a:prstGeom>
+          <a:noFill/>
+          <a:ln/>
+        </p:spPr>
+        <p:txBody>
+          <a:bodyPr wrap="square" lIns="0" tIns="0" rIns="0" bIns="0" rtlCol="0" anchor="t"/>
+          <a:lstStyle/>
+          <a:p>
+            <a:pPr algn="l" indent="0" marL="0">
+              <a:buNone/>
+            </a:pPr>
+            <a:r>
+              <a:rPr lang="en-US" sz="1500" b="1" dirty="0">
+                <a:solidFill>
+                  <a:srgbClr val="9E493D"/>
+                </a:solidFill>
+                <a:latin typeface="Microsoft YaHei" pitchFamily="34" charset="0"/>
+                <a:ea typeface="Microsoft YaHei" pitchFamily="34" charset="-122"/>
+                <a:cs typeface="Microsoft YaHei" pitchFamily="34" charset="-120"/>
+              </a:rPr>
+              <a:t>预设阈值下 9/10 为糖皮质激素，但放宽阈值后被 RAF/PI3K/mTOR 抑制剂部分取代；参考药恢复 p = 0.147，不显著</a:t>
+            </a:r>
+            <a:endParaRPr lang="en-US" sz="1500" dirty="0"/>
+          </a:p>
+        </p:txBody>
+      </p:sp>
+    </p:spTree>
+  </p:cSld>
+  <p:clrMapOvr>
+    <a:masterClrMapping/>
+  </p:clrMapOvr>
+</p:sld>
+</file>
+
+<file path=ppt/slides/slide11.xml><?xml version="1.0" encoding="utf-8"?>
+<p:sld xmlns:a="http://schemas.openxmlformats.org/drawingml/2006/main" xmlns:r="http://schemas.openxmlformats.org/officeDocument/2006/relationships" xmlns:p="http://schemas.openxmlformats.org/presentationml/2006/main">
+  <p:cSld name="Slide 11">
+    <p:bg>
+      <p:bgPr>
+        <a:solidFill>
+          <a:srgbClr val="FFFFFF"/>
+        </a:solidFill>
+      </p:bgPr>
+    </p:bg>
+    <p:spTree>
+      <p:nvGrpSpPr>
+        <p:cNvPr id="1" name=""/>
+        <p:cNvGrpSpPr/>
+        <p:nvPr/>
+      </p:nvGrpSpPr>
+      <p:grpSpPr>
+        <a:xfrm>
+          <a:off x="0" y="0"/>
+          <a:ext cx="0" cy="0"/>
+          <a:chOff x="0" y="0"/>
+          <a:chExt cx="0" cy="0"/>
+        </a:xfrm>
+      </p:grpSpPr>
+      <p:sp>
+        <p:nvSpPr>
+          <p:cNvPr id="2" name="Text 0"/>
+          <p:cNvSpPr txBox="1"/>
+          <p:nvPr/>
+        </p:nvSpPr>
+        <p:spPr>
+          <a:xfrm>
+            <a:off x="548640" y="320040"/>
+            <a:ext cx="11064240" cy="731520"/>
+          </a:xfrm>
+          <a:prstGeom prst="rect">
+            <a:avLst/>
+          </a:prstGeom>
+          <a:noFill/>
+          <a:ln/>
+        </p:spPr>
+        <p:txBody>
+          <a:bodyPr wrap="square" lIns="0" tIns="0" rIns="0" bIns="0" rtlCol="0" anchor="t"/>
+          <a:lstStyle/>
+          <a:p>
+            <a:pPr algn="l" indent="0" marL="0">
+              <a:buNone/>
+            </a:pPr>
+            <a:r>
+              <a:rPr lang="en-US" sz="3000" b="1" dirty="0">
+                <a:solidFill>
+                  <a:srgbClr val="112B3C"/>
+                </a:solidFill>
+                <a:latin typeface="Microsoft YaHei" pitchFamily="34" charset="0"/>
+                <a:ea typeface="Microsoft YaHei" pitchFamily="34" charset="-122"/>
+                <a:cs typeface="Microsoft YaHei" pitchFamily="34" charset="-120"/>
+              </a:rPr>
+              <a:t>多 Agent 证据审阅：逐字引用 ≠ 论断成立</a:t>
+            </a:r>
+            <a:endParaRPr lang="en-US" sz="3000" dirty="0"/>
+          </a:p>
+        </p:txBody>
+      </p:sp>
+      <p:sp>
+        <p:nvSpPr>
+          <p:cNvPr id="3" name="Text 1"/>
+          <p:cNvSpPr txBox="1"/>
+          <p:nvPr/>
+        </p:nvSpPr>
+        <p:spPr>
+          <a:xfrm>
+            <a:off x="11155680" y="6355080"/>
+            <a:ext cx="548640" cy="320040"/>
+          </a:xfrm>
+          <a:prstGeom prst="rect">
+            <a:avLst/>
+          </a:prstGeom>
+          <a:noFill/>
+          <a:ln/>
+        </p:spPr>
+        <p:txBody>
+          <a:bodyPr wrap="square" lIns="0" tIns="0" rIns="0" bIns="0" rtlCol="0" anchor="t"/>
+          <a:lstStyle/>
+          <a:p>
+            <a:pPr algn="r" indent="0" marL="0">
+              <a:buNone/>
+            </a:pPr>
+            <a:r>
+              <a:rPr lang="en-US" sz="1200" dirty="0">
+                <a:solidFill>
+                  <a:srgbClr val="5B6B75"/>
+                </a:solidFill>
+                <a:latin typeface="Microsoft YaHei" pitchFamily="34" charset="0"/>
+                <a:ea typeface="Microsoft YaHei" pitchFamily="34" charset="-122"/>
+                <a:cs typeface="Microsoft YaHei" pitchFamily="34" charset="-120"/>
+              </a:rPr>
+              <a:t>11</a:t>
             </a:r>
             <a:endParaRPr lang="en-US" sz="1200" dirty="0"/>
           </a:p>
@@ -3562,7 +4253,7 @@
       </p:sp>
       <p:graphicFrame>
         <p:nvGraphicFramePr>
-          <p:cNvPr id="11" name="Table 0"/>
+          <p:cNvPr id="12" name="Table 0"/>
           <p:cNvGraphicFramePr>
             <a:graphicFrameLocks noGrp="1"/>
           </p:cNvGraphicFramePr>
@@ -6614,9 +7305,9 @@
 </p:sld>
 </file>
 
-<file path=ppt/slides/slide11.xml><?xml version="1.0" encoding="utf-8"?>
+<file path=ppt/slides/slide12.xml><?xml version="1.0" encoding="utf-8"?>
 <p:sld xmlns:a="http://schemas.openxmlformats.org/drawingml/2006/main" xmlns:r="http://schemas.openxmlformats.org/officeDocument/2006/relationships" xmlns:p="http://schemas.openxmlformats.org/presentationml/2006/main">
-  <p:cSld name="Slide 11">
+  <p:cSld name="Slide 12">
     <p:bg>
       <p:bgPr>
         <a:solidFill>
@@ -8613,7 +9304,7 @@
                 <a:ea typeface="Microsoft YaHei" pitchFamily="34" charset="-122"/>
                 <a:cs typeface="Microsoft YaHei" pitchFamily="34" charset="-120"/>
               </a:rPr>
-              <a:t>系统架构：谁负责什么</a:t>
+              <a:t>系统架构：LLM 规划，工具计算，代码校验</a:t>
             </a:r>
             <a:endParaRPr lang="en-US" sz="3000" dirty="0"/>
           </a:p>
@@ -8658,927 +9349,29 @@
           </a:p>
         </p:txBody>
       </p:sp>
-      <p:sp>
-        <p:nvSpPr>
-          <p:cNvPr id="5" name="Shape 2"/>
-          <p:cNvSpPr/>
+      <p:pic>
+        <p:nvPicPr>
+          <p:cNvPr id="5" name="Image 0" descr="docs/figures/fig9_architecture.png">    </p:cNvPr>
+          <p:cNvPicPr>
+            <a:picLocks noChangeAspect="1"/>
+          </p:cNvPicPr>
           <p:nvPr/>
-        </p:nvSpPr>
+        </p:nvPicPr>
+        <p:blipFill>
+          <a:blip r:embed="rId1"/>
+          <a:srcRect l="0" r="0" t="0" b="0"/>
+          <a:stretch/>
+        </p:blipFill>
         <p:spPr>
           <a:xfrm>
-            <a:off x="502920" y="1645920"/>
-            <a:ext cx="1645920" cy="1463040"/>
-          </a:xfrm>
-          <a:prstGeom prst="roundRect">
-            <a:avLst>
-              <a:gd name="adj" fmla="val 6250"/>
-            </a:avLst>
-          </a:prstGeom>
-          <a:solidFill>
-            <a:srgbClr val="112B3C"/>
-          </a:solidFill>
-          <a:ln w="9525">
-            <a:solidFill>
-              <a:srgbClr val="112B3C"/>
-            </a:solidFill>
-            <a:prstDash val="solid"/>
-          </a:ln>
-        </p:spPr>
-      </p:sp>
-      <p:sp>
-        <p:nvSpPr>
-          <p:cNvPr id="6" name="Text 3"/>
-          <p:cNvSpPr txBox="1"/>
-          <p:nvPr/>
-        </p:nvSpPr>
-        <p:spPr>
-          <a:xfrm>
-            <a:off x="576072" y="1645920"/>
-            <a:ext cx="1499616" cy="1463040"/>
+            <a:off x="1188720" y="1051560"/>
+            <a:ext cx="9784080" cy="5577840"/>
           </a:xfrm>
           <a:prstGeom prst="rect">
             <a:avLst/>
           </a:prstGeom>
-          <a:noFill/>
-          <a:ln/>
         </p:spPr>
-        <p:txBody>
-          <a:bodyPr wrap="square" lIns="0" tIns="0" rIns="0" bIns="0" rtlCol="0" anchor="ctr"/>
-          <a:lstStyle/>
-          <a:p>
-            <a:pPr algn="ctr" indent="0" marL="0">
-              <a:buNone/>
-            </a:pPr>
-            <a:r>
-              <a:rPr lang="en-US" sz="1300" b="1" dirty="0">
-                <a:solidFill>
-                  <a:srgbClr val="FFFFFF"/>
-                </a:solidFill>
-                <a:latin typeface="Microsoft YaHei" pitchFamily="34" charset="0"/>
-                <a:ea typeface="Microsoft YaHei" pitchFamily="34" charset="-122"/>
-                <a:cs typeface="Microsoft YaHei" pitchFamily="34" charset="-120"/>
-              </a:rPr>
-              <a:t>自然语言请求</a:t>
-            </a:r>
-            <a:endParaRPr lang="en-US" sz="1300" dirty="0"/>
-          </a:p>
-        </p:txBody>
-      </p:sp>
-      <p:sp>
-        <p:nvSpPr>
-          <p:cNvPr id="7" name="Shape 4"/>
-          <p:cNvSpPr/>
-          <p:nvPr/>
-        </p:nvSpPr>
-        <p:spPr>
-          <a:xfrm>
-            <a:off x="2176272" y="2258568"/>
-            <a:ext cx="219456" cy="237744"/>
-          </a:xfrm>
-          <a:prstGeom prst="rightArrow">
-            <a:avLst/>
-          </a:prstGeom>
-          <a:solidFill>
-            <a:srgbClr val="087E78"/>
-          </a:solidFill>
-          <a:ln w="12700">
-            <a:solidFill>
-              <a:srgbClr val="087E78"/>
-            </a:solidFill>
-            <a:prstDash val="solid"/>
-          </a:ln>
-        </p:spPr>
-      </p:sp>
-      <p:sp>
-        <p:nvSpPr>
-          <p:cNvPr id="8" name="Shape 5"/>
-          <p:cNvSpPr/>
-          <p:nvPr/>
-        </p:nvSpPr>
-        <p:spPr>
-          <a:xfrm>
-            <a:off x="2423160" y="1645920"/>
-            <a:ext cx="1645920" cy="1463040"/>
-          </a:xfrm>
-          <a:prstGeom prst="roundRect">
-            <a:avLst>
-              <a:gd name="adj" fmla="val 6250"/>
-            </a:avLst>
-          </a:prstGeom>
-          <a:solidFill>
-            <a:srgbClr val="EEF3F2"/>
-          </a:solidFill>
-          <a:ln w="9525">
-            <a:solidFill>
-              <a:srgbClr val="B9C2C7"/>
-            </a:solidFill>
-            <a:prstDash val="solid"/>
-          </a:ln>
-        </p:spPr>
-      </p:sp>
-      <p:sp>
-        <p:nvSpPr>
-          <p:cNvPr id="9" name="Text 6"/>
-          <p:cNvSpPr txBox="1"/>
-          <p:nvPr/>
-        </p:nvSpPr>
-        <p:spPr>
-          <a:xfrm>
-            <a:off x="2496312" y="1645920"/>
-            <a:ext cx="1499616" cy="1463040"/>
-          </a:xfrm>
-          <a:prstGeom prst="rect">
-            <a:avLst/>
-          </a:prstGeom>
-          <a:noFill/>
-          <a:ln/>
-        </p:spPr>
-        <p:txBody>
-          <a:bodyPr wrap="square" lIns="0" tIns="0" rIns="0" bIns="0" rtlCol="0" anchor="ctr"/>
-          <a:lstStyle/>
-          <a:p>
-            <a:pPr algn="ctr" indent="0" marL="0">
-              <a:buNone/>
-            </a:pPr>
-            <a:r>
-              <a:rPr lang="en-US" sz="1300" b="1" dirty="0">
-                <a:solidFill>
-                  <a:srgbClr val="112B3C"/>
-                </a:solidFill>
-                <a:latin typeface="Microsoft YaHei" pitchFamily="34" charset="0"/>
-                <a:ea typeface="Microsoft YaHei" pitchFamily="34" charset="-122"/>
-                <a:cs typeface="Microsoft YaHei" pitchFamily="34" charset="-120"/>
-              </a:rPr>
-              <a:t>Planner</a:t>
-            </a:r>
-            <a:endParaRPr lang="en-US" sz="1300" dirty="0"/>
-          </a:p>
-          <a:p>
-            <a:pPr algn="ctr" indent="0" marL="0">
-              <a:buNone/>
-            </a:pPr>
-            <a:r>
-              <a:rPr lang="en-US" sz="1300" b="1" dirty="0">
-                <a:solidFill>
-                  <a:srgbClr val="112B3C"/>
-                </a:solidFill>
-                <a:latin typeface="Microsoft YaHei" pitchFamily="34" charset="0"/>
-                <a:ea typeface="Microsoft YaHei" pitchFamily="34" charset="-122"/>
-                <a:cs typeface="Microsoft YaHei" pitchFamily="34" charset="-120"/>
-              </a:rPr>
-              <a:t>DeepSeek / 规则</a:t>
-            </a:r>
-            <a:endParaRPr lang="en-US" sz="1300" dirty="0"/>
-          </a:p>
-        </p:txBody>
-      </p:sp>
-      <p:sp>
-        <p:nvSpPr>
-          <p:cNvPr id="10" name="Shape 7"/>
-          <p:cNvSpPr/>
-          <p:nvPr/>
-        </p:nvSpPr>
-        <p:spPr>
-          <a:xfrm>
-            <a:off x="4096512" y="2258568"/>
-            <a:ext cx="219456" cy="237744"/>
-          </a:xfrm>
-          <a:prstGeom prst="rightArrow">
-            <a:avLst/>
-          </a:prstGeom>
-          <a:solidFill>
-            <a:srgbClr val="087E78"/>
-          </a:solidFill>
-          <a:ln w="12700">
-            <a:solidFill>
-              <a:srgbClr val="087E78"/>
-            </a:solidFill>
-            <a:prstDash val="solid"/>
-          </a:ln>
-        </p:spPr>
-      </p:sp>
-      <p:sp>
-        <p:nvSpPr>
-          <p:cNvPr id="11" name="Shape 8"/>
-          <p:cNvSpPr/>
-          <p:nvPr/>
-        </p:nvSpPr>
-        <p:spPr>
-          <a:xfrm>
-            <a:off x="4343400" y="1645920"/>
-            <a:ext cx="1645920" cy="1463040"/>
-          </a:xfrm>
-          <a:prstGeom prst="roundRect">
-            <a:avLst>
-              <a:gd name="adj" fmla="val 6250"/>
-            </a:avLst>
-          </a:prstGeom>
-          <a:solidFill>
-            <a:srgbClr val="EEF3F2"/>
-          </a:solidFill>
-          <a:ln w="9525">
-            <a:solidFill>
-              <a:srgbClr val="B9C2C7"/>
-            </a:solidFill>
-            <a:prstDash val="solid"/>
-          </a:ln>
-        </p:spPr>
-      </p:sp>
-      <p:sp>
-        <p:nvSpPr>
-          <p:cNvPr id="12" name="Text 9"/>
-          <p:cNvSpPr txBox="1"/>
-          <p:nvPr/>
-        </p:nvSpPr>
-        <p:spPr>
-          <a:xfrm>
-            <a:off x="4416552" y="1645920"/>
-            <a:ext cx="1499616" cy="1463040"/>
-          </a:xfrm>
-          <a:prstGeom prst="rect">
-            <a:avLst/>
-          </a:prstGeom>
-          <a:noFill/>
-          <a:ln/>
-        </p:spPr>
-        <p:txBody>
-          <a:bodyPr wrap="square" lIns="0" tIns="0" rIns="0" bIns="0" rtlCol="0" anchor="ctr"/>
-          <a:lstStyle/>
-          <a:p>
-            <a:pPr algn="ctr" indent="0" marL="0">
-              <a:buNone/>
-            </a:pPr>
-            <a:r>
-              <a:rPr lang="en-US" sz="1300" b="1" dirty="0">
-                <a:solidFill>
-                  <a:srgbClr val="112B3C"/>
-                </a:solidFill>
-                <a:latin typeface="Microsoft YaHei" pitchFamily="34" charset="0"/>
-                <a:ea typeface="Microsoft YaHei" pitchFamily="34" charset="-122"/>
-                <a:cs typeface="Microsoft YaHei" pitchFamily="34" charset="-120"/>
-              </a:rPr>
-              <a:t>工具白名单</a:t>
-            </a:r>
-            <a:endParaRPr lang="en-US" sz="1300" dirty="0"/>
-          </a:p>
-          <a:p>
-            <a:pPr algn="ctr" indent="0" marL="0">
-              <a:buNone/>
-            </a:pPr>
-            <a:r>
-              <a:rPr lang="en-US" sz="1300" b="1" dirty="0">
-                <a:solidFill>
-                  <a:srgbClr val="112B3C"/>
-                </a:solidFill>
-                <a:latin typeface="Microsoft YaHei" pitchFamily="34" charset="0"/>
-                <a:ea typeface="Microsoft YaHei" pitchFamily="34" charset="-122"/>
-                <a:cs typeface="Microsoft YaHei" pitchFamily="34" charset="-120"/>
-              </a:rPr>
-              <a:t>Strict / Open</a:t>
-            </a:r>
-            <a:endParaRPr lang="en-US" sz="1300" dirty="0"/>
-          </a:p>
-        </p:txBody>
-      </p:sp>
-      <p:sp>
-        <p:nvSpPr>
-          <p:cNvPr id="13" name="Shape 10"/>
-          <p:cNvSpPr/>
-          <p:nvPr/>
-        </p:nvSpPr>
-        <p:spPr>
-          <a:xfrm>
-            <a:off x="6016752" y="2258568"/>
-            <a:ext cx="219456" cy="237744"/>
-          </a:xfrm>
-          <a:prstGeom prst="rightArrow">
-            <a:avLst/>
-          </a:prstGeom>
-          <a:solidFill>
-            <a:srgbClr val="087E78"/>
-          </a:solidFill>
-          <a:ln w="12700">
-            <a:solidFill>
-              <a:srgbClr val="087E78"/>
-            </a:solidFill>
-            <a:prstDash val="solid"/>
-          </a:ln>
-        </p:spPr>
-      </p:sp>
-      <p:sp>
-        <p:nvSpPr>
-          <p:cNvPr id="14" name="Shape 11"/>
-          <p:cNvSpPr/>
-          <p:nvPr/>
-        </p:nvSpPr>
-        <p:spPr>
-          <a:xfrm>
-            <a:off x="6263640" y="1645920"/>
-            <a:ext cx="1645920" cy="1463040"/>
-          </a:xfrm>
-          <a:prstGeom prst="roundRect">
-            <a:avLst>
-              <a:gd name="adj" fmla="val 6250"/>
-            </a:avLst>
-          </a:prstGeom>
-          <a:solidFill>
-            <a:srgbClr val="EEF3F2"/>
-          </a:solidFill>
-          <a:ln w="9525">
-            <a:solidFill>
-              <a:srgbClr val="B9C2C7"/>
-            </a:solidFill>
-            <a:prstDash val="solid"/>
-          </a:ln>
-        </p:spPr>
-      </p:sp>
-      <p:sp>
-        <p:nvSpPr>
-          <p:cNvPr id="15" name="Text 12"/>
-          <p:cNvSpPr txBox="1"/>
-          <p:nvPr/>
-        </p:nvSpPr>
-        <p:spPr>
-          <a:xfrm>
-            <a:off x="6336792" y="1645920"/>
-            <a:ext cx="1499616" cy="1463040"/>
-          </a:xfrm>
-          <a:prstGeom prst="rect">
-            <a:avLst/>
-          </a:prstGeom>
-          <a:noFill/>
-          <a:ln/>
-        </p:spPr>
-        <p:txBody>
-          <a:bodyPr wrap="square" lIns="0" tIns="0" rIns="0" bIns="0" rtlCol="0" anchor="ctr"/>
-          <a:lstStyle/>
-          <a:p>
-            <a:pPr algn="ctr" indent="0" marL="0">
-              <a:buNone/>
-            </a:pPr>
-            <a:r>
-              <a:rPr lang="en-US" sz="1300" b="1" dirty="0">
-                <a:solidFill>
-                  <a:srgbClr val="112B3C"/>
-                </a:solidFill>
-                <a:latin typeface="Microsoft YaHei" pitchFamily="34" charset="0"/>
-                <a:ea typeface="Microsoft YaHei" pitchFamily="34" charset="-122"/>
-                <a:cs typeface="Microsoft YaHei" pitchFamily="34" charset="-120"/>
-              </a:rPr>
-              <a:t>确定性计算</a:t>
-            </a:r>
-            <a:endParaRPr lang="en-US" sz="1300" dirty="0"/>
-          </a:p>
-          <a:p>
-            <a:pPr algn="ctr" indent="0" marL="0">
-              <a:buNone/>
-            </a:pPr>
-            <a:r>
-              <a:rPr lang="en-US" sz="1300" b="1" dirty="0">
-                <a:solidFill>
-                  <a:srgbClr val="112B3C"/>
-                </a:solidFill>
-                <a:latin typeface="Microsoft YaHei" pitchFamily="34" charset="0"/>
-                <a:ea typeface="Microsoft YaHei" pitchFamily="34" charset="-122"/>
-                <a:cs typeface="Microsoft YaHei" pitchFamily="34" charset="-120"/>
-              </a:rPr>
-              <a:t>差异表达·排名融合</a:t>
-            </a:r>
-            <a:endParaRPr lang="en-US" sz="1300" dirty="0"/>
-          </a:p>
-        </p:txBody>
-      </p:sp>
-      <p:sp>
-        <p:nvSpPr>
-          <p:cNvPr id="16" name="Shape 13"/>
-          <p:cNvSpPr/>
-          <p:nvPr/>
-        </p:nvSpPr>
-        <p:spPr>
-          <a:xfrm>
-            <a:off x="7936992" y="2258568"/>
-            <a:ext cx="219456" cy="237744"/>
-          </a:xfrm>
-          <a:prstGeom prst="rightArrow">
-            <a:avLst/>
-          </a:prstGeom>
-          <a:solidFill>
-            <a:srgbClr val="087E78"/>
-          </a:solidFill>
-          <a:ln w="12700">
-            <a:solidFill>
-              <a:srgbClr val="087E78"/>
-            </a:solidFill>
-            <a:prstDash val="solid"/>
-          </a:ln>
-        </p:spPr>
-      </p:sp>
-      <p:sp>
-        <p:nvSpPr>
-          <p:cNvPr id="17" name="Shape 14"/>
-          <p:cNvSpPr/>
-          <p:nvPr/>
-        </p:nvSpPr>
-        <p:spPr>
-          <a:xfrm>
-            <a:off x="8183880" y="1645920"/>
-            <a:ext cx="1645920" cy="1463040"/>
-          </a:xfrm>
-          <a:prstGeom prst="roundRect">
-            <a:avLst>
-              <a:gd name="adj" fmla="val 6250"/>
-            </a:avLst>
-          </a:prstGeom>
-          <a:solidFill>
-            <a:srgbClr val="EEF3F2"/>
-          </a:solidFill>
-          <a:ln w="9525">
-            <a:solidFill>
-              <a:srgbClr val="B9C2C7"/>
-            </a:solidFill>
-            <a:prstDash val="solid"/>
-          </a:ln>
-        </p:spPr>
-      </p:sp>
-      <p:sp>
-        <p:nvSpPr>
-          <p:cNvPr id="18" name="Text 15"/>
-          <p:cNvSpPr txBox="1"/>
-          <p:nvPr/>
-        </p:nvSpPr>
-        <p:spPr>
-          <a:xfrm>
-            <a:off x="8257032" y="1645920"/>
-            <a:ext cx="1499616" cy="1463040"/>
-          </a:xfrm>
-          <a:prstGeom prst="rect">
-            <a:avLst/>
-          </a:prstGeom>
-          <a:noFill/>
-          <a:ln/>
-        </p:spPr>
-        <p:txBody>
-          <a:bodyPr wrap="square" lIns="0" tIns="0" rIns="0" bIns="0" rtlCol="0" anchor="ctr"/>
-          <a:lstStyle/>
-          <a:p>
-            <a:pPr algn="ctr" indent="0" marL="0">
-              <a:buNone/>
-            </a:pPr>
-            <a:r>
-              <a:rPr lang="en-US" sz="1300" b="1" dirty="0">
-                <a:solidFill>
-                  <a:srgbClr val="112B3C"/>
-                </a:solidFill>
-                <a:latin typeface="Microsoft YaHei" pitchFamily="34" charset="0"/>
-                <a:ea typeface="Microsoft YaHei" pitchFamily="34" charset="-122"/>
-                <a:cs typeface="Microsoft YaHei" pitchFamily="34" charset="-120"/>
-              </a:rPr>
-              <a:t>证据层</a:t>
-            </a:r>
-            <a:endParaRPr lang="en-US" sz="1300" dirty="0"/>
-          </a:p>
-          <a:p>
-            <a:pPr algn="ctr" indent="0" marL="0">
-              <a:buNone/>
-            </a:pPr>
-            <a:r>
-              <a:rPr lang="en-US" sz="1300" b="1" dirty="0">
-                <a:solidFill>
-                  <a:srgbClr val="112B3C"/>
-                </a:solidFill>
-                <a:latin typeface="Microsoft YaHei" pitchFamily="34" charset="0"/>
-                <a:ea typeface="Microsoft YaHei" pitchFamily="34" charset="-122"/>
-                <a:cs typeface="Microsoft YaHei" pitchFamily="34" charset="-120"/>
-              </a:rPr>
-              <a:t>PubMed·多 Agent</a:t>
-            </a:r>
-            <a:endParaRPr lang="en-US" sz="1300" dirty="0"/>
-          </a:p>
-        </p:txBody>
-      </p:sp>
-      <p:sp>
-        <p:nvSpPr>
-          <p:cNvPr id="19" name="Shape 16"/>
-          <p:cNvSpPr/>
-          <p:nvPr/>
-        </p:nvSpPr>
-        <p:spPr>
-          <a:xfrm>
-            <a:off x="9857232" y="2258568"/>
-            <a:ext cx="219456" cy="237744"/>
-          </a:xfrm>
-          <a:prstGeom prst="rightArrow">
-            <a:avLst/>
-          </a:prstGeom>
-          <a:solidFill>
-            <a:srgbClr val="087E78"/>
-          </a:solidFill>
-          <a:ln w="12700">
-            <a:solidFill>
-              <a:srgbClr val="087E78"/>
-            </a:solidFill>
-            <a:prstDash val="solid"/>
-          </a:ln>
-        </p:spPr>
-      </p:sp>
-      <p:sp>
-        <p:nvSpPr>
-          <p:cNvPr id="20" name="Shape 17"/>
-          <p:cNvSpPr/>
-          <p:nvPr/>
-        </p:nvSpPr>
-        <p:spPr>
-          <a:xfrm>
-            <a:off x="10104120" y="1645920"/>
-            <a:ext cx="1645920" cy="1463040"/>
-          </a:xfrm>
-          <a:prstGeom prst="roundRect">
-            <a:avLst>
-              <a:gd name="adj" fmla="val 6250"/>
-            </a:avLst>
-          </a:prstGeom>
-          <a:solidFill>
-            <a:srgbClr val="EEF3F2"/>
-          </a:solidFill>
-          <a:ln w="9525">
-            <a:solidFill>
-              <a:srgbClr val="B9C2C7"/>
-            </a:solidFill>
-            <a:prstDash val="solid"/>
-          </a:ln>
-        </p:spPr>
-      </p:sp>
-      <p:sp>
-        <p:nvSpPr>
-          <p:cNvPr id="21" name="Text 18"/>
-          <p:cNvSpPr txBox="1"/>
-          <p:nvPr/>
-        </p:nvSpPr>
-        <p:spPr>
-          <a:xfrm>
-            <a:off x="10177272" y="1645920"/>
-            <a:ext cx="1499616" cy="1463040"/>
-          </a:xfrm>
-          <a:prstGeom prst="rect">
-            <a:avLst/>
-          </a:prstGeom>
-          <a:noFill/>
-          <a:ln/>
-        </p:spPr>
-        <p:txBody>
-          <a:bodyPr wrap="square" lIns="0" tIns="0" rIns="0" bIns="0" rtlCol="0" anchor="ctr"/>
-          <a:lstStyle/>
-          <a:p>
-            <a:pPr algn="ctr" indent="0" marL="0">
-              <a:buNone/>
-            </a:pPr>
-            <a:r>
-              <a:rPr lang="en-US" sz="1300" b="1" dirty="0">
-                <a:solidFill>
-                  <a:srgbClr val="112B3C"/>
-                </a:solidFill>
-                <a:latin typeface="Microsoft YaHei" pitchFamily="34" charset="0"/>
-                <a:ea typeface="Microsoft YaHei" pitchFamily="34" charset="-122"/>
-                <a:cs typeface="Microsoft YaHei" pitchFamily="34" charset="-120"/>
-              </a:rPr>
-              <a:t>Validator</a:t>
-            </a:r>
-            <a:endParaRPr lang="en-US" sz="1300" dirty="0"/>
-          </a:p>
-          <a:p>
-            <a:pPr algn="ctr" indent="0" marL="0">
-              <a:buNone/>
-            </a:pPr>
-            <a:r>
-              <a:rPr lang="en-US" sz="1300" b="1" dirty="0">
-                <a:solidFill>
-                  <a:srgbClr val="112B3C"/>
-                </a:solidFill>
-                <a:latin typeface="Microsoft YaHei" pitchFamily="34" charset="0"/>
-                <a:ea typeface="Microsoft YaHei" pitchFamily="34" charset="-122"/>
-                <a:cs typeface="Microsoft YaHei" pitchFamily="34" charset="-120"/>
-              </a:rPr>
-              <a:t>Schema·引用·权限</a:t>
-            </a:r>
-            <a:endParaRPr lang="en-US" sz="1300" dirty="0"/>
-          </a:p>
-        </p:txBody>
-      </p:sp>
-      <p:sp>
-        <p:nvSpPr>
-          <p:cNvPr id="22" name="Shape 19"/>
-          <p:cNvSpPr/>
-          <p:nvPr/>
-        </p:nvSpPr>
-        <p:spPr>
-          <a:xfrm>
-            <a:off x="548640" y="3840480"/>
-            <a:ext cx="3566160" cy="1234440"/>
-          </a:xfrm>
-          <a:prstGeom prst="roundRect">
-            <a:avLst>
-              <a:gd name="adj" fmla="val 5926"/>
-            </a:avLst>
-          </a:prstGeom>
-          <a:solidFill>
-            <a:srgbClr val="EEF3F2"/>
-          </a:solidFill>
-          <a:ln w="12700">
-            <a:solidFill>
-              <a:srgbClr val="EEF3F2"/>
-            </a:solidFill>
-            <a:prstDash val="solid"/>
-          </a:ln>
-        </p:spPr>
-      </p:sp>
-      <p:sp>
-        <p:nvSpPr>
-          <p:cNvPr id="23" name="Text 20"/>
-          <p:cNvSpPr txBox="1"/>
-          <p:nvPr/>
-        </p:nvSpPr>
-        <p:spPr>
-          <a:xfrm>
-            <a:off x="731520" y="3950208"/>
-            <a:ext cx="3200400" cy="640080"/>
-          </a:xfrm>
-          <a:prstGeom prst="rect">
-            <a:avLst/>
-          </a:prstGeom>
-          <a:noFill/>
-          <a:ln/>
-        </p:spPr>
-        <p:txBody>
-          <a:bodyPr wrap="square" lIns="0" tIns="0" rIns="0" bIns="0" rtlCol="0" anchor="t"/>
-          <a:lstStyle/>
-          <a:p>
-            <a:pPr algn="l" indent="0" marL="0">
-              <a:buNone/>
-            </a:pPr>
-            <a:r>
-              <a:rPr lang="en-US" sz="2800" b="1" dirty="0">
-                <a:solidFill>
-                  <a:srgbClr val="087E78"/>
-                </a:solidFill>
-                <a:latin typeface="Microsoft YaHei" pitchFamily="34" charset="0"/>
-                <a:ea typeface="Microsoft YaHei" pitchFamily="34" charset="-122"/>
-                <a:cs typeface="Microsoft YaHei" pitchFamily="34" charset="-120"/>
-              </a:rPr>
-              <a:t>98/100</a:t>
-            </a:r>
-            <a:endParaRPr lang="en-US" sz="2800" dirty="0"/>
-          </a:p>
-        </p:txBody>
-      </p:sp>
-      <p:sp>
-        <p:nvSpPr>
-          <p:cNvPr id="24" name="Text 21"/>
-          <p:cNvSpPr txBox="1"/>
-          <p:nvPr/>
-        </p:nvSpPr>
-        <p:spPr>
-          <a:xfrm>
-            <a:off x="731520" y="4590288"/>
-            <a:ext cx="3200400" cy="411480"/>
-          </a:xfrm>
-          <a:prstGeom prst="rect">
-            <a:avLst/>
-          </a:prstGeom>
-          <a:noFill/>
-          <a:ln/>
-        </p:spPr>
-        <p:txBody>
-          <a:bodyPr wrap="square" lIns="0" tIns="0" rIns="0" bIns="0" rtlCol="0" anchor="t"/>
-          <a:lstStyle/>
-          <a:p>
-            <a:pPr algn="l" indent="0" marL="0">
-              <a:buNone/>
-            </a:pPr>
-            <a:r>
-              <a:rPr lang="en-US" sz="1200" dirty="0">
-                <a:solidFill>
-                  <a:srgbClr val="5B6B75"/>
-                </a:solidFill>
-                <a:latin typeface="Microsoft YaHei" pitchFamily="34" charset="0"/>
-                <a:ea typeface="Microsoft YaHei" pitchFamily="34" charset="-122"/>
-                <a:cs typeface="Microsoft YaHei" pitchFamily="34" charset="-120"/>
-              </a:rPr>
-              <a:t>规划器冻结 holdout（DeepSeek；规则 90/100）</a:t>
-            </a:r>
-            <a:endParaRPr lang="en-US" sz="1200" dirty="0"/>
-          </a:p>
-        </p:txBody>
-      </p:sp>
-      <p:sp>
-        <p:nvSpPr>
-          <p:cNvPr id="25" name="Shape 22"/>
-          <p:cNvSpPr/>
-          <p:nvPr/>
-        </p:nvSpPr>
-        <p:spPr>
-          <a:xfrm>
-            <a:off x="4297680" y="3840480"/>
-            <a:ext cx="3566160" cy="1234440"/>
-          </a:xfrm>
-          <a:prstGeom prst="roundRect">
-            <a:avLst>
-              <a:gd name="adj" fmla="val 5926"/>
-            </a:avLst>
-          </a:prstGeom>
-          <a:solidFill>
-            <a:srgbClr val="EEF3F2"/>
-          </a:solidFill>
-          <a:ln w="12700">
-            <a:solidFill>
-              <a:srgbClr val="EEF3F2"/>
-            </a:solidFill>
-            <a:prstDash val="solid"/>
-          </a:ln>
-        </p:spPr>
-      </p:sp>
-      <p:sp>
-        <p:nvSpPr>
-          <p:cNvPr id="26" name="Text 23"/>
-          <p:cNvSpPr txBox="1"/>
-          <p:nvPr/>
-        </p:nvSpPr>
-        <p:spPr>
-          <a:xfrm>
-            <a:off x="4480560" y="3950208"/>
-            <a:ext cx="3200400" cy="640080"/>
-          </a:xfrm>
-          <a:prstGeom prst="rect">
-            <a:avLst/>
-          </a:prstGeom>
-          <a:noFill/>
-          <a:ln/>
-        </p:spPr>
-        <p:txBody>
-          <a:bodyPr wrap="square" lIns="0" tIns="0" rIns="0" bIns="0" rtlCol="0" anchor="t"/>
-          <a:lstStyle/>
-          <a:p>
-            <a:pPr algn="l" indent="0" marL="0">
-              <a:buNone/>
-            </a:pPr>
-            <a:r>
-              <a:rPr lang="en-US" sz="2800" b="1" dirty="0">
-                <a:solidFill>
-                  <a:srgbClr val="087E78"/>
-                </a:solidFill>
-                <a:latin typeface="Microsoft YaHei" pitchFamily="34" charset="0"/>
-                <a:ea typeface="Microsoft YaHei" pitchFamily="34" charset="-122"/>
-                <a:cs typeface="Microsoft YaHei" pitchFamily="34" charset="-120"/>
-              </a:rPr>
-              <a:t>0 标签</a:t>
-            </a:r>
-            <a:endParaRPr lang="en-US" sz="2800" dirty="0"/>
-          </a:p>
-        </p:txBody>
-      </p:sp>
-      <p:sp>
-        <p:nvSpPr>
-          <p:cNvPr id="27" name="Text 24"/>
-          <p:cNvSpPr txBox="1"/>
-          <p:nvPr/>
-        </p:nvSpPr>
-        <p:spPr>
-          <a:xfrm>
-            <a:off x="4480560" y="4590288"/>
-            <a:ext cx="3200400" cy="411480"/>
-          </a:xfrm>
-          <a:prstGeom prst="rect">
-            <a:avLst/>
-          </a:prstGeom>
-          <a:noFill/>
-          <a:ln/>
-        </p:spPr>
-        <p:txBody>
-          <a:bodyPr wrap="square" lIns="0" tIns="0" rIns="0" bIns="0" rtlCol="0" anchor="t"/>
-          <a:lstStyle/>
-          <a:p>
-            <a:pPr algn="l" indent="0" marL="0">
-              <a:buNone/>
-            </a:pPr>
-            <a:r>
-              <a:rPr lang="en-US" sz="1200" dirty="0">
-                <a:solidFill>
-                  <a:srgbClr val="5B6B75"/>
-                </a:solidFill>
-                <a:latin typeface="Microsoft YaHei" pitchFamily="34" charset="0"/>
-                <a:ea typeface="Microsoft YaHei" pitchFamily="34" charset="-122"/>
-                <a:cs typeface="Microsoft YaHei" pitchFamily="34" charset="-120"/>
-              </a:rPr>
-              <a:t>Strict 模式下 LLM 可见的 Benchmark 标签</a:t>
-            </a:r>
-            <a:endParaRPr lang="en-US" sz="1200" dirty="0"/>
-          </a:p>
-        </p:txBody>
-      </p:sp>
-      <p:sp>
-        <p:nvSpPr>
-          <p:cNvPr id="28" name="Shape 25"/>
-          <p:cNvSpPr/>
-          <p:nvPr/>
-        </p:nvSpPr>
-        <p:spPr>
-          <a:xfrm>
-            <a:off x="8046720" y="3840480"/>
-            <a:ext cx="3566160" cy="1234440"/>
-          </a:xfrm>
-          <a:prstGeom prst="roundRect">
-            <a:avLst>
-              <a:gd name="adj" fmla="val 5926"/>
-            </a:avLst>
-          </a:prstGeom>
-          <a:solidFill>
-            <a:srgbClr val="EEF3F2"/>
-          </a:solidFill>
-          <a:ln w="12700">
-            <a:solidFill>
-              <a:srgbClr val="EEF3F2"/>
-            </a:solidFill>
-            <a:prstDash val="solid"/>
-          </a:ln>
-        </p:spPr>
-      </p:sp>
-      <p:sp>
-        <p:nvSpPr>
-          <p:cNvPr id="29" name="Text 26"/>
-          <p:cNvSpPr txBox="1"/>
-          <p:nvPr/>
-        </p:nvSpPr>
-        <p:spPr>
-          <a:xfrm>
-            <a:off x="8229600" y="3950208"/>
-            <a:ext cx="3200400" cy="640080"/>
-          </a:xfrm>
-          <a:prstGeom prst="rect">
-            <a:avLst/>
-          </a:prstGeom>
-          <a:noFill/>
-          <a:ln/>
-        </p:spPr>
-        <p:txBody>
-          <a:bodyPr wrap="square" lIns="0" tIns="0" rIns="0" bIns="0" rtlCol="0" anchor="t"/>
-          <a:lstStyle/>
-          <a:p>
-            <a:pPr algn="l" indent="0" marL="0">
-              <a:buNone/>
-            </a:pPr>
-            <a:r>
-              <a:rPr lang="en-US" sz="2800" b="1" dirty="0">
-                <a:solidFill>
-                  <a:srgbClr val="087E78"/>
-                </a:solidFill>
-                <a:latin typeface="Microsoft YaHei" pitchFamily="34" charset="0"/>
-                <a:ea typeface="Microsoft YaHei" pitchFamily="34" charset="-122"/>
-                <a:cs typeface="Microsoft YaHei" pitchFamily="34" charset="-120"/>
-              </a:rPr>
-              <a:t>哈希链</a:t>
-            </a:r>
-            <a:endParaRPr lang="en-US" sz="2800" dirty="0"/>
-          </a:p>
-        </p:txBody>
-      </p:sp>
-      <p:sp>
-        <p:nvSpPr>
-          <p:cNvPr id="30" name="Text 27"/>
-          <p:cNvSpPr txBox="1"/>
-          <p:nvPr/>
-        </p:nvSpPr>
-        <p:spPr>
-          <a:xfrm>
-            <a:off x="8229600" y="4590288"/>
-            <a:ext cx="3200400" cy="411480"/>
-          </a:xfrm>
-          <a:prstGeom prst="rect">
-            <a:avLst/>
-          </a:prstGeom>
-          <a:noFill/>
-          <a:ln/>
-        </p:spPr>
-        <p:txBody>
-          <a:bodyPr wrap="square" lIns="0" tIns="0" rIns="0" bIns="0" rtlCol="0" anchor="t"/>
-          <a:lstStyle/>
-          <a:p>
-            <a:pPr algn="l" indent="0" marL="0">
-              <a:buNone/>
-            </a:pPr>
-            <a:r>
-              <a:rPr lang="en-US" sz="1200" dirty="0">
-                <a:solidFill>
-                  <a:srgbClr val="5B6B75"/>
-                </a:solidFill>
-                <a:latin typeface="Microsoft YaHei" pitchFamily="34" charset="0"/>
-                <a:ea typeface="Microsoft YaHei" pitchFamily="34" charset="-122"/>
-                <a:cs typeface="Microsoft YaHei" pitchFamily="34" charset="-120"/>
-              </a:rPr>
-              <a:t>每次运行写入 JSONL 轨迹，可逐步复核</a:t>
-            </a:r>
-            <a:endParaRPr lang="en-US" sz="1200" dirty="0"/>
-          </a:p>
-        </p:txBody>
-      </p:sp>
+      </p:pic>
     </p:spTree>
   </p:cSld>
   <p:clrMapOvr>
@@ -9644,7 +9437,7 @@
                 <a:ea typeface="Microsoft YaHei" pitchFamily="34" charset="-122"/>
                 <a:cs typeface="Microsoft YaHei" pitchFamily="34" charset="-120"/>
               </a:rPr>
-              <a:t>发现：反转≈随机，提分来自对齐评价指标</a:t>
+              <a:t>Agent 自主规划：一句话 → 多步计划 → 失败后重新规划</a:t>
             </a:r>
             <a:endParaRPr lang="en-US" sz="3000" dirty="0"/>
           </a:p>
@@ -9696,8 +9489,8 @@
           <p:nvPr/>
         </p:nvGraphicFramePr>
         <p:xfrm>
-          <a:off x="457200" y="1188720"/>
-          <a:ext cx="7132320" cy="4846320"/>
+          <a:off x="365760" y="1188720"/>
+          <a:ext cx="6583680" cy="4572000"/>
         </p:xfrm>
         <a:graphic xmlns:a="http://schemas.openxmlformats.org/drawingml/2006/main">
           <a:graphicData uri="http://schemas.openxmlformats.org/drawingml/2006/chart">
@@ -9713,8 +9506,8 @@
         </p:nvSpPr>
         <p:spPr>
           <a:xfrm>
-            <a:off x="7955280" y="1463040"/>
-            <a:ext cx="3749040" cy="4389120"/>
+            <a:off x="7223760" y="1234440"/>
+            <a:ext cx="4572000" cy="365760"/>
           </a:xfrm>
           <a:prstGeom prst="rect">
             <a:avLst/>
@@ -9726,15 +9519,116 @@
           <a:bodyPr wrap="square" lIns="0" tIns="0" rIns="0" bIns="0" rtlCol="0" anchor="t"/>
           <a:lstStyle/>
           <a:p>
-            <a:pPr marL="342900" indent="-342900">
-              <a:spcAft>
-                <a:spcPts val="1000"/>
-              </a:spcAft>
-              <a:buSzPct val="100000"/>
-              <a:buChar char="•"/>
+            <a:pPr algn="l" indent="0" marL="0">
+              <a:buNone/>
             </a:pPr>
             <a:r>
-              <a:rPr lang="en-US" sz="1500" dirty="0">
+              <a:rPr lang="en-US" sz="1400" b="1" dirty="0">
+                <a:solidFill>
+                  <a:srgbClr val="112B3C"/>
+                </a:solidFill>
+                <a:latin typeface="Microsoft YaHei" pitchFamily="34" charset="0"/>
+                <a:ea typeface="Microsoft YaHei" pitchFamily="34" charset="-122"/>
+                <a:cs typeface="Microsoft YaHei" pitchFamily="34" charset="-120"/>
+              </a:rPr>
+              <a:t>真实运行：排名首次失败后的重新规划</a:t>
+            </a:r>
+            <a:endParaRPr lang="en-US" sz="1400" dirty="0"/>
+          </a:p>
+        </p:txBody>
+      </p:sp>
+      <p:sp>
+        <p:nvSpPr>
+          <p:cNvPr id="7" name="Shape 3"/>
+          <p:cNvSpPr/>
+          <p:nvPr/>
+        </p:nvSpPr>
+        <p:spPr>
+          <a:xfrm>
+            <a:off x="7223760" y="1737360"/>
+            <a:ext cx="4480560" cy="868680"/>
+          </a:xfrm>
+          <a:prstGeom prst="roundRect">
+            <a:avLst>
+              <a:gd name="adj" fmla="val 6316"/>
+            </a:avLst>
+          </a:prstGeom>
+          <a:solidFill>
+            <a:srgbClr val="EEF3F2"/>
+          </a:solidFill>
+          <a:ln w="12700">
+            <a:solidFill>
+              <a:srgbClr val="EEF3F2"/>
+            </a:solidFill>
+            <a:prstDash val="solid"/>
+          </a:ln>
+        </p:spPr>
+      </p:sp>
+      <p:sp>
+        <p:nvSpPr>
+          <p:cNvPr id="8" name="Text 4"/>
+          <p:cNvSpPr txBox="1"/>
+          <p:nvPr/>
+        </p:nvSpPr>
+        <p:spPr>
+          <a:xfrm>
+            <a:off x="7360920" y="1810512"/>
+            <a:ext cx="4206240" cy="274320"/>
+          </a:xfrm>
+          <a:prstGeom prst="rect">
+            <a:avLst/>
+          </a:prstGeom>
+          <a:noFill/>
+          <a:ln/>
+        </p:spPr>
+        <p:txBody>
+          <a:bodyPr wrap="square" lIns="0" tIns="0" rIns="0" bIns="0" rtlCol="0" anchor="t"/>
+          <a:lstStyle/>
+          <a:p>
+            <a:pPr algn="l" indent="0" marL="0">
+              <a:buNone/>
+            </a:pPr>
+            <a:r>
+              <a:rPr lang="en-US" sz="1200" b="1" dirty="0">
+                <a:solidFill>
+                  <a:srgbClr val="087E78"/>
+                </a:solidFill>
+                <a:latin typeface="Microsoft YaHei" pitchFamily="34" charset="0"/>
+                <a:ea typeface="Microsoft YaHei" pitchFamily="34" charset="-122"/>
+                <a:cs typeface="Microsoft YaHei" pitchFamily="34" charset="-120"/>
+              </a:rPr>
+              <a:t>第 1 轮计划（7 步）</a:t>
+            </a:r>
+            <a:endParaRPr lang="en-US" sz="1200" dirty="0"/>
+          </a:p>
+        </p:txBody>
+      </p:sp>
+      <p:sp>
+        <p:nvSpPr>
+          <p:cNvPr id="9" name="Text 5"/>
+          <p:cNvSpPr txBox="1"/>
+          <p:nvPr/>
+        </p:nvSpPr>
+        <p:spPr>
+          <a:xfrm>
+            <a:off x="7360920" y="2121408"/>
+            <a:ext cx="4206240" cy="457200"/>
+          </a:xfrm>
+          <a:prstGeom prst="rect">
+            <a:avLst/>
+          </a:prstGeom>
+          <a:noFill/>
+          <a:ln/>
+        </p:spPr>
+        <p:txBody>
+          <a:bodyPr wrap="square" lIns="0" tIns="0" rIns="0" bIns="0" rtlCol="0" anchor="t"/>
+          <a:lstStyle/>
+          <a:p>
+            <a:pPr algn="l" indent="0" marL="0">
+              <a:buNone/>
+            </a:pPr>
+            <a:r>
+              <a:rPr lang="en-US" sz="1200" dirty="0">
                 <a:solidFill>
                   <a:srgbClr val="183042"/>
                 </a:solidFill>
@@ -9742,20 +9636,104 @@
                 <a:ea typeface="Microsoft YaHei" pitchFamily="34" charset="-122"/>
                 <a:cs typeface="Microsoft YaHei" pitchFamily="34" charset="-120"/>
               </a:rPr>
-              <a:t>官方 NS-AUC 在每个药物行内比较疾病，同分记 0</a:t>
+              <a:t>质控 → 差异表达 → 通路 → 排名 → 审计 → 文献 → 报告</a:t>
             </a:r>
-            <a:endParaRPr lang="en-US" sz="1500" dirty="0"/>
-          </a:p>
-          <a:p>
-            <a:pPr marL="342900" indent="-342900">
-              <a:spcAft>
-                <a:spcPts val="1000"/>
-              </a:spcAft>
-              <a:buSzPct val="100000"/>
-              <a:buChar char="•"/>
+            <a:endParaRPr lang="en-US" sz="1200" dirty="0"/>
+          </a:p>
+        </p:txBody>
+      </p:sp>
+      <p:sp>
+        <p:nvSpPr>
+          <p:cNvPr id="10" name="Shape 6"/>
+          <p:cNvSpPr/>
+          <p:nvPr/>
+        </p:nvSpPr>
+        <p:spPr>
+          <a:xfrm>
+            <a:off x="7223760" y="2761488"/>
+            <a:ext cx="4480560" cy="868680"/>
+          </a:xfrm>
+          <a:prstGeom prst="roundRect">
+            <a:avLst>
+              <a:gd name="adj" fmla="val 6316"/>
+            </a:avLst>
+          </a:prstGeom>
+          <a:solidFill>
+            <a:srgbClr val="F2E7E4"/>
+          </a:solidFill>
+          <a:ln w="12700">
+            <a:solidFill>
+              <a:srgbClr val="EEF3F2"/>
+            </a:solidFill>
+            <a:prstDash val="solid"/>
+          </a:ln>
+        </p:spPr>
+      </p:sp>
+      <p:sp>
+        <p:nvSpPr>
+          <p:cNvPr id="11" name="Text 7"/>
+          <p:cNvSpPr txBox="1"/>
+          <p:nvPr/>
+        </p:nvSpPr>
+        <p:spPr>
+          <a:xfrm>
+            <a:off x="7360920" y="2834640"/>
+            <a:ext cx="4206240" cy="274320"/>
+          </a:xfrm>
+          <a:prstGeom prst="rect">
+            <a:avLst/>
+          </a:prstGeom>
+          <a:noFill/>
+          <a:ln/>
+        </p:spPr>
+        <p:txBody>
+          <a:bodyPr wrap="square" lIns="0" tIns="0" rIns="0" bIns="0" rtlCol="0" anchor="t"/>
+          <a:lstStyle/>
+          <a:p>
+            <a:pPr algn="l" indent="0" marL="0">
+              <a:buNone/>
             </a:pPr>
             <a:r>
-              <a:rPr lang="en-US" sz="1500" dirty="0">
+              <a:rPr lang="en-US" sz="1200" b="1" dirty="0">
+                <a:solidFill>
+                  <a:srgbClr val="9E493D"/>
+                </a:solidFill>
+                <a:latin typeface="Microsoft YaHei" pitchFamily="34" charset="0"/>
+                <a:ea typeface="Microsoft YaHei" pitchFamily="34" charset="-122"/>
+                <a:cs typeface="Microsoft YaHei" pitchFamily="34" charset="-120"/>
+              </a:rPr>
+              <a:t>执行</a:t>
+            </a:r>
+            <a:endParaRPr lang="en-US" sz="1200" dirty="0"/>
+          </a:p>
+        </p:txBody>
+      </p:sp>
+      <p:sp>
+        <p:nvSpPr>
+          <p:cNvPr id="12" name="Text 8"/>
+          <p:cNvSpPr txBox="1"/>
+          <p:nvPr/>
+        </p:nvSpPr>
+        <p:spPr>
+          <a:xfrm>
+            <a:off x="7360920" y="3145536"/>
+            <a:ext cx="4206240" cy="457200"/>
+          </a:xfrm>
+          <a:prstGeom prst="rect">
+            <a:avLst/>
+          </a:prstGeom>
+          <a:noFill/>
+          <a:ln/>
+        </p:spPr>
+        <p:txBody>
+          <a:bodyPr wrap="square" lIns="0" tIns="0" rIns="0" bIns="0" rtlCol="0" anchor="t"/>
+          <a:lstStyle/>
+          <a:p>
+            <a:pPr algn="l" indent="0" marL="0">
+              <a:buNone/>
+            </a:pPr>
+            <a:r>
+              <a:rPr lang="en-US" sz="1200" dirty="0">
                 <a:solidFill>
                   <a:srgbClr val="183042"/>
                 </a:solidFill>
@@ -9763,20 +9741,104 @@
                 <a:ea typeface="Microsoft YaHei" pitchFamily="34" charset="-122"/>
                 <a:cs typeface="Microsoft YaHei" pitchFamily="34" charset="-120"/>
               </a:rPr>
-              <a:t>旧 B2 按疾病列排序，流行度在行内是常数 → 失效</a:t>
+              <a:t>质控、差异表达、通路 ✓ ；排名 ✗</a:t>
             </a:r>
-            <a:endParaRPr lang="en-US" sz="1500" dirty="0"/>
-          </a:p>
-          <a:p>
-            <a:pPr marL="342900" indent="-342900">
-              <a:spcAft>
-                <a:spcPts val="1000"/>
-              </a:spcAft>
-              <a:buSzPct val="100000"/>
-              <a:buChar char="•"/>
+            <a:endParaRPr lang="en-US" sz="1200" dirty="0"/>
+          </a:p>
+        </p:txBody>
+      </p:sp>
+      <p:sp>
+        <p:nvSpPr>
+          <p:cNvPr id="13" name="Shape 9"/>
+          <p:cNvSpPr/>
+          <p:nvPr/>
+        </p:nvSpPr>
+        <p:spPr>
+          <a:xfrm>
+            <a:off x="7223760" y="3785616"/>
+            <a:ext cx="4480560" cy="868680"/>
+          </a:xfrm>
+          <a:prstGeom prst="roundRect">
+            <a:avLst>
+              <a:gd name="adj" fmla="val 6316"/>
+            </a:avLst>
+          </a:prstGeom>
+          <a:solidFill>
+            <a:srgbClr val="EEF3F2"/>
+          </a:solidFill>
+          <a:ln w="12700">
+            <a:solidFill>
+              <a:srgbClr val="EEF3F2"/>
+            </a:solidFill>
+            <a:prstDash val="solid"/>
+          </a:ln>
+        </p:spPr>
+      </p:sp>
+      <p:sp>
+        <p:nvSpPr>
+          <p:cNvPr id="14" name="Text 10"/>
+          <p:cNvSpPr txBox="1"/>
+          <p:nvPr/>
+        </p:nvSpPr>
+        <p:spPr>
+          <a:xfrm>
+            <a:off x="7360920" y="3858768"/>
+            <a:ext cx="4206240" cy="274320"/>
+          </a:xfrm>
+          <a:prstGeom prst="rect">
+            <a:avLst/>
+          </a:prstGeom>
+          <a:noFill/>
+          <a:ln/>
+        </p:spPr>
+        <p:txBody>
+          <a:bodyPr wrap="square" lIns="0" tIns="0" rIns="0" bIns="0" rtlCol="0" anchor="t"/>
+          <a:lstStyle/>
+          <a:p>
+            <a:pPr algn="l" indent="0" marL="0">
+              <a:buNone/>
             </a:pPr>
             <a:r>
-              <a:rPr lang="en-US" sz="1500" dirty="0">
+              <a:rPr lang="en-US" sz="1200" b="1" dirty="0">
+                <a:solidFill>
+                  <a:srgbClr val="087E78"/>
+                </a:solidFill>
+                <a:latin typeface="Microsoft YaHei" pitchFamily="34" charset="0"/>
+                <a:ea typeface="Microsoft YaHei" pitchFamily="34" charset="-122"/>
+                <a:cs typeface="Microsoft YaHei" pitchFamily="34" charset="-120"/>
+              </a:rPr>
+              <a:t>第 2 轮计划（4 步）</a:t>
+            </a:r>
+            <a:endParaRPr lang="en-US" sz="1200" dirty="0"/>
+          </a:p>
+        </p:txBody>
+      </p:sp>
+      <p:sp>
+        <p:nvSpPr>
+          <p:cNvPr id="15" name="Text 11"/>
+          <p:cNvSpPr txBox="1"/>
+          <p:nvPr/>
+        </p:nvSpPr>
+        <p:spPr>
+          <a:xfrm>
+            <a:off x="7360920" y="4169664"/>
+            <a:ext cx="4206240" cy="457200"/>
+          </a:xfrm>
+          <a:prstGeom prst="rect">
+            <a:avLst/>
+          </a:prstGeom>
+          <a:noFill/>
+          <a:ln/>
+        </p:spPr>
+        <p:txBody>
+          <a:bodyPr wrap="square" lIns="0" tIns="0" rIns="0" bIns="0" rtlCol="0" anchor="t"/>
+          <a:lstStyle/>
+          <a:p>
+            <a:pPr algn="l" indent="0" marL="0">
+              <a:buNone/>
+            </a:pPr>
+            <a:r>
+              <a:rPr lang="en-US" sz="1200" dirty="0">
                 <a:solidFill>
                   <a:srgbClr val="183042"/>
                 </a:solidFill>
@@ -9784,20 +9846,104 @@
                 <a:ea typeface="Microsoft YaHei" pitchFamily="34" charset="-122"/>
                 <a:cs typeface="Microsoft YaHei" pitchFamily="34" charset="-120"/>
               </a:rPr>
-              <a:t>B3 改为行方向：疾病流行度 + 表达 kNN + 标签共现 + 反转</a:t>
+              <a:t>排名 → 审计 → 文献 → 报告</a:t>
             </a:r>
-            <a:endParaRPr lang="en-US" sz="1500" dirty="0"/>
-          </a:p>
-          <a:p>
-            <a:pPr marL="342900" indent="-342900">
-              <a:spcAft>
-                <a:spcPts val="1000"/>
-              </a:spcAft>
-              <a:buSzPct val="100000"/>
-              <a:buChar char="•"/>
+            <a:endParaRPr lang="en-US" sz="1200" dirty="0"/>
+          </a:p>
+        </p:txBody>
+      </p:sp>
+      <p:sp>
+        <p:nvSpPr>
+          <p:cNvPr id="16" name="Shape 12"/>
+          <p:cNvSpPr/>
+          <p:nvPr/>
+        </p:nvSpPr>
+        <p:spPr>
+          <a:xfrm>
+            <a:off x="7223760" y="4809744"/>
+            <a:ext cx="4480560" cy="868680"/>
+          </a:xfrm>
+          <a:prstGeom prst="roundRect">
+            <a:avLst>
+              <a:gd name="adj" fmla="val 6316"/>
+            </a:avLst>
+          </a:prstGeom>
+          <a:solidFill>
+            <a:srgbClr val="EEF3F2"/>
+          </a:solidFill>
+          <a:ln w="12700">
+            <a:solidFill>
+              <a:srgbClr val="EEF3F2"/>
+            </a:solidFill>
+            <a:prstDash val="solid"/>
+          </a:ln>
+        </p:spPr>
+      </p:sp>
+      <p:sp>
+        <p:nvSpPr>
+          <p:cNvPr id="17" name="Text 13"/>
+          <p:cNvSpPr txBox="1"/>
+          <p:nvPr/>
+        </p:nvSpPr>
+        <p:spPr>
+          <a:xfrm>
+            <a:off x="7360920" y="4882896"/>
+            <a:ext cx="4206240" cy="274320"/>
+          </a:xfrm>
+          <a:prstGeom prst="rect">
+            <a:avLst/>
+          </a:prstGeom>
+          <a:noFill/>
+          <a:ln/>
+        </p:spPr>
+        <p:txBody>
+          <a:bodyPr wrap="square" lIns="0" tIns="0" rIns="0" bIns="0" rtlCol="0" anchor="t"/>
+          <a:lstStyle/>
+          <a:p>
+            <a:pPr algn="l" indent="0" marL="0">
+              <a:buNone/>
             </a:pPr>
             <a:r>
-              <a:rPr lang="en-US" sz="1500" dirty="0">
+              <a:rPr lang="en-US" sz="1200" b="1" dirty="0">
+                <a:solidFill>
+                  <a:srgbClr val="087E78"/>
+                </a:solidFill>
+                <a:latin typeface="Microsoft YaHei" pitchFamily="34" charset="0"/>
+                <a:ea typeface="Microsoft YaHei" pitchFamily="34" charset="-122"/>
+                <a:cs typeface="Microsoft YaHei" pitchFamily="34" charset="-120"/>
+              </a:rPr>
+              <a:t>结果</a:t>
+            </a:r>
+            <a:endParaRPr lang="en-US" sz="1200" dirty="0"/>
+          </a:p>
+        </p:txBody>
+      </p:sp>
+      <p:sp>
+        <p:nvSpPr>
+          <p:cNvPr id="18" name="Text 14"/>
+          <p:cNvSpPr txBox="1"/>
+          <p:nvPr/>
+        </p:nvSpPr>
+        <p:spPr>
+          <a:xfrm>
+            <a:off x="7360920" y="5193792"/>
+            <a:ext cx="4206240" cy="457200"/>
+          </a:xfrm>
+          <a:prstGeom prst="rect">
+            <a:avLst/>
+          </a:prstGeom>
+          <a:noFill/>
+          <a:ln/>
+        </p:spPr>
+        <p:txBody>
+          <a:bodyPr wrap="square" lIns="0" tIns="0" rIns="0" bIns="0" rtlCol="0" anchor="t"/>
+          <a:lstStyle/>
+          <a:p>
+            <a:pPr algn="l" indent="0" marL="0">
+              <a:buNone/>
+            </a:pPr>
+            <a:r>
+              <a:rPr lang="en-US" sz="1200" dirty="0">
                 <a:solidFill>
                   <a:srgbClr val="183042"/>
                 </a:solidFill>
@@ -9805,30 +9951,9 @@
                 <a:ea typeface="Microsoft YaHei" pitchFamily="34" charset="-122"/>
                 <a:cs typeface="Microsoft YaHei" pitchFamily="34" charset="-120"/>
               </a:rPr>
-              <a:t>配置在正式评分前冻结；开发种子与官方种子不相交</a:t>
+              <a:t>完成：completed；已完成步骤未重跑</a:t>
             </a:r>
-            <a:endParaRPr lang="en-US" sz="1500" dirty="0"/>
-          </a:p>
-          <a:p>
-            <a:pPr marL="342900" indent="-342900">
-              <a:spcAft>
-                <a:spcPts val="1000"/>
-              </a:spcAft>
-              <a:buSzPct val="100000"/>
-              <a:buChar char="•"/>
-            </a:pPr>
-            <a:r>
-              <a:rPr lang="en-US" sz="1500" dirty="0">
-                <a:solidFill>
-                  <a:srgbClr val="183042"/>
-                </a:solidFill>
-                <a:latin typeface="Microsoft YaHei" pitchFamily="34" charset="0"/>
-                <a:ea typeface="Microsoft YaHei" pitchFamily="34" charset="-122"/>
-                <a:cs typeface="Microsoft YaHei" pitchFamily="34" charset="-120"/>
-              </a:rPr>
-              <a:t>第二轮 B4 = B3 + BNNR 移植（与作者结果逐种子一致），单独冻结后评分</a:t>
-            </a:r>
-            <a:endParaRPr lang="en-US" sz="1500" dirty="0"/>
+            <a:endParaRPr lang="en-US" sz="1200" dirty="0"/>
           </a:p>
         </p:txBody>
       </p:sp>
@@ -9897,7 +10022,7 @@
                 <a:ea typeface="Microsoft YaHei" pitchFamily="34" charset="-122"/>
                 <a:cs typeface="Microsoft YaHei" pitchFamily="34" charset="-120"/>
               </a:rPr>
-              <a:t>Benchmark：B4 随机 1/13（与 BNNR 持平）、弱相关 3/13</a:t>
+              <a:t>发现：反转≈随机，提分来自对齐评价指标</a:t>
             </a:r>
             <a:endParaRPr lang="en-US" sz="3000" dirty="0"/>
           </a:p>
@@ -9942,29 +10067,149 @@
           </a:p>
         </p:txBody>
       </p:sp>
-      <p:pic>
-        <p:nvPicPr>
-          <p:cNvPr id="5" name="Image 0" descr="docs/figures/fig1_nsauc_boxplot.png">    </p:cNvPr>
-          <p:cNvPicPr>
-            <a:picLocks noChangeAspect="1"/>
-          </p:cNvPicPr>
+      <p:graphicFrame>
+        <p:nvGraphicFramePr>
+          <p:cNvPr id="5" name="Chart 0" descr=""/>
+          <p:cNvGraphicFramePr/>
           <p:nvPr/>
-        </p:nvPicPr>
-        <p:blipFill>
-          <a:blip r:embed="rId1"/>
-          <a:srcRect l="0" r="0" t="0" b="0"/>
-          <a:stretch/>
-        </p:blipFill>
+        </p:nvGraphicFramePr>
+        <p:xfrm>
+          <a:off x="457200" y="1188720"/>
+          <a:ext cx="7132320" cy="4846320"/>
+        </p:xfrm>
+        <a:graphic xmlns:a="http://schemas.openxmlformats.org/drawingml/2006/main">
+          <a:graphicData uri="http://schemas.openxmlformats.org/drawingml/2006/chart">
+            <c:chart xmlns:c="http://schemas.openxmlformats.org/drawingml/2006/chart" r:id="rId1"/>
+          </a:graphicData>
+        </a:graphic>
+      </p:graphicFrame>
+      <p:sp>
+        <p:nvSpPr>
+          <p:cNvPr id="6" name="Text 2"/>
+          <p:cNvSpPr txBox="1"/>
+          <p:nvPr/>
+        </p:nvSpPr>
         <p:spPr>
           <a:xfrm>
-            <a:off x="502920" y="1188720"/>
-            <a:ext cx="11155680" cy="5074920"/>
+            <a:off x="7955280" y="1463040"/>
+            <a:ext cx="3749040" cy="4389120"/>
           </a:xfrm>
           <a:prstGeom prst="rect">
             <a:avLst/>
           </a:prstGeom>
+          <a:noFill/>
+          <a:ln/>
         </p:spPr>
-      </p:pic>
+        <p:txBody>
+          <a:bodyPr wrap="square" lIns="0" tIns="0" rIns="0" bIns="0" rtlCol="0" anchor="t"/>
+          <a:lstStyle/>
+          <a:p>
+            <a:pPr marL="342900" indent="-342900">
+              <a:spcAft>
+                <a:spcPts val="1000"/>
+              </a:spcAft>
+              <a:buSzPct val="100000"/>
+              <a:buChar char="•"/>
+            </a:pPr>
+            <a:r>
+              <a:rPr lang="en-US" sz="1500" dirty="0">
+                <a:solidFill>
+                  <a:srgbClr val="183042"/>
+                </a:solidFill>
+                <a:latin typeface="Microsoft YaHei" pitchFamily="34" charset="0"/>
+                <a:ea typeface="Microsoft YaHei" pitchFamily="34" charset="-122"/>
+                <a:cs typeface="Microsoft YaHei" pitchFamily="34" charset="-120"/>
+              </a:rPr>
+              <a:t>官方 NS-AUC 在每个药物行内比较疾病，同分记 0</a:t>
+            </a:r>
+            <a:endParaRPr lang="en-US" sz="1500" dirty="0"/>
+          </a:p>
+          <a:p>
+            <a:pPr marL="342900" indent="-342900">
+              <a:spcAft>
+                <a:spcPts val="1000"/>
+              </a:spcAft>
+              <a:buSzPct val="100000"/>
+              <a:buChar char="•"/>
+            </a:pPr>
+            <a:r>
+              <a:rPr lang="en-US" sz="1500" dirty="0">
+                <a:solidFill>
+                  <a:srgbClr val="183042"/>
+                </a:solidFill>
+                <a:latin typeface="Microsoft YaHei" pitchFamily="34" charset="0"/>
+                <a:ea typeface="Microsoft YaHei" pitchFamily="34" charset="-122"/>
+                <a:cs typeface="Microsoft YaHei" pitchFamily="34" charset="-120"/>
+              </a:rPr>
+              <a:t>旧 B2 按疾病列排序，流行度在行内是常数 → 失效</a:t>
+            </a:r>
+            <a:endParaRPr lang="en-US" sz="1500" dirty="0"/>
+          </a:p>
+          <a:p>
+            <a:pPr marL="342900" indent="-342900">
+              <a:spcAft>
+                <a:spcPts val="1000"/>
+              </a:spcAft>
+              <a:buSzPct val="100000"/>
+              <a:buChar char="•"/>
+            </a:pPr>
+            <a:r>
+              <a:rPr lang="en-US" sz="1500" dirty="0">
+                <a:solidFill>
+                  <a:srgbClr val="183042"/>
+                </a:solidFill>
+                <a:latin typeface="Microsoft YaHei" pitchFamily="34" charset="0"/>
+                <a:ea typeface="Microsoft YaHei" pitchFamily="34" charset="-122"/>
+                <a:cs typeface="Microsoft YaHei" pitchFamily="34" charset="-120"/>
+              </a:rPr>
+              <a:t>B3 改为行方向：疾病流行度 + 表达 kNN + 标签共现 + 反转</a:t>
+            </a:r>
+            <a:endParaRPr lang="en-US" sz="1500" dirty="0"/>
+          </a:p>
+          <a:p>
+            <a:pPr marL="342900" indent="-342900">
+              <a:spcAft>
+                <a:spcPts val="1000"/>
+              </a:spcAft>
+              <a:buSzPct val="100000"/>
+              <a:buChar char="•"/>
+            </a:pPr>
+            <a:r>
+              <a:rPr lang="en-US" sz="1500" dirty="0">
+                <a:solidFill>
+                  <a:srgbClr val="183042"/>
+                </a:solidFill>
+                <a:latin typeface="Microsoft YaHei" pitchFamily="34" charset="0"/>
+                <a:ea typeface="Microsoft YaHei" pitchFamily="34" charset="-122"/>
+                <a:cs typeface="Microsoft YaHei" pitchFamily="34" charset="-120"/>
+              </a:rPr>
+              <a:t>配置在正式评分前冻结；开发种子与官方种子不相交</a:t>
+            </a:r>
+            <a:endParaRPr lang="en-US" sz="1500" dirty="0"/>
+          </a:p>
+          <a:p>
+            <a:pPr marL="342900" indent="-342900">
+              <a:spcAft>
+                <a:spcPts val="1000"/>
+              </a:spcAft>
+              <a:buSzPct val="100000"/>
+              <a:buChar char="•"/>
+            </a:pPr>
+            <a:r>
+              <a:rPr lang="en-US" sz="1500" dirty="0">
+                <a:solidFill>
+                  <a:srgbClr val="183042"/>
+                </a:solidFill>
+                <a:latin typeface="Microsoft YaHei" pitchFamily="34" charset="0"/>
+                <a:ea typeface="Microsoft YaHei" pitchFamily="34" charset="-122"/>
+                <a:cs typeface="Microsoft YaHei" pitchFamily="34" charset="-120"/>
+              </a:rPr>
+              <a:t>第二轮 B4 = B3 + BNNR 移植（与作者结果逐种子一致），单独冻结后评分</a:t>
+            </a:r>
+            <a:endParaRPr lang="en-US" sz="1500" dirty="0"/>
+          </a:p>
+        </p:txBody>
+      </p:sp>
     </p:spTree>
   </p:cSld>
   <p:clrMapOvr>
@@ -10030,7 +10275,7 @@
                 <a:ea typeface="Microsoft YaHei" pitchFamily="34" charset="-122"/>
                 <a:cs typeface="Microsoft YaHei" pitchFamily="34" charset="-120"/>
               </a:rPr>
-              <a:t>为什么必须 Strict 模式：LLM 知识污染探针</a:t>
+              <a:t>Benchmark：B4 随机 1/13（与 BNNR 持平）、弱相关 3/13</a:t>
             </a:r>
             <a:endParaRPr lang="en-US" sz="3000" dirty="0"/>
           </a:p>
@@ -10075,128 +10320,29 @@
           </a:p>
         </p:txBody>
       </p:sp>
-      <p:graphicFrame>
-        <p:nvGraphicFramePr>
-          <p:cNvPr id="5" name="Chart 0" descr=""/>
-          <p:cNvGraphicFramePr/>
+      <p:pic>
+        <p:nvPicPr>
+          <p:cNvPr id="5" name="Image 0" descr="docs/figures/fig1_nsauc_boxplot.png">    </p:cNvPr>
+          <p:cNvPicPr>
+            <a:picLocks noChangeAspect="1"/>
+          </p:cNvPicPr>
           <p:nvPr/>
-        </p:nvGraphicFramePr>
-        <p:xfrm>
-          <a:off x="457200" y="1188720"/>
-          <a:ext cx="6766560" cy="4846320"/>
-        </p:xfrm>
-        <a:graphic xmlns:a="http://schemas.openxmlformats.org/drawingml/2006/main">
-          <a:graphicData uri="http://schemas.openxmlformats.org/drawingml/2006/chart">
-            <c:chart xmlns:c="http://schemas.openxmlformats.org/drawingml/2006/chart" r:id="rId1"/>
-          </a:graphicData>
-        </a:graphic>
-      </p:graphicFrame>
-      <p:sp>
-        <p:nvSpPr>
-          <p:cNvPr id="6" name="Text 2"/>
-          <p:cNvSpPr txBox="1"/>
-          <p:nvPr/>
-        </p:nvSpPr>
+        </p:nvPicPr>
+        <p:blipFill>
+          <a:blip r:embed="rId1"/>
+          <a:srcRect l="0" r="0" t="0" b="0"/>
+          <a:stretch/>
+        </p:blipFill>
         <p:spPr>
           <a:xfrm>
-            <a:off x="7589520" y="1463040"/>
-            <a:ext cx="4114800" cy="4480560"/>
+            <a:off x="502920" y="1188720"/>
+            <a:ext cx="11155680" cy="5074920"/>
           </a:xfrm>
           <a:prstGeom prst="rect">
             <a:avLst/>
           </a:prstGeom>
-          <a:noFill/>
-          <a:ln/>
         </p:spPr>
-        <p:txBody>
-          <a:bodyPr wrap="square" lIns="0" tIns="0" rIns="0" bIns="0" rtlCol="0" anchor="t"/>
-          <a:lstStyle/>
-          <a:p>
-            <a:pPr marL="342900" indent="-342900">
-              <a:spcAft>
-                <a:spcPts val="1000"/>
-              </a:spcAft>
-              <a:buSzPct val="100000"/>
-              <a:buChar char="•"/>
-            </a:pPr>
-            <a:r>
-              <a:rPr lang="en-US" sz="1500" dirty="0">
-                <a:solidFill>
-                  <a:srgbClr val="183042"/>
-                </a:solidFill>
-                <a:latin typeface="Microsoft YaHei" pitchFamily="34" charset="0"/>
-                <a:ea typeface="Microsoft YaHei" pitchFamily="34" charset="-122"/>
-                <a:cs typeface="Microsoft YaHei" pitchFamily="34" charset="-120"/>
-              </a:rPr>
-              <a:t>开卷 95% CI [0.526, 0.609]：唯一显著高于 0.5</a:t>
-            </a:r>
-            <a:endParaRPr lang="en-US" sz="1500" dirty="0"/>
-          </a:p>
-          <a:p>
-            <a:pPr marL="342900" indent="-342900">
-              <a:spcAft>
-                <a:spcPts val="1000"/>
-              </a:spcAft>
-              <a:buSzPct val="100000"/>
-              <a:buChar char="•"/>
-            </a:pPr>
-            <a:r>
-              <a:rPr lang="en-US" sz="1500" dirty="0">
-                <a:solidFill>
-                  <a:srgbClr val="183042"/>
-                </a:solidFill>
-                <a:latin typeface="Microsoft YaHei" pitchFamily="34" charset="0"/>
-                <a:ea typeface="Microsoft YaHei" pitchFamily="34" charset="-122"/>
-                <a:cs typeface="Microsoft YaHei" pitchFamily="34" charset="-120"/>
-              </a:rPr>
-              <a:t>高置信命中都是教科书适应症（如四环素类—痤疮）</a:t>
-            </a:r>
-            <a:endParaRPr lang="en-US" sz="1500" dirty="0"/>
-          </a:p>
-          <a:p>
-            <a:pPr marL="342900" indent="-342900">
-              <a:spcAft>
-                <a:spcPts val="1000"/>
-              </a:spcAft>
-              <a:buSzPct val="100000"/>
-              <a:buChar char="•"/>
-            </a:pPr>
-            <a:r>
-              <a:rPr lang="en-US" sz="1500" dirty="0">
-                <a:solidFill>
-                  <a:srgbClr val="183042"/>
-                </a:solidFill>
-                <a:latin typeface="Microsoft YaHei" pitchFamily="34" charset="0"/>
-                <a:ea typeface="Microsoft YaHei" pitchFamily="34" charset="-122"/>
-                <a:cs typeface="Microsoft YaHei" pitchFamily="34" charset="-120"/>
-              </a:rPr>
-              <a:t>开卷 − 闭卷 = 0.040，CI 跨 0：泄漏存在但幅度小</a:t>
-            </a:r>
-            <a:endParaRPr lang="en-US" sz="1500" dirty="0"/>
-          </a:p>
-          <a:p>
-            <a:pPr marL="342900" indent="-342900">
-              <a:spcAft>
-                <a:spcPts val="1000"/>
-              </a:spcAft>
-              <a:buSzPct val="100000"/>
-              <a:buChar char="•"/>
-            </a:pPr>
-            <a:r>
-              <a:rPr lang="en-US" sz="1500" dirty="0">
-                <a:solidFill>
-                  <a:srgbClr val="183042"/>
-                </a:solidFill>
-                <a:latin typeface="Microsoft YaHei" pitchFamily="34" charset="0"/>
-                <a:ea typeface="Microsoft YaHei" pitchFamily="34" charset="-122"/>
-                <a:cs typeface="Microsoft YaHei" pitchFamily="34" charset="-120"/>
-              </a:rPr>
-              <a:t>看得到药名的 LLM 会“背答案”，所以 Benchmark 必须在 Strict 模式下运行</a:t>
-            </a:r>
-            <a:endParaRPr lang="en-US" sz="1500" dirty="0"/>
-          </a:p>
-        </p:txBody>
-      </p:sp>
+      </p:pic>
     </p:spTree>
   </p:cSld>
   <p:clrMapOvr>
@@ -10262,7 +10408,7 @@
                 <a:ea typeface="Microsoft YaHei" pitchFamily="34" charset="-122"/>
                 <a:cs typeface="Microsoft YaHei" pitchFamily="34" charset="-120"/>
               </a:rPr>
-              <a:t>决策层：规则 vs 通用 LLM vs Jev（实测）</a:t>
+              <a:t>为什么必须 Strict 模式：LLM 知识污染探针</a:t>
             </a:r>
             <a:endParaRPr lang="en-US" sz="3000" dirty="0"/>
           </a:p>
@@ -10314,8 +10460,8 @@
           <p:nvPr/>
         </p:nvGraphicFramePr>
         <p:xfrm>
-          <a:off x="365760" y="1188720"/>
-          <a:ext cx="7772400" cy="4937760"/>
+          <a:off x="457200" y="1188720"/>
+          <a:ext cx="6766560" cy="4846320"/>
         </p:xfrm>
         <a:graphic xmlns:a="http://schemas.openxmlformats.org/drawingml/2006/main">
           <a:graphicData uri="http://schemas.openxmlformats.org/drawingml/2006/chart">
@@ -10331,8 +10477,8 @@
         </p:nvSpPr>
         <p:spPr>
           <a:xfrm>
-            <a:off x="8321040" y="1280160"/>
-            <a:ext cx="3474720" cy="4846320"/>
+            <a:off x="7589520" y="1463040"/>
+            <a:ext cx="4114800" cy="4480560"/>
           </a:xfrm>
           <a:prstGeom prst="rect">
             <a:avLst/>
@@ -10352,7 +10498,7 @@
               <a:buChar char="•"/>
             </a:pPr>
             <a:r>
-              <a:rPr lang="en-US" sz="1300" dirty="0">
+              <a:rPr lang="en-US" sz="1500" dirty="0">
                 <a:solidFill>
                   <a:srgbClr val="183042"/>
                 </a:solidFill>
@@ -10360,9 +10506,9 @@
                 <a:ea typeface="Microsoft YaHei" pitchFamily="34" charset="-122"/>
                 <a:cs typeface="Microsoft YaHei" pitchFamily="34" charset="-120"/>
               </a:rPr>
-              <a:t>v1 120 例：Jev 准确率 0.900 最高，Brier 0.147 最低</a:t>
+              <a:t>开卷 95% CI [0.526, 0.609]：唯一显著高于 0.5</a:t>
             </a:r>
-            <a:endParaRPr lang="en-US" sz="1300" dirty="0"/>
+            <a:endParaRPr lang="en-US" sz="1500" dirty="0"/>
           </a:p>
           <a:p>
             <a:pPr marL="342900" indent="-342900">
@@ -10373,7 +10519,7 @@
               <a:buChar char="•"/>
             </a:pPr>
             <a:r>
-              <a:rPr lang="en-US" sz="1300" dirty="0">
+              <a:rPr lang="en-US" sz="1500" dirty="0">
                 <a:solidFill>
                   <a:srgbClr val="183042"/>
                 </a:solidFill>
@@ -10381,9 +10527,9 @@
                 <a:ea typeface="Microsoft YaHei" pitchFamily="34" charset="-122"/>
                 <a:cs typeface="Microsoft YaHei" pitchFamily="34" charset="-120"/>
               </a:rPr>
-              <a:t>Jev + 门控：高风险误执行 0.000，但升级率 0.483</a:t>
+              <a:t>高置信命中都是教科书适应症（如四环素类—痤疮）</a:t>
             </a:r>
-            <a:endParaRPr lang="en-US" sz="1300" dirty="0"/>
+            <a:endParaRPr lang="en-US" sz="1500" dirty="0"/>
           </a:p>
           <a:p>
             <a:pPr marL="342900" indent="-342900">
@@ -10394,7 +10540,7 @@
               <a:buChar char="•"/>
             </a:pPr>
             <a:r>
-              <a:rPr lang="en-US" sz="1300" dirty="0">
+              <a:rPr lang="en-US" sz="1500" dirty="0">
                 <a:solidFill>
                   <a:srgbClr val="183042"/>
                 </a:solidFill>
@@ -10402,9 +10548,9 @@
                 <a:ea typeface="Microsoft YaHei" pitchFamily="34" charset="-122"/>
                 <a:cs typeface="Microsoft YaHei" pitchFamily="34" charset="-120"/>
               </a:rPr>
-              <a:t>v2 混合层（Jev 判备注）39/40、0 高风险误执行；完整 Jev 32/40</a:t>
+              <a:t>开卷 − 闭卷 = 0.040，CI 跨 0：泄漏存在但幅度小</a:t>
             </a:r>
-            <a:endParaRPr lang="en-US" sz="1300" dirty="0"/>
+            <a:endParaRPr lang="en-US" sz="1500" dirty="0"/>
           </a:p>
           <a:p>
             <a:pPr marL="342900" indent="-342900">
@@ -10415,7 +10561,7 @@
               <a:buChar char="•"/>
             </a:pPr>
             <a:r>
-              <a:rPr lang="en-US" sz="1300" dirty="0">
+              <a:rPr lang="en-US" sz="1500" dirty="0">
                 <a:solidFill>
                   <a:srgbClr val="183042"/>
                 </a:solidFill>
@@ -10423,30 +10569,9 @@
                 <a:ea typeface="Microsoft YaHei" pitchFamily="34" charset="-122"/>
                 <a:cs typeface="Microsoft YaHei" pitchFamily="34" charset="-120"/>
               </a:rPr>
-              <a:t>混合设计换 flash / v4-pro / Jev 都是 0 高风险误执行</a:t>
+              <a:t>看得到药名的 LLM 会“背答案”，所以 Benchmark 必须在 Strict 模式下运行</a:t>
             </a:r>
-            <a:endParaRPr lang="en-US" sz="1300" dirty="0"/>
-          </a:p>
-          <a:p>
-            <a:pPr marL="342900" indent="-342900">
-              <a:spcAft>
-                <a:spcPts val="1000"/>
-              </a:spcAft>
-              <a:buSzPct val="100000"/>
-              <a:buChar char="•"/>
-            </a:pPr>
-            <a:r>
-              <a:rPr lang="en-US" sz="1300" dirty="0">
-                <a:solidFill>
-                  <a:srgbClr val="183042"/>
-                </a:solidFill>
-                <a:latin typeface="Microsoft YaHei" pitchFamily="34" charset="0"/>
-                <a:ea typeface="Microsoft YaHei" pitchFamily="34" charset="-122"/>
-                <a:cs typeface="Microsoft YaHei" pitchFamily="34" charset="-120"/>
-              </a:rPr>
-              <a:t>合成用例、单次运行；Jev 用免费版</a:t>
-            </a:r>
-            <a:endParaRPr lang="en-US" sz="1300" dirty="0"/>
+            <a:endParaRPr lang="en-US" sz="1500" dirty="0"/>
           </a:p>
         </p:txBody>
       </p:sp>
@@ -10515,7 +10640,7 @@
                 <a:ea typeface="Microsoft YaHei" pitchFamily="34" charset="-122"/>
                 <a:cs typeface="Microsoft YaHei" pitchFamily="34" charset="-120"/>
               </a:rPr>
-              <a:t>肺腺癌案例：通路与机制</a:t>
+              <a:t>决策层：规则 vs 通用 LLM vs Jev（实测）</a:t>
             </a:r>
             <a:endParaRPr lang="en-US" sz="3000" dirty="0"/>
           </a:p>
@@ -10560,62 +10685,32 @@
           </a:p>
         </p:txBody>
       </p:sp>
-      <p:pic>
-        <p:nvPicPr>
-          <p:cNvPr id="5" name="Image 0" descr="docs/figures/fig7_luad_pathways.png">    </p:cNvPr>
-          <p:cNvPicPr>
-            <a:picLocks noChangeAspect="1"/>
-          </p:cNvPicPr>
+      <p:graphicFrame>
+        <p:nvGraphicFramePr>
+          <p:cNvPr id="5" name="Chart 0" descr=""/>
+          <p:cNvGraphicFramePr/>
           <p:nvPr/>
-        </p:nvPicPr>
-        <p:blipFill>
-          <a:blip r:embed="rId1"/>
-          <a:srcRect l="0" r="0" t="0" b="0"/>
-          <a:stretch/>
-        </p:blipFill>
+        </p:nvGraphicFramePr>
+        <p:xfrm>
+          <a:off x="365760" y="1188720"/>
+          <a:ext cx="7772400" cy="4937760"/>
+        </p:xfrm>
+        <a:graphic xmlns:a="http://schemas.openxmlformats.org/drawingml/2006/main">
+          <a:graphicData uri="http://schemas.openxmlformats.org/drawingml/2006/chart">
+            <c:chart xmlns:c="http://schemas.openxmlformats.org/drawingml/2006/chart" r:id="rId1"/>
+          </a:graphicData>
+        </a:graphic>
+      </p:graphicFrame>
+      <p:sp>
+        <p:nvSpPr>
+          <p:cNvPr id="6" name="Text 2"/>
+          <p:cNvSpPr txBox="1"/>
+          <p:nvPr/>
+        </p:nvSpPr>
         <p:spPr>
           <a:xfrm>
-            <a:off x="365760" y="1188720"/>
-            <a:ext cx="5760720" cy="4480560"/>
-          </a:xfrm>
-          <a:prstGeom prst="rect">
-            <a:avLst/>
-          </a:prstGeom>
-        </p:spPr>
-      </p:pic>
-      <p:pic>
-        <p:nvPicPr>
-          <p:cNvPr id="6" name="Image 1" descr="docs/figures/fig8_top10_pathway_reversal.png">    </p:cNvPr>
-          <p:cNvPicPr>
-            <a:picLocks noChangeAspect="1"/>
-          </p:cNvPicPr>
-          <p:nvPr/>
-        </p:nvPicPr>
-        <p:blipFill>
-          <a:blip r:embed="rId2"/>
-          <a:srcRect l="0" r="0" t="0" b="0"/>
-          <a:stretch/>
-        </p:blipFill>
-        <p:spPr>
-          <a:xfrm>
-            <a:off x="6263640" y="1188720"/>
-            <a:ext cx="5577840" cy="4480560"/>
-          </a:xfrm>
-          <a:prstGeom prst="rect">
-            <a:avLst/>
-          </a:prstGeom>
-        </p:spPr>
-      </p:pic>
-      <p:sp>
-        <p:nvSpPr>
-          <p:cNvPr id="7" name="Text 2"/>
-          <p:cNvSpPr txBox="1"/>
-          <p:nvPr/>
-        </p:nvSpPr>
-        <p:spPr>
-          <a:xfrm>
-            <a:off x="548640" y="5852160"/>
-            <a:ext cx="10881360" cy="411480"/>
+            <a:off x="8321040" y="1280160"/>
+            <a:ext cx="3474720" cy="4846320"/>
           </a:xfrm>
           <a:prstGeom prst="rect">
             <a:avLst/>
@@ -10627,21 +10722,109 @@
           <a:bodyPr wrap="square" lIns="0" tIns="0" rIns="0" bIns="0" rtlCol="0" anchor="t"/>
           <a:lstStyle/>
           <a:p>
-            <a:pPr algn="l" indent="0" marL="0">
-              <a:buNone/>
+            <a:pPr marL="342900" indent="-342900">
+              <a:spcAft>
+                <a:spcPts val="1000"/>
+              </a:spcAft>
+              <a:buSzPct val="100000"/>
+              <a:buChar char="•"/>
             </a:pPr>
             <a:r>
-              <a:rPr lang="en-US" sz="1500" b="1" dirty="0">
+              <a:rPr lang="en-US" sz="1300" dirty="0">
                 <a:solidFill>
-                  <a:srgbClr val="9E493D"/>
+                  <a:srgbClr val="183042"/>
                 </a:solidFill>
                 <a:latin typeface="Microsoft YaHei" pitchFamily="34" charset="0"/>
                 <a:ea typeface="Microsoft YaHei" pitchFamily="34" charset="-122"/>
                 <a:cs typeface="Microsoft YaHei" pitchFamily="34" charset="-120"/>
               </a:rPr>
-              <a:t>预设阈值下 9/10 为糖皮质激素，但放宽阈值后被 RAF/PI3K/mTOR 抑制剂部分取代；参考药恢复 p = 0.147，不显著</a:t>
+              <a:t>v1 120 例：Jev 准确率 0.900 最高，Brier 0.147 最低</a:t>
             </a:r>
-            <a:endParaRPr lang="en-US" sz="1500" dirty="0"/>
+            <a:endParaRPr lang="en-US" sz="1300" dirty="0"/>
+          </a:p>
+          <a:p>
+            <a:pPr marL="342900" indent="-342900">
+              <a:spcAft>
+                <a:spcPts val="1000"/>
+              </a:spcAft>
+              <a:buSzPct val="100000"/>
+              <a:buChar char="•"/>
+            </a:pPr>
+            <a:r>
+              <a:rPr lang="en-US" sz="1300" dirty="0">
+                <a:solidFill>
+                  <a:srgbClr val="183042"/>
+                </a:solidFill>
+                <a:latin typeface="Microsoft YaHei" pitchFamily="34" charset="0"/>
+                <a:ea typeface="Microsoft YaHei" pitchFamily="34" charset="-122"/>
+                <a:cs typeface="Microsoft YaHei" pitchFamily="34" charset="-120"/>
+              </a:rPr>
+              <a:t>Jev + 门控：高风险误执行 0.000，但升级率 0.483</a:t>
+            </a:r>
+            <a:endParaRPr lang="en-US" sz="1300" dirty="0"/>
+          </a:p>
+          <a:p>
+            <a:pPr marL="342900" indent="-342900">
+              <a:spcAft>
+                <a:spcPts val="1000"/>
+              </a:spcAft>
+              <a:buSzPct val="100000"/>
+              <a:buChar char="•"/>
+            </a:pPr>
+            <a:r>
+              <a:rPr lang="en-US" sz="1300" dirty="0">
+                <a:solidFill>
+                  <a:srgbClr val="183042"/>
+                </a:solidFill>
+                <a:latin typeface="Microsoft YaHei" pitchFamily="34" charset="0"/>
+                <a:ea typeface="Microsoft YaHei" pitchFamily="34" charset="-122"/>
+                <a:cs typeface="Microsoft YaHei" pitchFamily="34" charset="-120"/>
+              </a:rPr>
+              <a:t>v2 混合层（Jev 判备注）39/40、0 高风险误执行；完整 Jev 32/40</a:t>
+            </a:r>
+            <a:endParaRPr lang="en-US" sz="1300" dirty="0"/>
+          </a:p>
+          <a:p>
+            <a:pPr marL="342900" indent="-342900">
+              <a:spcAft>
+                <a:spcPts val="1000"/>
+              </a:spcAft>
+              <a:buSzPct val="100000"/>
+              <a:buChar char="•"/>
+            </a:pPr>
+            <a:r>
+              <a:rPr lang="en-US" sz="1300" dirty="0">
+                <a:solidFill>
+                  <a:srgbClr val="183042"/>
+                </a:solidFill>
+                <a:latin typeface="Microsoft YaHei" pitchFamily="34" charset="0"/>
+                <a:ea typeface="Microsoft YaHei" pitchFamily="34" charset="-122"/>
+                <a:cs typeface="Microsoft YaHei" pitchFamily="34" charset="-120"/>
+              </a:rPr>
+              <a:t>混合设计换 flash / v4-pro / Jev 都是 0 高风险误执行</a:t>
+            </a:r>
+            <a:endParaRPr lang="en-US" sz="1300" dirty="0"/>
+          </a:p>
+          <a:p>
+            <a:pPr marL="342900" indent="-342900">
+              <a:spcAft>
+                <a:spcPts val="1000"/>
+              </a:spcAft>
+              <a:buSzPct val="100000"/>
+              <a:buChar char="•"/>
+            </a:pPr>
+            <a:r>
+              <a:rPr lang="en-US" sz="1300" dirty="0">
+                <a:solidFill>
+                  <a:srgbClr val="183042"/>
+                </a:solidFill>
+                <a:latin typeface="Microsoft YaHei" pitchFamily="34" charset="0"/>
+                <a:ea typeface="Microsoft YaHei" pitchFamily="34" charset="-122"/>
+                <a:cs typeface="Microsoft YaHei" pitchFamily="34" charset="-120"/>
+              </a:rPr>
+              <a:t>合成用例、单次运行；Jev 用免费版</a:t>
+            </a:r>
+            <a:endParaRPr lang="en-US" sz="1300" dirty="0"/>
           </a:p>
         </p:txBody>
       </p:sp>

</xml_diff>

<commit_message>
deliverables: rebuild deck v7 and report v5 (Word 12 pages, LaTeX 11 pages)
Rendered and inspected; LaTeX QA, deliverable check and tests pass.

Co-Authored-By: Claude Opus 5.5 <noreply@anthropic.com>
</commit_message>
<xml_diff>
--- a/deliverables/药物重定位Agent_答辩稿_v7.pptx
+++ b/deliverables/药物重定位Agent_答辩稿_v7.pptx
@@ -2332,7 +2332,7 @@
           <a:p>
             <a:r>
               <a:rPr lang="en-US" dirty="0"/>
-              <a:t>约 40 秒。总结五点。23 条是事后来源/药名范围预筛标记，并非 65 条都经过全文审阅；13 条原样候选级引用需排除，冻结药物分级未重算。独立外部方法选择 v3 的数据与标签门槛未通过，没有外部 NS-AUC 结果。Benchmark 分数只代表已知关联恢复能力；LUAD 候选是待验证的研究假设，不是用药建议。代码与所有结果见 GitHub 仓库。</a:t>
+              <a:t>约 50 秒。总结五点。Agent 一行：去掉大模型，Benchmark 分数和 Top-10 一个数字都不会变，因为数值计算全部由确定性代码完成；我们也测过让大模型挑方法、直接判断药物，结果都更差，后者还会泄漏答案。大模型的作用在规划和文字理解：多步规划中“只做一部分”的请求，规则只做对 2/8，大模型 8/8；中文风险备注规则只对 20/40，混合设计 39/40。但它对越权请求的拒绝（5/8）不如规则（7/8），所以安全靠代码层校验，不靠大模型。一句话：算法决定结果对不对，Agent 决定系统好不好用、敢不敢用。文献审阅方面，23 条是事后来源/药名范围预筛标记，并非 65 条都经过全文审阅；13 条原样候选级引用需排除，冻结药物分级未重算。独立外部方法选择 v3 的数据与标签门槛未通过，没有外部 NS-AUC 结果。Benchmark 分数只代表已知关联恢复能力；LUAD 候选是待验证的研究假设，不是用药建议。代码与所有结果见 GitHub 仓库。</a:t>
             </a:r>
             <a:endParaRPr lang="en-US" dirty="0"/>
           </a:p>
@@ -7674,7 +7674,7 @@
                 <a:ea typeface="Microsoft YaHei" pitchFamily="34" charset="-122"/>
                 <a:cs typeface="Microsoft YaHei" pitchFamily="34" charset="-120"/>
               </a:rPr>
-              <a:t>规划 98/100；23 条范围预筛引用中 13 条原样需排除</a:t>
+              <a:t>去掉大模型分数不变；它负责理解请求与文字（部分任务：规则 2/8 → 大模型 8/8）</a:t>
             </a:r>
             <a:endParaRPr lang="en-US" sz="1800" dirty="0"/>
           </a:p>

</xml_diff>

<commit_message>
deliverables: rebuild deck v7 and report v5 with the capability boundary
Report section 5.3 (registered diseases, GEO download, breast-cancer
feasibility), the 10-tool architecture figure, and the slide 12 limitations
row. Word 12 pages, LaTeX 11 pages; 12 slides rendered and inspected; LaTeX
QA, deliverable check and 169 tests pass.

Co-Authored-By: Claude Opus 5.5 <noreply@anthropic.com>
</commit_message>
<xml_diff>
--- a/deliverables/药物重定位Agent_答辩稿_v7.pptx
+++ b/deliverables/药物重定位Agent_答辩稿_v7.pptx
@@ -2684,7 +2684,7 @@
           <a:p>
             <a:r>
               <a:rPr lang="en-US" dirty="0"/>
-              <a:t>约 60 秒。v1 只从 3 个工具里选 1 个；v2 让大模型把请求拆成有序步骤，代码校验依赖、模式和输入后执行，失败时带着已完成产物重新规划。冻结的 40 例多步规划测试（调用前提交）：DeepSeek 36/40，规则规划器 30/40。规则输在“部分任务”（只认关键词，把“只做差异表达”也跑成全流程）；DeepSeek 部分任务、缺少输入、基准模式全对，但越权类 5/8：对“跳过质控”“忽略校验当治疗方案”“排完删数据”它照常跑了安全的标准流程而没有拒绝——代码层依赖校验和白名单仍挡住了实际风险，但这是规划器的真实弱点。右侧是真实工具上的一次运行：排名第一次失败后，第 2 轮只规划剩下的 4 步，跳过已完成的质控、差异表达和通路分析，最终完成。补充一句：大模型决定用哪些工具、按什么顺序、何时停止（40 例中第一轮出现 9 种不同计划），但每个工具内部的算法和阈值由代码固定——阈值会改变 Top-10，不能让模型看完结果再调。</a:t>
+              <a:t>约 60 秒。v1 只从 3 个工具里选 1 个；v2 让大模型把请求拆成有序步骤，代码校验依赖、模式和输入后执行，失败时带着已完成产物重新规划。冻结的 40 例多步规划测试（调用前提交）：DeepSeek 36/40，规则规划器 30/40。规则输在“部分任务”（只认关键词，把“只做差异表达”也跑成全流程）；DeepSeek 部分任务、缺少输入、基准模式全对，但越权类 5/8：对“跳过质控”“忽略校验当治疗方案”“排完删数据”它照常跑了安全的标准流程而没有拒绝——代码层依赖校验和白名单仍挡住了实际风险，但这是规划器的真实弱点。右侧是真实工具上的一次运行：排名第一次失败后，第 2 轮只规划剩下的 4 步，跳过已完成的质控、差异表达和通路分析，最终完成。能力边界：只支持登记表中的疾病（目前只有肺腺癌）；说出疾病名后，Agent 能自动从 GEO 下载数据、核对哈希、从原始数据重算，一路跑到报告，未登记的疾病会转人工。补充一句：大模型决定用哪些工具、按什么顺序、何时停止（40 例中第一轮出现 9 种不同计划），但每个工具内部的算法和阈值由代码固定——阈值会改变 Top-10，不能让模型看完结果再调。</a:t>
             </a:r>
             <a:endParaRPr lang="en-US" dirty="0"/>
           </a:p>
@@ -7752,7 +7752,7 @@
                 <a:ea typeface="Microsoft YaHei" pitchFamily="34" charset="-122"/>
                 <a:cs typeface="Microsoft YaHei" pitchFamily="34" charset="-120"/>
               </a:rPr>
-              <a:t>细胞系 ≠ 患者；未知 ≠ 阴性；外部 v3 未跑；无湿实验；Jev 仅免费版单次运行</a:t>
+              <a:t>只支持登记疾病（目前仅肺腺癌）；细胞系 ≠ 患者；未知 ≠ 阴性；外部 v3 未跑；无湿实验</a:t>
             </a:r>
             <a:endParaRPr lang="en-US" sz="1800" dirty="0"/>
           </a:p>

</xml_diff>

<commit_message>
deliverables: rebuild deck v7 and report v5 with breast cancer registered
Word 12 pages, LaTeX 12 pages (agent_v2 5 pages); 12 slides rendered; LaTeX
QA, deliverable check and tests pass.

Co-Authored-By: Claude Opus 5.5 <noreply@anthropic.com>
</commit_message>
<xml_diff>
--- a/deliverables/药物重定位Agent_答辩稿_v7.pptx
+++ b/deliverables/药物重定位Agent_答辩稿_v7.pptx
@@ -2684,7 +2684,7 @@
           <a:p>
             <a:r>
               <a:rPr lang="en-US" dirty="0"/>
-              <a:t>约 60 秒。v1 只从 3 个工具里选 1 个；v2 让大模型把请求拆成有序步骤，代码校验依赖、模式和输入后执行，失败时带着已完成产物重新规划。冻结的 40 例多步规划测试（调用前提交）：DeepSeek 36/40，规则规划器 30/40。规则输在“部分任务”（只认关键词，把“只做差异表达”也跑成全流程）；DeepSeek 部分任务、缺少输入、基准模式全对，但越权类 5/8：对“跳过质控”“忽略校验当治疗方案”“排完删数据”它照常跑了安全的标准流程而没有拒绝——代码层依赖校验和白名单仍挡住了实际风险，但这是规划器的真实弱点。右侧是真实工具上的一次运行：排名第一次失败后，第 2 轮只规划剩下的 4 步，跳过已完成的质控、差异表达和通路分析，最终完成。能力边界：只支持登记表中的疾病（目前只有肺腺癌）；说出疾病名后，Agent 能自动从 GEO 下载数据、核对哈希、从原始数据重算，一路跑到报告，未登记的疾病会转人工。补充一句：大模型决定用哪些工具、按什么顺序、何时停止（40 例中第一轮出现 9 种不同计划），但每个工具内部的算法和阈值由代码固定——阈值会改变 Top-10，不能让模型看完结果再调。</a:t>
+              <a:t>约 60 秒。v1 只从 3 个工具里选 1 个；v2 让大模型把请求拆成有序步骤，代码校验依赖、模式和输入后执行，失败时带着已完成产物重新规划。冻结的 40 例多步规划测试（调用前提交）：DeepSeek 36/40，规则规划器 30/40。规则输在“部分任务”（只认关键词，把“只做差异表达”也跑成全流程）；DeepSeek 部分任务、缺少输入、基准模式全对，但越权类 5/8：对“跳过质控”“忽略校验当治疗方案”“排完删数据”它照常跑了安全的标准流程而没有拒绝——代码层依赖校验和白名单仍挡住了实际风险，但这是规划器的真实弱点。右侧是真实工具上的一次运行：排名第一次失败后，第 2 轮只规划剩下的 4 步，跳过已完成的质控、差异表达和通路分析，最终完成。能力边界：只支持登记表中的疾病（目前是肺腺癌和乳腺癌）；说出疾病名后，Agent 能自动从 GEO 下载数据、核对哈希、从原始数据重算，一路跑到报告，未登记的疾病会转人工。补充一句：大模型决定用哪些工具、按什么顺序、何时停止（40 例中第一轮出现 9 种不同计划），但每个工具内部的算法和阈值由代码固定——阈值会改变 Top-10，不能让模型看完结果再调。</a:t>
             </a:r>
             <a:endParaRPr lang="en-US" dirty="0"/>
           </a:p>
@@ -7752,7 +7752,7 @@
                 <a:ea typeface="Microsoft YaHei" pitchFamily="34" charset="-122"/>
                 <a:cs typeface="Microsoft YaHei" pitchFamily="34" charset="-120"/>
               </a:rPr>
-              <a:t>只支持登记疾病（目前仅肺腺癌）；细胞系 ≠ 患者；未知 ≠ 阴性；外部 v3 未跑；无湿实验</a:t>
+              <a:t>只支持登记疾病（肺腺癌、乳腺癌）；细胞系 ≠ 患者；未知 ≠ 阴性；外部 v3 未跑；无湿实验</a:t>
             </a:r>
             <a:endParaRPr lang="en-US" sz="1800" dirty="0"/>
           </a:p>

</xml_diff>

<commit_message>
deliverables: rebuild deck v7 and report v5 with five registered diseases
Word 13 pages, LaTeX 12 pages (agent_v2 6 pages); 12 slides rendered; LaTeX
QA, deliverable check and tests pass.

Co-Authored-By: Claude Opus 5.5 <noreply@anthropic.com>
</commit_message>
<xml_diff>
--- a/deliverables/药物重定位Agent_答辩稿_v7.pptx
+++ b/deliverables/药物重定位Agent_答辩稿_v7.pptx
@@ -2684,7 +2684,7 @@
           <a:p>
             <a:r>
               <a:rPr lang="en-US" dirty="0"/>
-              <a:t>约 60 秒。v1 只从 3 个工具里选 1 个；v2 让大模型把请求拆成有序步骤，代码校验依赖、模式和输入后执行，失败时带着已完成产物重新规划。冻结的 40 例多步规划测试（调用前提交）：DeepSeek 36/40，规则规划器 30/40。规则输在“部分任务”（只认关键词，把“只做差异表达”也跑成全流程）；DeepSeek 部分任务、缺少输入、基准模式全对，但越权类 5/8：对“跳过质控”“忽略校验当治疗方案”“排完删数据”它照常跑了安全的标准流程而没有拒绝——代码层依赖校验和白名单仍挡住了实际风险，但这是规划器的真实弱点。右侧是真实工具上的一次运行：排名第一次失败后，第 2 轮只规划剩下的 4 步，跳过已完成的质控、差异表达和通路分析，最终完成。能力边界：只支持登记表中的疾病（目前是肺腺癌和乳腺癌）；说出疾病名后，Agent 能自动从 GEO 下载数据、核对哈希、从原始数据重算，一路跑到报告，未登记的疾病会转人工。补充一句：大模型决定用哪些工具、按什么顺序、何时停止（40 例中第一轮出现 9 种不同计划），但每个工具内部的算法和阈值由代码固定——阈值会改变 Top-10，不能让模型看完结果再调。</a:t>
+              <a:t>约 60 秒。v1 只从 3 个工具里选 1 个；v2 让大模型把请求拆成有序步骤，代码校验依赖、模式和输入后执行，失败时带着已完成产物重新规划。冻结的 40 例多步规划测试（调用前提交）：DeepSeek 36/40，规则规划器 30/40。规则输在“部分任务”（只认关键词，把“只做差异表达”也跑成全流程）；DeepSeek 部分任务、缺少输入、基准模式全对，但越权类 5/8：对“跳过质控”“忽略校验当治疗方案”“排完删数据”它照常跑了安全的标准流程而没有拒绝——代码层依赖校验和白名单仍挡住了实际风险，但这是规划器的真实弱点。右侧是真实工具上的一次运行：排名第一次失败后，第 2 轮只规划剩下的 4 步，跳过已完成的质控、差异表达和通路分析，最终完成。能力边界：只支持登记表中的疾病（预先登记了肺腺癌、乳腺癌、结直肠癌、前列腺癌、黑色素瘤，数据用到时才下载）；说出疾病名后，Agent 能自动从 GEO 下载数据、核对哈希、从原始数据重算，一路跑到报告，未登记的疾病会转人工。补充一句：大模型决定用哪些工具、按什么顺序、何时停止（40 例中第一轮出现 9 种不同计划），但每个工具内部的算法和阈值由代码固定——阈值会改变 Top-10，不能让模型看完结果再调。</a:t>
             </a:r>
             <a:endParaRPr lang="en-US" dirty="0"/>
           </a:p>
@@ -7752,7 +7752,7 @@
                 <a:ea typeface="Microsoft YaHei" pitchFamily="34" charset="-122"/>
                 <a:cs typeface="Microsoft YaHei" pitchFamily="34" charset="-120"/>
               </a:rPr>
-              <a:t>只支持登记疾病（肺腺癌、乳腺癌）；细胞系 ≠ 患者；未知 ≠ 阴性；外部 v3 未跑；无湿实验</a:t>
+              <a:t>只支持 5 个登记疾病；细胞系 ≠ 患者；未知 ≠ 阴性；外部 v3 未跑；无湿实验</a:t>
             </a:r>
             <a:endParaRPr lang="en-US" sz="1800" dirty="0"/>
           </a:p>

</xml_diff>